<commit_message>
Refresh research deliverables with public links
</commit_message>
<xml_diff>
--- a/outputs/loneliness_risk_research_deck.pptx
+++ b/outputs/loneliness_risk_research_deck.pptx
@@ -2,21 +2,22 @@
 <file path=ppt/presentation.xml><?xml version="1.0" encoding="utf-8"?>
 <p:presentation xmlns:p="http://schemas.openxmlformats.org/presentationml/2006/main">
   <p:sldMasterIdLst>
-    <p:sldMasterId xmlns:r="http://schemas.openxmlformats.org/officeDocument/2006/relationships" id="2147483648" r:id="R4b6c6f3a609e47ec"/>
+    <p:sldMasterId xmlns:r="http://schemas.openxmlformats.org/officeDocument/2006/relationships" id="2147483648" r:id="Rb8fb1cb49c7243a2"/>
   </p:sldMasterIdLst>
   <p:notesMasterIdLst>
-    <p:notesMasterId xmlns:r="http://schemas.openxmlformats.org/officeDocument/2006/relationships" r:id="R606804510f5848c5"/>
+    <p:notesMasterId xmlns:r="http://schemas.openxmlformats.org/officeDocument/2006/relationships" r:id="R92338f001092419a"/>
   </p:notesMasterIdLst>
   <p:sldIdLst>
-    <p:sldId xmlns:r="http://schemas.openxmlformats.org/officeDocument/2006/relationships" id="256" r:id="R9fed1abdd1ea4080"/>
-    <p:sldId xmlns:r="http://schemas.openxmlformats.org/officeDocument/2006/relationships" id="257" r:id="R39151d8f3f364a9c"/>
-    <p:sldId xmlns:r="http://schemas.openxmlformats.org/officeDocument/2006/relationships" id="258" r:id="R294a99dc92c14755"/>
-    <p:sldId xmlns:r="http://schemas.openxmlformats.org/officeDocument/2006/relationships" id="259" r:id="R1da6bc691b10463e"/>
-    <p:sldId xmlns:r="http://schemas.openxmlformats.org/officeDocument/2006/relationships" id="260" r:id="R55e26d5c0e084a95"/>
-    <p:sldId xmlns:r="http://schemas.openxmlformats.org/officeDocument/2006/relationships" id="261" r:id="Rd5d067c62b42470b"/>
-    <p:sldId xmlns:r="http://schemas.openxmlformats.org/officeDocument/2006/relationships" id="262" r:id="Racce0c8e2e714728"/>
-    <p:sldId xmlns:r="http://schemas.openxmlformats.org/officeDocument/2006/relationships" id="263" r:id="Rc551d18fa2dc47d4"/>
-    <p:sldId xmlns:r="http://schemas.openxmlformats.org/officeDocument/2006/relationships" id="264" r:id="R305cbe0b7a354b33"/>
+    <p:sldId xmlns:r="http://schemas.openxmlformats.org/officeDocument/2006/relationships" id="256" r:id="R24cff93964734cd1"/>
+    <p:sldId xmlns:r="http://schemas.openxmlformats.org/officeDocument/2006/relationships" id="257" r:id="Reff9a1b281fe4566"/>
+    <p:sldId xmlns:r="http://schemas.openxmlformats.org/officeDocument/2006/relationships" id="258" r:id="Rc3744fbd8264449b"/>
+    <p:sldId xmlns:r="http://schemas.openxmlformats.org/officeDocument/2006/relationships" id="259" r:id="R8764ca7cda534778"/>
+    <p:sldId xmlns:r="http://schemas.openxmlformats.org/officeDocument/2006/relationships" id="260" r:id="R0a68345ebe234bb0"/>
+    <p:sldId xmlns:r="http://schemas.openxmlformats.org/officeDocument/2006/relationships" id="261" r:id="Red18a4f235bc4c7e"/>
+    <p:sldId xmlns:r="http://schemas.openxmlformats.org/officeDocument/2006/relationships" id="262" r:id="R414322294e224358"/>
+    <p:sldId xmlns:r="http://schemas.openxmlformats.org/officeDocument/2006/relationships" id="263" r:id="Re6b349f134e147ef"/>
+    <p:sldId xmlns:r="http://schemas.openxmlformats.org/officeDocument/2006/relationships" id="264" r:id="Rea513101998a4fc1"/>
+    <p:sldId xmlns:r="http://schemas.openxmlformats.org/officeDocument/2006/relationships" id="265" r:id="R615e99a46b634a41"/>
   </p:sldIdLst>
   <p:sldSz cx="12192000" cy="6858000"/>
   <p:notesSz cx="6858000" cy="9144000"/>
@@ -571,6 +572,72 @@
 </p:notes>
 </file>
 
+<file path=ppt/notesSlides/notesSlide10.xml><?xml version="1.0" encoding="utf-8"?>
+<p:notes xmlns:p="http://schemas.openxmlformats.org/presentationml/2006/main">
+  <p:cSld>
+    <p:spTree>
+      <p:nvGrpSpPr>
+        <p:cNvPr id="1" name=""/>
+        <p:cNvGrpSpPr/>
+        <p:nvPr/>
+      </p:nvGrpSpPr>
+      <p:grpSpPr>
+        <a:xfrm xmlns:a="http://schemas.openxmlformats.org/drawingml/2006/main"/>
+      </p:grpSpPr>
+      <p:sp>
+        <p:nvSpPr>
+          <p:cNvPr id="2" name="Slide Image Placeholder 1"/>
+          <p:cNvSpPr>
+            <a:spLocks xmlns:a="http://schemas.openxmlformats.org/drawingml/2006/main" noGrp="1"/>
+          </p:cNvSpPr>
+          <p:nvPr>
+            <p:ph type="sldImg" idx="0"/>
+          </p:nvPr>
+        </p:nvSpPr>
+        <p:spPr/>
+      </p:sp>
+      <p:sp>
+        <p:nvSpPr>
+          <p:cNvPr id="3" name="Notes Placeholder 2"/>
+          <p:cNvSpPr>
+            <a:spLocks xmlns:a="http://schemas.openxmlformats.org/drawingml/2006/main" noGrp="1"/>
+          </p:cNvSpPr>
+          <p:nvPr>
+            <p:ph type="body" idx="1"/>
+          </p:nvPr>
+        </p:nvSpPr>
+        <p:spPr/>
+        <p:txBody>
+          <a:bodyPr xmlns:a="http://schemas.openxmlformats.org/drawingml/2006/main"/>
+          <a:lstStyle xmlns:a="http://schemas.openxmlformats.org/drawingml/2006/main"/>
+          <a:p xmlns:a="http://schemas.openxmlformats.org/drawingml/2006/main"/>
+        </p:txBody>
+      </p:sp>
+      <p:sp>
+        <p:nvSpPr>
+          <p:cNvPr id="4" name="Slide Number Placeholder 3"/>
+          <p:cNvSpPr>
+            <a:spLocks xmlns:a="http://schemas.openxmlformats.org/drawingml/2006/main" noGrp="1"/>
+          </p:cNvSpPr>
+          <p:nvPr>
+            <p:ph type="sldNum" idx="5"/>
+          </p:nvPr>
+        </p:nvSpPr>
+        <p:spPr/>
+        <p:txBody>
+          <a:bodyPr xmlns:a="http://schemas.openxmlformats.org/drawingml/2006/main"/>
+          <a:lstStyle xmlns:a="http://schemas.openxmlformats.org/drawingml/2006/main"/>
+          <a:p xmlns:a="http://schemas.openxmlformats.org/drawingml/2006/main"/>
+        </p:txBody>
+      </p:sp>
+    </p:spTree>
+  </p:cSld>
+  <p:clrMapOvr>
+    <a:masterClrMapping xmlns:a="http://schemas.openxmlformats.org/drawingml/2006/main"/>
+  </p:clrMapOvr>
+</p:notes>
+</file>
+
 <file path=ppt/notesSlides/notesSlide2.xml><?xml version="1.0" encoding="utf-8"?>
 <p:notes xmlns:p="http://schemas.openxmlformats.org/presentationml/2006/main">
   <p:cSld>
@@ -1137,7 +1204,7 @@
   </p:cSld>
   <p:clrMap bg1="lt1" tx1="dk1" bg2="lt2" tx2="dk2" accent1="accent1" accent2="accent2" accent3="accent3" accent4="accent4" accent5="accent5" accent6="accent6" hlink="hlink" folHlink="folHlink"/>
   <p:sldLayoutIdLst>
-    <p:sldLayoutId xmlns:r="http://schemas.openxmlformats.org/officeDocument/2006/relationships" id="2147483649" r:id="R119dd38300a0406b"/>
+    <p:sldLayoutId xmlns:r="http://schemas.openxmlformats.org/officeDocument/2006/relationships" id="2147483649" r:id="R9175d7c9fa294724"/>
   </p:sldLayoutIdLst>
   <p:txStyles>
     <p:titleStyle>
@@ -2002,7 +2069,7 @@
           <p:cNvPr id="1" name="">
             <a:extLst xmlns:a="http://schemas.openxmlformats.org/drawingml/2006/main">
               <a:ext uri="{FF2B5EF4-FFF2-40B4-BE49-F238E27FC236}">
-                <a16:creationId xmlns:a16="http://schemas.microsoft.com/office/drawing/2014/main" id="{F8AA8C9E-9E33-4CCF-8B29-79A837AF6094}"/>
+                <a16:creationId xmlns:a16="http://schemas.microsoft.com/office/drawing/2014/main" id="{220B8DD6-D170-44A8-90A9-9B4802830AA3}"/>
               </a:ext>
             </a:extLst>
           </p:cNvPr>
@@ -2052,7 +2119,7 @@
           <p:cNvPr id="2" name="">
             <a:extLst xmlns:a="http://schemas.openxmlformats.org/drawingml/2006/main">
               <a:ext uri="{FF2B5EF4-FFF2-40B4-BE49-F238E27FC236}">
-                <a16:creationId xmlns:a16="http://schemas.microsoft.com/office/drawing/2014/main" id="{F2F73A64-BEA1-4411-AD09-0E01BCB8E7D3}"/>
+                <a16:creationId xmlns:a16="http://schemas.microsoft.com/office/drawing/2014/main" id="{344496FB-82E8-4CE2-BE41-07434E69D577}"/>
               </a:ext>
             </a:extLst>
           </p:cNvPr>
@@ -2102,7 +2169,7 @@
           <p:cNvPr id="3" name="">
             <a:extLst xmlns:a="http://schemas.openxmlformats.org/drawingml/2006/main">
               <a:ext uri="{FF2B5EF4-FFF2-40B4-BE49-F238E27FC236}">
-                <a16:creationId xmlns:a16="http://schemas.microsoft.com/office/drawing/2014/main" id="{97B05FFC-6D3E-40D8-9D5A-010210AEAA09}"/>
+                <a16:creationId xmlns:a16="http://schemas.microsoft.com/office/drawing/2014/main" id="{2FDF4714-D767-4729-AFC9-670BA289CACA}"/>
               </a:ext>
             </a:extLst>
           </p:cNvPr>
@@ -2152,7 +2219,7 @@
           <p:cNvPr id="4" name="">
             <a:extLst xmlns:a="http://schemas.openxmlformats.org/drawingml/2006/main">
               <a:ext uri="{FF2B5EF4-FFF2-40B4-BE49-F238E27FC236}">
-                <a16:creationId xmlns:a16="http://schemas.microsoft.com/office/drawing/2014/main" id="{865D8D05-8E9C-458D-9746-289FC04CF878}"/>
+                <a16:creationId xmlns:a16="http://schemas.microsoft.com/office/drawing/2014/main" id="{31C07F7F-1158-4041-9138-E7CE281C2AD6}"/>
               </a:ext>
             </a:extLst>
           </p:cNvPr>
@@ -2185,7 +2252,7 @@
           <p:cNvPr id="5" name="">
             <a:extLst xmlns:a="http://schemas.openxmlformats.org/drawingml/2006/main">
               <a:ext uri="{FF2B5EF4-FFF2-40B4-BE49-F238E27FC236}">
-                <a16:creationId xmlns:a16="http://schemas.microsoft.com/office/drawing/2014/main" id="{45133E87-815A-4CB7-AA0A-25D11470C6F4}"/>
+                <a16:creationId xmlns:a16="http://schemas.microsoft.com/office/drawing/2014/main" id="{53DA6E3B-DEA0-4EF9-AB01-063D527F088B}"/>
               </a:ext>
             </a:extLst>
           </p:cNvPr>
@@ -2235,7 +2302,7 @@
           <p:cNvPr id="6" name="">
             <a:extLst xmlns:a="http://schemas.openxmlformats.org/drawingml/2006/main">
               <a:ext uri="{FF2B5EF4-FFF2-40B4-BE49-F238E27FC236}">
-                <a16:creationId xmlns:a16="http://schemas.microsoft.com/office/drawing/2014/main" id="{D73E07AA-39FA-4653-91E9-BE29F98E3856}"/>
+                <a16:creationId xmlns:a16="http://schemas.microsoft.com/office/drawing/2014/main" id="{735F75B8-FD0B-4633-ADF1-4089F142EFD0}"/>
               </a:ext>
             </a:extLst>
           </p:cNvPr>
@@ -2285,7 +2352,7 @@
           <p:cNvPr id="7" name="">
             <a:extLst xmlns:a="http://schemas.openxmlformats.org/drawingml/2006/main">
               <a:ext uri="{FF2B5EF4-FFF2-40B4-BE49-F238E27FC236}">
-                <a16:creationId xmlns:a16="http://schemas.microsoft.com/office/drawing/2014/main" id="{EB8A0739-0CA1-4EBC-96B4-E6C0A6C5EC3B}"/>
+                <a16:creationId xmlns:a16="http://schemas.microsoft.com/office/drawing/2014/main" id="{DB5D4AD9-BA6D-417B-B2AE-336B225B7FDF}"/>
               </a:ext>
             </a:extLst>
           </p:cNvPr>
@@ -2335,7 +2402,7 @@
           <p:cNvPr id="8" name="">
             <a:extLst xmlns:a="http://schemas.openxmlformats.org/drawingml/2006/main">
               <a:ext uri="{FF2B5EF4-FFF2-40B4-BE49-F238E27FC236}">
-                <a16:creationId xmlns:a16="http://schemas.microsoft.com/office/drawing/2014/main" id="{E3CED4BA-E184-407D-BB49-49D3A20BAC64}"/>
+                <a16:creationId xmlns:a16="http://schemas.microsoft.com/office/drawing/2014/main" id="{7C156618-218E-4DFB-826F-DE19210CED75}"/>
               </a:ext>
             </a:extLst>
           </p:cNvPr>
@@ -2385,7 +2452,7 @@
           <p:cNvPr id="9" name="">
             <a:extLst xmlns:a="http://schemas.openxmlformats.org/drawingml/2006/main">
               <a:ext uri="{FF2B5EF4-FFF2-40B4-BE49-F238E27FC236}">
-                <a16:creationId xmlns:a16="http://schemas.microsoft.com/office/drawing/2014/main" id="{308DC1E9-28D4-4E6D-ABA4-AD265D1A02E7}"/>
+                <a16:creationId xmlns:a16="http://schemas.microsoft.com/office/drawing/2014/main" id="{40996D2B-0C30-4B3C-8479-DB469ED4CA2D}"/>
               </a:ext>
             </a:extLst>
           </p:cNvPr>
@@ -2435,7 +2502,7 @@
           <p:cNvPr id="10" name="">
             <a:extLst xmlns:a="http://schemas.openxmlformats.org/drawingml/2006/main">
               <a:ext uri="{FF2B5EF4-FFF2-40B4-BE49-F238E27FC236}">
-                <a16:creationId xmlns:a16="http://schemas.microsoft.com/office/drawing/2014/main" id="{DACA9B6E-22A1-45DC-994E-B96C98B161E3}"/>
+                <a16:creationId xmlns:a16="http://schemas.microsoft.com/office/drawing/2014/main" id="{23F1867C-F954-4E8E-A428-9441916698D2}"/>
               </a:ext>
             </a:extLst>
           </p:cNvPr>
@@ -2485,7 +2552,7 @@
           <p:cNvPr id="11" name="">
             <a:extLst xmlns:a="http://schemas.openxmlformats.org/drawingml/2006/main">
               <a:ext uri="{FF2B5EF4-FFF2-40B4-BE49-F238E27FC236}">
-                <a16:creationId xmlns:a16="http://schemas.microsoft.com/office/drawing/2014/main" id="{33BB8C77-3A72-41C1-9E1C-376B16412870}"/>
+                <a16:creationId xmlns:a16="http://schemas.microsoft.com/office/drawing/2014/main" id="{818B625D-389F-4C50-A234-FF6FBCED7F82}"/>
               </a:ext>
             </a:extLst>
           </p:cNvPr>
@@ -2535,7 +2602,7 @@
           <p:cNvPr id="12" name="">
             <a:extLst xmlns:a="http://schemas.openxmlformats.org/drawingml/2006/main">
               <a:ext uri="{FF2B5EF4-FFF2-40B4-BE49-F238E27FC236}">
-                <a16:creationId xmlns:a16="http://schemas.microsoft.com/office/drawing/2014/main" id="{7C0DBCDF-7610-45EE-ABBB-38B533682D9F}"/>
+                <a16:creationId xmlns:a16="http://schemas.microsoft.com/office/drawing/2014/main" id="{85A850D3-1764-4E4F-8968-54E5A2AE8612}"/>
               </a:ext>
             </a:extLst>
           </p:cNvPr>
@@ -2585,7 +2652,7 @@
           <p:cNvPr id="13" name="">
             <a:extLst xmlns:a="http://schemas.openxmlformats.org/drawingml/2006/main">
               <a:ext uri="{FF2B5EF4-FFF2-40B4-BE49-F238E27FC236}">
-                <a16:creationId xmlns:a16="http://schemas.microsoft.com/office/drawing/2014/main" id="{BAE77410-3439-4783-B0D5-D7F610631CAA}"/>
+                <a16:creationId xmlns:a16="http://schemas.microsoft.com/office/drawing/2014/main" id="{22E465A1-B007-4E3D-8522-8BD558226467}"/>
               </a:ext>
             </a:extLst>
           </p:cNvPr>
@@ -2635,7 +2702,7 @@
           <p:cNvPr id="14" name="">
             <a:extLst xmlns:a="http://schemas.openxmlformats.org/drawingml/2006/main">
               <a:ext uri="{FF2B5EF4-FFF2-40B4-BE49-F238E27FC236}">
-                <a16:creationId xmlns:a16="http://schemas.microsoft.com/office/drawing/2014/main" id="{8BF7645C-14DF-4A15-AEC2-54AF6D56E949}"/>
+                <a16:creationId xmlns:a16="http://schemas.microsoft.com/office/drawing/2014/main" id="{35B756DF-6A7A-4C29-B41E-F58C94236B89}"/>
               </a:ext>
             </a:extLst>
           </p:cNvPr>
@@ -2685,7 +2752,7 @@
           <p:cNvPr id="15" name="">
             <a:extLst xmlns:a="http://schemas.openxmlformats.org/drawingml/2006/main">
               <a:ext uri="{FF2B5EF4-FFF2-40B4-BE49-F238E27FC236}">
-                <a16:creationId xmlns:a16="http://schemas.microsoft.com/office/drawing/2014/main" id="{94C001AD-4B79-4A78-B6AE-EE9F781CB4F3}"/>
+                <a16:creationId xmlns:a16="http://schemas.microsoft.com/office/drawing/2014/main" id="{5036E272-14AD-4D0F-8BC5-8D4F59A7A5D9}"/>
               </a:ext>
             </a:extLst>
           </p:cNvPr>
@@ -2735,7 +2802,7 @@
           <p:cNvPr id="16" name="">
             <a:extLst xmlns:a="http://schemas.openxmlformats.org/drawingml/2006/main">
               <a:ext uri="{FF2B5EF4-FFF2-40B4-BE49-F238E27FC236}">
-                <a16:creationId xmlns:a16="http://schemas.microsoft.com/office/drawing/2014/main" id="{489662C2-EEC4-4A62-8987-30E679A27C3C}"/>
+                <a16:creationId xmlns:a16="http://schemas.microsoft.com/office/drawing/2014/main" id="{3F7C1D15-2677-431C-9A67-684AE9A44EC6}"/>
               </a:ext>
             </a:extLst>
           </p:cNvPr>
@@ -2783,7 +2850,968 @@
     </p:spTree>
     <p:extLst>
       <p:ext uri="{BB962C8B-B14F-4D97-AF65-F5344CB8AC3E}">
-        <p14:creationId xmlns:p14="http://schemas.microsoft.com/office/powerpoint/2010/main" val="1149851606"/>
+        <p14:creationId xmlns:p14="http://schemas.microsoft.com/office/powerpoint/2010/main" val="1604797754"/>
+      </p:ext>
+    </p:extLst>
+  </p:cSld>
+</p:sld>
+</file>
+
+<file path=ppt/slides/slide10.xml><?xml version="1.0" encoding="utf-8"?>
+<p:sld xmlns:p="http://schemas.openxmlformats.org/presentationml/2006/main">
+  <p:cSld>
+    <p:bg>
+      <p:bgPr>
+        <a:solidFill xmlns:a="http://schemas.openxmlformats.org/drawingml/2006/main">
+          <a:srgbClr val="F7F5F0"/>
+        </a:solidFill>
+      </p:bgPr>
+    </p:bg>
+    <p:spTree>
+      <p:nvGrpSpPr>
+        <p:cNvPr id="1" name=""/>
+        <p:cNvGrpSpPr/>
+        <p:nvPr/>
+      </p:nvGrpSpPr>
+      <p:grpSpPr>
+        <a:xfrm xmlns:a="http://schemas.openxmlformats.org/drawingml/2006/main"/>
+      </p:grpSpPr>
+      <p:sp>
+        <p:nvSpPr>
+          <p:cNvPr id="1" name="">
+            <a:extLst xmlns:a="http://schemas.openxmlformats.org/drawingml/2006/main">
+              <a:ext uri="{FF2B5EF4-FFF2-40B4-BE49-F238E27FC236}">
+                <a16:creationId xmlns:a16="http://schemas.microsoft.com/office/drawing/2014/main" id="{85C2AFCB-54D4-46A2-9D8A-758762DE97AB}"/>
+              </a:ext>
+            </a:extLst>
+          </p:cNvPr>
+          <p:cNvSpPr>
+            <a:spLocks xmlns:a="http://schemas.openxmlformats.org/drawingml/2006/main" noGrp="1"/>
+          </p:cNvSpPr>
+          <p:nvPr/>
+        </p:nvSpPr>
+        <p:spPr>
+          <a:xfrm xmlns:a="http://schemas.openxmlformats.org/drawingml/2006/main">
+            <a:off x="685800" y="514350"/>
+            <a:ext cx="9239250" cy="723900"/>
+          </a:xfrm>
+          <a:prstGeom xmlns:a="http://schemas.openxmlformats.org/drawingml/2006/main" prst="rect">
+            <a:avLst/>
+          </a:prstGeom>
+          <a:noFill xmlns:a="http://schemas.openxmlformats.org/drawingml/2006/main"/>
+          <a:ln xmlns:a="http://schemas.openxmlformats.org/drawingml/2006/main" w="0">
+            <a:noFill/>
+            <a:prstDash val="solid"/>
+          </a:ln>
+        </p:spPr>
+        <p:txBody>
+          <a:bodyPr xmlns:a="http://schemas.openxmlformats.org/drawingml/2006/main"/>
+          <a:lstStyle xmlns:a="http://schemas.openxmlformats.org/drawingml/2006/main"/>
+          <a:p xmlns:a="http://schemas.openxmlformats.org/drawingml/2006/main">
+            <a:pPr algn="l">
+              <a:defRPr sz="3150" b="1">
+                <a:solidFill>
+                  <a:srgbClr val="1C2430"/>
+                </a:solidFill>
+              </a:defRPr>
+            </a:pPr>
+            <a:r>
+              <a:rPr sz="3150" b="1">
+                <a:solidFill>
+                  <a:srgbClr val="1C2430"/>
+                </a:solidFill>
+              </a:rPr>
+              <a:t>The strongest next step is real sampling, not more decoration.</a:t>
+            </a:r>
+          </a:p>
+        </p:txBody>
+      </p:sp>
+      <p:sp>
+        <p:nvSpPr>
+          <p:cNvPr id="2" name="">
+            <a:extLst xmlns:a="http://schemas.openxmlformats.org/drawingml/2006/main">
+              <a:ext uri="{FF2B5EF4-FFF2-40B4-BE49-F238E27FC236}">
+                <a16:creationId xmlns:a16="http://schemas.microsoft.com/office/drawing/2014/main" id="{A7F2A7DE-9B61-43F6-A5F3-63B5BB511DA1}"/>
+              </a:ext>
+            </a:extLst>
+          </p:cNvPr>
+          <p:cNvSpPr>
+            <a:spLocks xmlns:a="http://schemas.openxmlformats.org/drawingml/2006/main" noGrp="1"/>
+          </p:cNvSpPr>
+          <p:nvPr/>
+        </p:nvSpPr>
+        <p:spPr>
+          <a:xfrm xmlns:a="http://schemas.openxmlformats.org/drawingml/2006/main">
+            <a:off x="857250" y="1695450"/>
+            <a:ext cx="4476750" cy="1257300"/>
+          </a:xfrm>
+          <a:prstGeom xmlns:a="http://schemas.openxmlformats.org/drawingml/2006/main" prst="rect">
+            <a:avLst/>
+          </a:prstGeom>
+          <a:solidFill xmlns:a="http://schemas.openxmlformats.org/drawingml/2006/main">
+            <a:srgbClr val="FFFFFF"/>
+          </a:solidFill>
+          <a:ln xmlns:a="http://schemas.openxmlformats.org/drawingml/2006/main" w="9525">
+            <a:solidFill>
+              <a:srgbClr val="1C2430"/>
+            </a:solidFill>
+            <a:prstDash val="solid"/>
+          </a:ln>
+        </p:spPr>
+      </p:sp>
+      <p:sp>
+        <p:nvSpPr>
+          <p:cNvPr id="3" name="">
+            <a:extLst xmlns:a="http://schemas.openxmlformats.org/drawingml/2006/main">
+              <a:ext uri="{FF2B5EF4-FFF2-40B4-BE49-F238E27FC236}">
+                <a16:creationId xmlns:a16="http://schemas.microsoft.com/office/drawing/2014/main" id="{6D98BD58-B366-4E30-B369-1D79794D6487}"/>
+              </a:ext>
+            </a:extLst>
+          </p:cNvPr>
+          <p:cNvSpPr>
+            <a:spLocks xmlns:a="http://schemas.openxmlformats.org/drawingml/2006/main" noGrp="1"/>
+          </p:cNvSpPr>
+          <p:nvPr/>
+        </p:nvSpPr>
+        <p:spPr>
+          <a:xfrm xmlns:a="http://schemas.openxmlformats.org/drawingml/2006/main">
+            <a:off x="1085850" y="1943100"/>
+            <a:ext cx="552450" cy="495300"/>
+          </a:xfrm>
+          <a:prstGeom xmlns:a="http://schemas.openxmlformats.org/drawingml/2006/main" prst="rect">
+            <a:avLst/>
+          </a:prstGeom>
+          <a:noFill xmlns:a="http://schemas.openxmlformats.org/drawingml/2006/main"/>
+          <a:ln xmlns:a="http://schemas.openxmlformats.org/drawingml/2006/main" w="0">
+            <a:noFill/>
+            <a:prstDash val="solid"/>
+          </a:ln>
+        </p:spPr>
+        <p:txBody>
+          <a:bodyPr xmlns:a="http://schemas.openxmlformats.org/drawingml/2006/main"/>
+          <a:lstStyle xmlns:a="http://schemas.openxmlformats.org/drawingml/2006/main"/>
+          <a:p xmlns:a="http://schemas.openxmlformats.org/drawingml/2006/main">
+            <a:pPr algn="l">
+              <a:defRPr sz="3300" b="1">
+                <a:solidFill>
+                  <a:srgbClr val="2D6A6A"/>
+                </a:solidFill>
+              </a:defRPr>
+            </a:pPr>
+            <a:r>
+              <a:rPr sz="3300" b="1">
+                <a:solidFill>
+                  <a:srgbClr val="2D6A6A"/>
+                </a:solidFill>
+              </a:rPr>
+              <a:t>1</a:t>
+            </a:r>
+          </a:p>
+        </p:txBody>
+      </p:sp>
+      <p:sp>
+        <p:nvSpPr>
+          <p:cNvPr id="4" name="">
+            <a:extLst xmlns:a="http://schemas.openxmlformats.org/drawingml/2006/main">
+              <a:ext uri="{FF2B5EF4-FFF2-40B4-BE49-F238E27FC236}">
+                <a16:creationId xmlns:a16="http://schemas.microsoft.com/office/drawing/2014/main" id="{977333DE-1D8B-4097-98B8-B3FFDECB5D78}"/>
+              </a:ext>
+            </a:extLst>
+          </p:cNvPr>
+          <p:cNvSpPr>
+            <a:spLocks xmlns:a="http://schemas.openxmlformats.org/drawingml/2006/main" noGrp="1"/>
+          </p:cNvSpPr>
+          <p:nvPr/>
+        </p:nvSpPr>
+        <p:spPr>
+          <a:xfrm xmlns:a="http://schemas.openxmlformats.org/drawingml/2006/main">
+            <a:off x="1790700" y="1905000"/>
+            <a:ext cx="3143250" cy="552450"/>
+          </a:xfrm>
+          <a:prstGeom xmlns:a="http://schemas.openxmlformats.org/drawingml/2006/main" prst="rect">
+            <a:avLst/>
+          </a:prstGeom>
+          <a:noFill xmlns:a="http://schemas.openxmlformats.org/drawingml/2006/main"/>
+          <a:ln xmlns:a="http://schemas.openxmlformats.org/drawingml/2006/main" w="0">
+            <a:noFill/>
+            <a:prstDash val="solid"/>
+          </a:ln>
+        </p:spPr>
+        <p:txBody>
+          <a:bodyPr xmlns:a="http://schemas.openxmlformats.org/drawingml/2006/main"/>
+          <a:lstStyle xmlns:a="http://schemas.openxmlformats.org/drawingml/2006/main"/>
+          <a:p xmlns:a="http://schemas.openxmlformats.org/drawingml/2006/main">
+            <a:pPr algn="l">
+              <a:defRPr sz="1725" b="1">
+                <a:solidFill>
+                  <a:srgbClr val="1C2430"/>
+                </a:solidFill>
+              </a:defRPr>
+            </a:pPr>
+            <a:r>
+              <a:rPr sz="1725" b="1">
+                <a:solidFill>
+                  <a:srgbClr val="1C2430"/>
+                </a:solidFill>
+              </a:rPr>
+              <a:t>Pilot review</a:t>
+            </a:r>
+          </a:p>
+        </p:txBody>
+      </p:sp>
+      <p:sp>
+        <p:nvSpPr>
+          <p:cNvPr id="5" name="">
+            <a:extLst xmlns:a="http://schemas.openxmlformats.org/drawingml/2006/main">
+              <a:ext uri="{FF2B5EF4-FFF2-40B4-BE49-F238E27FC236}">
+                <a16:creationId xmlns:a16="http://schemas.microsoft.com/office/drawing/2014/main" id="{CFF8818C-13E6-4FAD-8B9E-6F6F6950207A}"/>
+              </a:ext>
+            </a:extLst>
+          </p:cNvPr>
+          <p:cNvSpPr>
+            <a:spLocks xmlns:a="http://schemas.openxmlformats.org/drawingml/2006/main" noGrp="1"/>
+          </p:cNvSpPr>
+          <p:nvPr/>
+        </p:nvSpPr>
+        <p:spPr>
+          <a:xfrm xmlns:a="http://schemas.openxmlformats.org/drawingml/2006/main">
+            <a:off x="1790700" y="2438400"/>
+            <a:ext cx="3143250" cy="400050"/>
+          </a:xfrm>
+          <a:prstGeom xmlns:a="http://schemas.openxmlformats.org/drawingml/2006/main" prst="rect">
+            <a:avLst/>
+          </a:prstGeom>
+          <a:noFill xmlns:a="http://schemas.openxmlformats.org/drawingml/2006/main"/>
+          <a:ln xmlns:a="http://schemas.openxmlformats.org/drawingml/2006/main" w="0">
+            <a:noFill/>
+            <a:prstDash val="solid"/>
+          </a:ln>
+        </p:spPr>
+        <p:txBody>
+          <a:bodyPr xmlns:a="http://schemas.openxmlformats.org/drawingml/2006/main"/>
+          <a:lstStyle xmlns:a="http://schemas.openxmlformats.org/drawingml/2006/main"/>
+          <a:p xmlns:a="http://schemas.openxmlformats.org/drawingml/2006/main">
+            <a:pPr algn="l">
+              <a:defRPr sz="1200" b="0">
+                <a:solidFill>
+                  <a:srgbClr val="5B6472"/>
+                </a:solidFill>
+              </a:defRPr>
+            </a:pPr>
+            <a:r>
+              <a:rPr sz="1200" b="0">
+                <a:solidFill>
+                  <a:srgbClr val="5B6472"/>
+                </a:solidFill>
+              </a:rPr>
+              <a:t>Have a mentor review item wording, consent, and risk language.</a:t>
+            </a:r>
+          </a:p>
+        </p:txBody>
+      </p:sp>
+      <p:sp>
+        <p:nvSpPr>
+          <p:cNvPr id="6" name="">
+            <a:extLst xmlns:a="http://schemas.openxmlformats.org/drawingml/2006/main">
+              <a:ext uri="{FF2B5EF4-FFF2-40B4-BE49-F238E27FC236}">
+                <a16:creationId xmlns:a16="http://schemas.microsoft.com/office/drawing/2014/main" id="{7EAFD498-67B3-4438-A83C-5F950E0DEA5C}"/>
+              </a:ext>
+            </a:extLst>
+          </p:cNvPr>
+          <p:cNvSpPr>
+            <a:spLocks xmlns:a="http://schemas.openxmlformats.org/drawingml/2006/main" noGrp="1"/>
+          </p:cNvSpPr>
+          <p:nvPr/>
+        </p:nvSpPr>
+        <p:spPr>
+          <a:xfrm xmlns:a="http://schemas.openxmlformats.org/drawingml/2006/main">
+            <a:off x="6000750" y="1695450"/>
+            <a:ext cx="4476750" cy="1257300"/>
+          </a:xfrm>
+          <a:prstGeom xmlns:a="http://schemas.openxmlformats.org/drawingml/2006/main" prst="rect">
+            <a:avLst/>
+          </a:prstGeom>
+          <a:solidFill xmlns:a="http://schemas.openxmlformats.org/drawingml/2006/main">
+            <a:srgbClr val="FFFFFF"/>
+          </a:solidFill>
+          <a:ln xmlns:a="http://schemas.openxmlformats.org/drawingml/2006/main" w="9525">
+            <a:solidFill>
+              <a:srgbClr val="1C2430"/>
+            </a:solidFill>
+            <a:prstDash val="solid"/>
+          </a:ln>
+        </p:spPr>
+      </p:sp>
+      <p:sp>
+        <p:nvSpPr>
+          <p:cNvPr id="7" name="">
+            <a:extLst xmlns:a="http://schemas.openxmlformats.org/drawingml/2006/main">
+              <a:ext uri="{FF2B5EF4-FFF2-40B4-BE49-F238E27FC236}">
+                <a16:creationId xmlns:a16="http://schemas.microsoft.com/office/drawing/2014/main" id="{D248D7F9-750D-41A3-BD98-35B6CE55CB5E}"/>
+              </a:ext>
+            </a:extLst>
+          </p:cNvPr>
+          <p:cNvSpPr>
+            <a:spLocks xmlns:a="http://schemas.openxmlformats.org/drawingml/2006/main" noGrp="1"/>
+          </p:cNvSpPr>
+          <p:nvPr/>
+        </p:nvSpPr>
+        <p:spPr>
+          <a:xfrm xmlns:a="http://schemas.openxmlformats.org/drawingml/2006/main">
+            <a:off x="6229350" y="1943100"/>
+            <a:ext cx="552450" cy="495300"/>
+          </a:xfrm>
+          <a:prstGeom xmlns:a="http://schemas.openxmlformats.org/drawingml/2006/main" prst="rect">
+            <a:avLst/>
+          </a:prstGeom>
+          <a:noFill xmlns:a="http://schemas.openxmlformats.org/drawingml/2006/main"/>
+          <a:ln xmlns:a="http://schemas.openxmlformats.org/drawingml/2006/main" w="0">
+            <a:noFill/>
+            <a:prstDash val="solid"/>
+          </a:ln>
+        </p:spPr>
+        <p:txBody>
+          <a:bodyPr xmlns:a="http://schemas.openxmlformats.org/drawingml/2006/main"/>
+          <a:lstStyle xmlns:a="http://schemas.openxmlformats.org/drawingml/2006/main"/>
+          <a:p xmlns:a="http://schemas.openxmlformats.org/drawingml/2006/main">
+            <a:pPr algn="l">
+              <a:defRPr sz="3300" b="1">
+                <a:solidFill>
+                  <a:srgbClr val="D98E04"/>
+                </a:solidFill>
+              </a:defRPr>
+            </a:pPr>
+            <a:r>
+              <a:rPr sz="3300" b="1">
+                <a:solidFill>
+                  <a:srgbClr val="D98E04"/>
+                </a:solidFill>
+              </a:rPr>
+              <a:t>2</a:t>
+            </a:r>
+          </a:p>
+        </p:txBody>
+      </p:sp>
+      <p:sp>
+        <p:nvSpPr>
+          <p:cNvPr id="8" name="">
+            <a:extLst xmlns:a="http://schemas.openxmlformats.org/drawingml/2006/main">
+              <a:ext uri="{FF2B5EF4-FFF2-40B4-BE49-F238E27FC236}">
+                <a16:creationId xmlns:a16="http://schemas.microsoft.com/office/drawing/2014/main" id="{F8EB5965-A00C-4469-B459-14BAEA198185}"/>
+              </a:ext>
+            </a:extLst>
+          </p:cNvPr>
+          <p:cNvSpPr>
+            <a:spLocks xmlns:a="http://schemas.openxmlformats.org/drawingml/2006/main" noGrp="1"/>
+          </p:cNvSpPr>
+          <p:nvPr/>
+        </p:nvSpPr>
+        <p:spPr>
+          <a:xfrm xmlns:a="http://schemas.openxmlformats.org/drawingml/2006/main">
+            <a:off x="6934200" y="1905000"/>
+            <a:ext cx="3143250" cy="552450"/>
+          </a:xfrm>
+          <a:prstGeom xmlns:a="http://schemas.openxmlformats.org/drawingml/2006/main" prst="rect">
+            <a:avLst/>
+          </a:prstGeom>
+          <a:noFill xmlns:a="http://schemas.openxmlformats.org/drawingml/2006/main"/>
+          <a:ln xmlns:a="http://schemas.openxmlformats.org/drawingml/2006/main" w="0">
+            <a:noFill/>
+            <a:prstDash val="solid"/>
+          </a:ln>
+        </p:spPr>
+        <p:txBody>
+          <a:bodyPr xmlns:a="http://schemas.openxmlformats.org/drawingml/2006/main"/>
+          <a:lstStyle xmlns:a="http://schemas.openxmlformats.org/drawingml/2006/main"/>
+          <a:p xmlns:a="http://schemas.openxmlformats.org/drawingml/2006/main">
+            <a:pPr algn="l">
+              <a:defRPr sz="1725" b="1">
+                <a:solidFill>
+                  <a:srgbClr val="1C2430"/>
+                </a:solidFill>
+              </a:defRPr>
+            </a:pPr>
+            <a:r>
+              <a:rPr sz="1725" b="1">
+                <a:solidFill>
+                  <a:srgbClr val="1C2430"/>
+                </a:solidFill>
+              </a:rPr>
+              <a:t>Collect 80-150 live responses</a:t>
+            </a:r>
+          </a:p>
+        </p:txBody>
+      </p:sp>
+      <p:sp>
+        <p:nvSpPr>
+          <p:cNvPr id="9" name="">
+            <a:extLst xmlns:a="http://schemas.openxmlformats.org/drawingml/2006/main">
+              <a:ext uri="{FF2B5EF4-FFF2-40B4-BE49-F238E27FC236}">
+                <a16:creationId xmlns:a16="http://schemas.microsoft.com/office/drawing/2014/main" id="{73F02BF4-E9F2-4218-8478-C7FADEB8B6E3}"/>
+              </a:ext>
+            </a:extLst>
+          </p:cNvPr>
+          <p:cNvSpPr>
+            <a:spLocks xmlns:a="http://schemas.openxmlformats.org/drawingml/2006/main" noGrp="1"/>
+          </p:cNvSpPr>
+          <p:nvPr/>
+        </p:nvSpPr>
+        <p:spPr>
+          <a:xfrm xmlns:a="http://schemas.openxmlformats.org/drawingml/2006/main">
+            <a:off x="6934200" y="2438400"/>
+            <a:ext cx="3143250" cy="400050"/>
+          </a:xfrm>
+          <a:prstGeom xmlns:a="http://schemas.openxmlformats.org/drawingml/2006/main" prst="rect">
+            <a:avLst/>
+          </a:prstGeom>
+          <a:noFill xmlns:a="http://schemas.openxmlformats.org/drawingml/2006/main"/>
+          <a:ln xmlns:a="http://schemas.openxmlformats.org/drawingml/2006/main" w="0">
+            <a:noFill/>
+            <a:prstDash val="solid"/>
+          </a:ln>
+        </p:spPr>
+        <p:txBody>
+          <a:bodyPr xmlns:a="http://schemas.openxmlformats.org/drawingml/2006/main"/>
+          <a:lstStyle xmlns:a="http://schemas.openxmlformats.org/drawingml/2006/main"/>
+          <a:p xmlns:a="http://schemas.openxmlformats.org/drawingml/2006/main">
+            <a:pPr algn="l">
+              <a:defRPr sz="1200" b="0">
+                <a:solidFill>
+                  <a:srgbClr val="5B6472"/>
+                </a:solidFill>
+              </a:defRPr>
+            </a:pPr>
+            <a:r>
+              <a:rPr sz="1200" b="0">
+                <a:solidFill>
+                  <a:srgbClr val="5B6472"/>
+                </a:solidFill>
+              </a:rPr>
+              <a:t>Use the QR/link and keep synthetic data separate.</a:t>
+            </a:r>
+          </a:p>
+        </p:txBody>
+      </p:sp>
+      <p:sp>
+        <p:nvSpPr>
+          <p:cNvPr id="10" name="">
+            <a:extLst xmlns:a="http://schemas.openxmlformats.org/drawingml/2006/main">
+              <a:ext uri="{FF2B5EF4-FFF2-40B4-BE49-F238E27FC236}">
+                <a16:creationId xmlns:a16="http://schemas.microsoft.com/office/drawing/2014/main" id="{D419F312-3698-496B-9376-3D2EDF6589C1}"/>
+              </a:ext>
+            </a:extLst>
+          </p:cNvPr>
+          <p:cNvSpPr>
+            <a:spLocks xmlns:a="http://schemas.openxmlformats.org/drawingml/2006/main" noGrp="1"/>
+          </p:cNvSpPr>
+          <p:nvPr/>
+        </p:nvSpPr>
+        <p:spPr>
+          <a:xfrm xmlns:a="http://schemas.openxmlformats.org/drawingml/2006/main">
+            <a:off x="857250" y="3314700"/>
+            <a:ext cx="4476750" cy="1257300"/>
+          </a:xfrm>
+          <a:prstGeom xmlns:a="http://schemas.openxmlformats.org/drawingml/2006/main" prst="rect">
+            <a:avLst/>
+          </a:prstGeom>
+          <a:solidFill xmlns:a="http://schemas.openxmlformats.org/drawingml/2006/main">
+            <a:srgbClr val="FFFFFF"/>
+          </a:solidFill>
+          <a:ln xmlns:a="http://schemas.openxmlformats.org/drawingml/2006/main" w="9525">
+            <a:solidFill>
+              <a:srgbClr val="1C2430"/>
+            </a:solidFill>
+            <a:prstDash val="solid"/>
+          </a:ln>
+        </p:spPr>
+      </p:sp>
+      <p:sp>
+        <p:nvSpPr>
+          <p:cNvPr id="11" name="">
+            <a:extLst xmlns:a="http://schemas.openxmlformats.org/drawingml/2006/main">
+              <a:ext uri="{FF2B5EF4-FFF2-40B4-BE49-F238E27FC236}">
+                <a16:creationId xmlns:a16="http://schemas.microsoft.com/office/drawing/2014/main" id="{B2089760-5D14-476E-9A83-DE7845F780DF}"/>
+              </a:ext>
+            </a:extLst>
+          </p:cNvPr>
+          <p:cNvSpPr>
+            <a:spLocks xmlns:a="http://schemas.openxmlformats.org/drawingml/2006/main" noGrp="1"/>
+          </p:cNvSpPr>
+          <p:nvPr/>
+        </p:nvSpPr>
+        <p:spPr>
+          <a:xfrm xmlns:a="http://schemas.openxmlformats.org/drawingml/2006/main">
+            <a:off x="1085850" y="3562350"/>
+            <a:ext cx="552450" cy="495300"/>
+          </a:xfrm>
+          <a:prstGeom xmlns:a="http://schemas.openxmlformats.org/drawingml/2006/main" prst="rect">
+            <a:avLst/>
+          </a:prstGeom>
+          <a:noFill xmlns:a="http://schemas.openxmlformats.org/drawingml/2006/main"/>
+          <a:ln xmlns:a="http://schemas.openxmlformats.org/drawingml/2006/main" w="0">
+            <a:noFill/>
+            <a:prstDash val="solid"/>
+          </a:ln>
+        </p:spPr>
+        <p:txBody>
+          <a:bodyPr xmlns:a="http://schemas.openxmlformats.org/drawingml/2006/main"/>
+          <a:lstStyle xmlns:a="http://schemas.openxmlformats.org/drawingml/2006/main"/>
+          <a:p xmlns:a="http://schemas.openxmlformats.org/drawingml/2006/main">
+            <a:pPr algn="l">
+              <a:defRPr sz="3300" b="1">
+                <a:solidFill>
+                  <a:srgbClr val="456990"/>
+                </a:solidFill>
+              </a:defRPr>
+            </a:pPr>
+            <a:r>
+              <a:rPr sz="3300" b="1">
+                <a:solidFill>
+                  <a:srgbClr val="456990"/>
+                </a:solidFill>
+              </a:rPr>
+              <a:t>3</a:t>
+            </a:r>
+          </a:p>
+        </p:txBody>
+      </p:sp>
+      <p:sp>
+        <p:nvSpPr>
+          <p:cNvPr id="12" name="">
+            <a:extLst xmlns:a="http://schemas.openxmlformats.org/drawingml/2006/main">
+              <a:ext uri="{FF2B5EF4-FFF2-40B4-BE49-F238E27FC236}">
+                <a16:creationId xmlns:a16="http://schemas.microsoft.com/office/drawing/2014/main" id="{138E83C8-7A93-4BE4-A04E-A2D7CDFF96E0}"/>
+              </a:ext>
+            </a:extLst>
+          </p:cNvPr>
+          <p:cNvSpPr>
+            <a:spLocks xmlns:a="http://schemas.openxmlformats.org/drawingml/2006/main" noGrp="1"/>
+          </p:cNvSpPr>
+          <p:nvPr/>
+        </p:nvSpPr>
+        <p:spPr>
+          <a:xfrm xmlns:a="http://schemas.openxmlformats.org/drawingml/2006/main">
+            <a:off x="1790700" y="3524250"/>
+            <a:ext cx="3143250" cy="552450"/>
+          </a:xfrm>
+          <a:prstGeom xmlns:a="http://schemas.openxmlformats.org/drawingml/2006/main" prst="rect">
+            <a:avLst/>
+          </a:prstGeom>
+          <a:noFill xmlns:a="http://schemas.openxmlformats.org/drawingml/2006/main"/>
+          <a:ln xmlns:a="http://schemas.openxmlformats.org/drawingml/2006/main" w="0">
+            <a:noFill/>
+            <a:prstDash val="solid"/>
+          </a:ln>
+        </p:spPr>
+        <p:txBody>
+          <a:bodyPr xmlns:a="http://schemas.openxmlformats.org/drawingml/2006/main"/>
+          <a:lstStyle xmlns:a="http://schemas.openxmlformats.org/drawingml/2006/main"/>
+          <a:p xmlns:a="http://schemas.openxmlformats.org/drawingml/2006/main">
+            <a:pPr algn="l">
+              <a:defRPr sz="1725" b="1">
+                <a:solidFill>
+                  <a:srgbClr val="1C2430"/>
+                </a:solidFill>
+              </a:defRPr>
+            </a:pPr>
+            <a:r>
+              <a:rPr sz="1725" b="1">
+                <a:solidFill>
+                  <a:srgbClr val="1C2430"/>
+                </a:solidFill>
+              </a:rPr>
+              <a:t>Run Stata/R replication</a:t>
+            </a:r>
+          </a:p>
+        </p:txBody>
+      </p:sp>
+      <p:sp>
+        <p:nvSpPr>
+          <p:cNvPr id="13" name="">
+            <a:extLst xmlns:a="http://schemas.openxmlformats.org/drawingml/2006/main">
+              <a:ext uri="{FF2B5EF4-FFF2-40B4-BE49-F238E27FC236}">
+                <a16:creationId xmlns:a16="http://schemas.microsoft.com/office/drawing/2014/main" id="{BDFC8624-E2F4-4C18-8BED-357FF1CD3451}"/>
+              </a:ext>
+            </a:extLst>
+          </p:cNvPr>
+          <p:cNvSpPr>
+            <a:spLocks xmlns:a="http://schemas.openxmlformats.org/drawingml/2006/main" noGrp="1"/>
+          </p:cNvSpPr>
+          <p:nvPr/>
+        </p:nvSpPr>
+        <p:spPr>
+          <a:xfrm xmlns:a="http://schemas.openxmlformats.org/drawingml/2006/main">
+            <a:off x="1790700" y="4057650"/>
+            <a:ext cx="3143250" cy="400050"/>
+          </a:xfrm>
+          <a:prstGeom xmlns:a="http://schemas.openxmlformats.org/drawingml/2006/main" prst="rect">
+            <a:avLst/>
+          </a:prstGeom>
+          <a:noFill xmlns:a="http://schemas.openxmlformats.org/drawingml/2006/main"/>
+          <a:ln xmlns:a="http://schemas.openxmlformats.org/drawingml/2006/main" w="0">
+            <a:noFill/>
+            <a:prstDash val="solid"/>
+          </a:ln>
+        </p:spPr>
+        <p:txBody>
+          <a:bodyPr xmlns:a="http://schemas.openxmlformats.org/drawingml/2006/main"/>
+          <a:lstStyle xmlns:a="http://schemas.openxmlformats.org/drawingml/2006/main"/>
+          <a:p xmlns:a="http://schemas.openxmlformats.org/drawingml/2006/main">
+            <a:pPr algn="l">
+              <a:defRPr sz="1200" b="0">
+                <a:solidFill>
+                  <a:srgbClr val="5B6472"/>
+                </a:solidFill>
+              </a:defRPr>
+            </a:pPr>
+            <a:r>
+              <a:rPr sz="1200" b="0">
+                <a:solidFill>
+                  <a:srgbClr val="5B6472"/>
+                </a:solidFill>
+              </a:rPr>
+              <a:t>Use the included .do file and workbook model sheets.</a:t>
+            </a:r>
+          </a:p>
+        </p:txBody>
+      </p:sp>
+      <p:sp>
+        <p:nvSpPr>
+          <p:cNvPr id="14" name="">
+            <a:extLst xmlns:a="http://schemas.openxmlformats.org/drawingml/2006/main">
+              <a:ext uri="{FF2B5EF4-FFF2-40B4-BE49-F238E27FC236}">
+                <a16:creationId xmlns:a16="http://schemas.microsoft.com/office/drawing/2014/main" id="{C96EC2D2-F46D-426A-A65C-E24C8C55692F}"/>
+              </a:ext>
+            </a:extLst>
+          </p:cNvPr>
+          <p:cNvSpPr>
+            <a:spLocks xmlns:a="http://schemas.openxmlformats.org/drawingml/2006/main" noGrp="1"/>
+          </p:cNvSpPr>
+          <p:nvPr/>
+        </p:nvSpPr>
+        <p:spPr>
+          <a:xfrm xmlns:a="http://schemas.openxmlformats.org/drawingml/2006/main">
+            <a:off x="6000750" y="3314700"/>
+            <a:ext cx="4476750" cy="1257300"/>
+          </a:xfrm>
+          <a:prstGeom xmlns:a="http://schemas.openxmlformats.org/drawingml/2006/main" prst="rect">
+            <a:avLst/>
+          </a:prstGeom>
+          <a:solidFill xmlns:a="http://schemas.openxmlformats.org/drawingml/2006/main">
+            <a:srgbClr val="FFFFFF"/>
+          </a:solidFill>
+          <a:ln xmlns:a="http://schemas.openxmlformats.org/drawingml/2006/main" w="9525">
+            <a:solidFill>
+              <a:srgbClr val="1C2430"/>
+            </a:solidFill>
+            <a:prstDash val="solid"/>
+          </a:ln>
+        </p:spPr>
+      </p:sp>
+      <p:sp>
+        <p:nvSpPr>
+          <p:cNvPr id="15" name="">
+            <a:extLst xmlns:a="http://schemas.openxmlformats.org/drawingml/2006/main">
+              <a:ext uri="{FF2B5EF4-FFF2-40B4-BE49-F238E27FC236}">
+                <a16:creationId xmlns:a16="http://schemas.microsoft.com/office/drawing/2014/main" id="{52E7D27C-2ACC-475C-AC74-8309EED59170}"/>
+              </a:ext>
+            </a:extLst>
+          </p:cNvPr>
+          <p:cNvSpPr>
+            <a:spLocks xmlns:a="http://schemas.openxmlformats.org/drawingml/2006/main" noGrp="1"/>
+          </p:cNvSpPr>
+          <p:nvPr/>
+        </p:nvSpPr>
+        <p:spPr>
+          <a:xfrm xmlns:a="http://schemas.openxmlformats.org/drawingml/2006/main">
+            <a:off x="6229350" y="3562350"/>
+            <a:ext cx="552450" cy="495300"/>
+          </a:xfrm>
+          <a:prstGeom xmlns:a="http://schemas.openxmlformats.org/drawingml/2006/main" prst="rect">
+            <a:avLst/>
+          </a:prstGeom>
+          <a:noFill xmlns:a="http://schemas.openxmlformats.org/drawingml/2006/main"/>
+          <a:ln xmlns:a="http://schemas.openxmlformats.org/drawingml/2006/main" w="0">
+            <a:noFill/>
+            <a:prstDash val="solid"/>
+          </a:ln>
+        </p:spPr>
+        <p:txBody>
+          <a:bodyPr xmlns:a="http://schemas.openxmlformats.org/drawingml/2006/main"/>
+          <a:lstStyle xmlns:a="http://schemas.openxmlformats.org/drawingml/2006/main"/>
+          <a:p xmlns:a="http://schemas.openxmlformats.org/drawingml/2006/main">
+            <a:pPr algn="l">
+              <a:defRPr sz="3300" b="1">
+                <a:solidFill>
+                  <a:srgbClr val="B23A48"/>
+                </a:solidFill>
+              </a:defRPr>
+            </a:pPr>
+            <a:r>
+              <a:rPr sz="3300" b="1">
+                <a:solidFill>
+                  <a:srgbClr val="B23A48"/>
+                </a:solidFill>
+              </a:rPr>
+              <a:t>4</a:t>
+            </a:r>
+          </a:p>
+        </p:txBody>
+      </p:sp>
+      <p:sp>
+        <p:nvSpPr>
+          <p:cNvPr id="16" name="">
+            <a:extLst xmlns:a="http://schemas.openxmlformats.org/drawingml/2006/main">
+              <a:ext uri="{FF2B5EF4-FFF2-40B4-BE49-F238E27FC236}">
+                <a16:creationId xmlns:a16="http://schemas.microsoft.com/office/drawing/2014/main" id="{F46DD983-87C2-47F9-A892-84D642A692CA}"/>
+              </a:ext>
+            </a:extLst>
+          </p:cNvPr>
+          <p:cNvSpPr>
+            <a:spLocks xmlns:a="http://schemas.openxmlformats.org/drawingml/2006/main" noGrp="1"/>
+          </p:cNvSpPr>
+          <p:nvPr/>
+        </p:nvSpPr>
+        <p:spPr>
+          <a:xfrm xmlns:a="http://schemas.openxmlformats.org/drawingml/2006/main">
+            <a:off x="6934200" y="3524250"/>
+            <a:ext cx="3143250" cy="552450"/>
+          </a:xfrm>
+          <a:prstGeom xmlns:a="http://schemas.openxmlformats.org/drawingml/2006/main" prst="rect">
+            <a:avLst/>
+          </a:prstGeom>
+          <a:noFill xmlns:a="http://schemas.openxmlformats.org/drawingml/2006/main"/>
+          <a:ln xmlns:a="http://schemas.openxmlformats.org/drawingml/2006/main" w="0">
+            <a:noFill/>
+            <a:prstDash val="solid"/>
+          </a:ln>
+        </p:spPr>
+        <p:txBody>
+          <a:bodyPr xmlns:a="http://schemas.openxmlformats.org/drawingml/2006/main"/>
+          <a:lstStyle xmlns:a="http://schemas.openxmlformats.org/drawingml/2006/main"/>
+          <a:p xmlns:a="http://schemas.openxmlformats.org/drawingml/2006/main">
+            <a:pPr algn="l">
+              <a:defRPr sz="1725" b="1">
+                <a:solidFill>
+                  <a:srgbClr val="1C2430"/>
+                </a:solidFill>
+              </a:defRPr>
+            </a:pPr>
+            <a:r>
+              <a:rPr sz="1725" b="1">
+                <a:solidFill>
+                  <a:srgbClr val="1C2430"/>
+                </a:solidFill>
+              </a:rPr>
+              <a:t>Revise claims</a:t>
+            </a:r>
+          </a:p>
+        </p:txBody>
+      </p:sp>
+      <p:sp>
+        <p:nvSpPr>
+          <p:cNvPr id="17" name="">
+            <a:extLst xmlns:a="http://schemas.openxmlformats.org/drawingml/2006/main">
+              <a:ext uri="{FF2B5EF4-FFF2-40B4-BE49-F238E27FC236}">
+                <a16:creationId xmlns:a16="http://schemas.microsoft.com/office/drawing/2014/main" id="{E5EC4004-4F3D-4009-AB55-382C1A23DA8D}"/>
+              </a:ext>
+            </a:extLst>
+          </p:cNvPr>
+          <p:cNvSpPr>
+            <a:spLocks xmlns:a="http://schemas.openxmlformats.org/drawingml/2006/main" noGrp="1"/>
+          </p:cNvSpPr>
+          <p:nvPr/>
+        </p:nvSpPr>
+        <p:spPr>
+          <a:xfrm xmlns:a="http://schemas.openxmlformats.org/drawingml/2006/main">
+            <a:off x="6934200" y="4057650"/>
+            <a:ext cx="3143250" cy="400050"/>
+          </a:xfrm>
+          <a:prstGeom xmlns:a="http://schemas.openxmlformats.org/drawingml/2006/main" prst="rect">
+            <a:avLst/>
+          </a:prstGeom>
+          <a:noFill xmlns:a="http://schemas.openxmlformats.org/drawingml/2006/main"/>
+          <a:ln xmlns:a="http://schemas.openxmlformats.org/drawingml/2006/main" w="0">
+            <a:noFill/>
+            <a:prstDash val="solid"/>
+          </a:ln>
+        </p:spPr>
+        <p:txBody>
+          <a:bodyPr xmlns:a="http://schemas.openxmlformats.org/drawingml/2006/main"/>
+          <a:lstStyle xmlns:a="http://schemas.openxmlformats.org/drawingml/2006/main"/>
+          <a:p xmlns:a="http://schemas.openxmlformats.org/drawingml/2006/main">
+            <a:pPr algn="l">
+              <a:defRPr sz="1200" b="0">
+                <a:solidFill>
+                  <a:srgbClr val="5B6472"/>
+                </a:solidFill>
+              </a:defRPr>
+            </a:pPr>
+            <a:r>
+              <a:rPr sz="1200" b="0">
+                <a:solidFill>
+                  <a:srgbClr val="5B6472"/>
+                </a:solidFill>
+              </a:rPr>
+              <a:t>Replace demonstration language with empirical findings only after real data.</a:t>
+            </a:r>
+          </a:p>
+        </p:txBody>
+      </p:sp>
+      <p:sp>
+        <p:nvSpPr>
+          <p:cNvPr id="18" name="">
+            <a:extLst xmlns:a="http://schemas.openxmlformats.org/drawingml/2006/main">
+              <a:ext uri="{FF2B5EF4-FFF2-40B4-BE49-F238E27FC236}">
+                <a16:creationId xmlns:a16="http://schemas.microsoft.com/office/drawing/2014/main" id="{00B7BAFD-02B3-41BB-994B-F0869AD0B47A}"/>
+              </a:ext>
+            </a:extLst>
+          </p:cNvPr>
+          <p:cNvSpPr>
+            <a:spLocks xmlns:a="http://schemas.openxmlformats.org/drawingml/2006/main" noGrp="1"/>
+          </p:cNvSpPr>
+          <p:nvPr/>
+        </p:nvSpPr>
+        <p:spPr>
+          <a:xfrm xmlns:a="http://schemas.openxmlformats.org/drawingml/2006/main">
+            <a:off x="1047750" y="5619750"/>
+            <a:ext cx="9334500" cy="361950"/>
+          </a:xfrm>
+          <a:prstGeom xmlns:a="http://schemas.openxmlformats.org/drawingml/2006/main" prst="rect">
+            <a:avLst/>
+          </a:prstGeom>
+          <a:noFill xmlns:a="http://schemas.openxmlformats.org/drawingml/2006/main"/>
+          <a:ln xmlns:a="http://schemas.openxmlformats.org/drawingml/2006/main" w="0">
+            <a:noFill/>
+            <a:prstDash val="solid"/>
+          </a:ln>
+        </p:spPr>
+        <p:txBody>
+          <a:bodyPr xmlns:a="http://schemas.openxmlformats.org/drawingml/2006/main"/>
+          <a:lstStyle xmlns:a="http://schemas.openxmlformats.org/drawingml/2006/main"/>
+          <a:p xmlns:a="http://schemas.openxmlformats.org/drawingml/2006/main">
+            <a:pPr algn="ctr">
+              <a:defRPr sz="1725" b="1">
+                <a:solidFill>
+                  <a:srgbClr val="1C2430"/>
+                </a:solidFill>
+              </a:defRPr>
+            </a:pPr>
+            <a:r>
+              <a:rPr sz="1725" b="1">
+                <a:solidFill>
+                  <a:srgbClr val="1C2430"/>
+                </a:solidFill>
+              </a:rPr>
+              <a:t>Final output: public research website, Word report, PDF paper, workbook, deck, video, and full package.</a:t>
+            </a:r>
+          </a:p>
+        </p:txBody>
+      </p:sp>
+      <p:sp>
+        <p:nvSpPr>
+          <p:cNvPr id="19" name="">
+            <a:extLst xmlns:a="http://schemas.openxmlformats.org/drawingml/2006/main">
+              <a:ext uri="{FF2B5EF4-FFF2-40B4-BE49-F238E27FC236}">
+                <a16:creationId xmlns:a16="http://schemas.microsoft.com/office/drawing/2014/main" id="{2F6BC279-22BB-4661-A89A-E60B422641C8}"/>
+              </a:ext>
+            </a:extLst>
+          </p:cNvPr>
+          <p:cNvSpPr>
+            <a:spLocks xmlns:a="http://schemas.openxmlformats.org/drawingml/2006/main" noGrp="1"/>
+          </p:cNvSpPr>
+          <p:nvPr/>
+        </p:nvSpPr>
+        <p:spPr>
+          <a:xfrm xmlns:a="http://schemas.openxmlformats.org/drawingml/2006/main">
+            <a:off x="685800" y="6419850"/>
+            <a:ext cx="4095750" cy="228600"/>
+          </a:xfrm>
+          <a:prstGeom xmlns:a="http://schemas.openxmlformats.org/drawingml/2006/main" prst="rect">
+            <a:avLst/>
+          </a:prstGeom>
+          <a:noFill xmlns:a="http://schemas.openxmlformats.org/drawingml/2006/main"/>
+          <a:ln xmlns:a="http://schemas.openxmlformats.org/drawingml/2006/main" w="0">
+            <a:noFill/>
+            <a:prstDash val="solid"/>
+          </a:ln>
+        </p:spPr>
+        <p:txBody>
+          <a:bodyPr xmlns:a="http://schemas.openxmlformats.org/drawingml/2006/main"/>
+          <a:lstStyle xmlns:a="http://schemas.openxmlformats.org/drawingml/2006/main"/>
+          <a:p xmlns:a="http://schemas.openxmlformats.org/drawingml/2006/main">
+            <a:pPr algn="l">
+              <a:defRPr sz="1050" b="0">
+                <a:solidFill>
+                  <a:srgbClr val="5B6472"/>
+                </a:solidFill>
+              </a:defRPr>
+            </a:pPr>
+            <a:r>
+              <a:rPr sz="1050" b="0">
+                <a:solidFill>
+                  <a:srgbClr val="5B6472"/>
+                </a:solidFill>
+              </a:rPr>
+              <a:t>Loneliness &amp; Risk Decision Lab</a:t>
+            </a:r>
+          </a:p>
+        </p:txBody>
+      </p:sp>
+      <p:sp>
+        <p:nvSpPr>
+          <p:cNvPr id="20" name="">
+            <a:extLst xmlns:a="http://schemas.openxmlformats.org/drawingml/2006/main">
+              <a:ext uri="{FF2B5EF4-FFF2-40B4-BE49-F238E27FC236}">
+                <a16:creationId xmlns:a16="http://schemas.microsoft.com/office/drawing/2014/main" id="{91026896-1215-4A57-A7ED-E2459A63C2E7}"/>
+              </a:ext>
+            </a:extLst>
+          </p:cNvPr>
+          <p:cNvSpPr>
+            <a:spLocks xmlns:a="http://schemas.openxmlformats.org/drawingml/2006/main" noGrp="1"/>
+          </p:cNvSpPr>
+          <p:nvPr/>
+        </p:nvSpPr>
+        <p:spPr>
+          <a:xfrm xmlns:a="http://schemas.openxmlformats.org/drawingml/2006/main">
+            <a:off x="11049000" y="6419850"/>
+            <a:ext cx="457200" cy="228600"/>
+          </a:xfrm>
+          <a:prstGeom xmlns:a="http://schemas.openxmlformats.org/drawingml/2006/main" prst="rect">
+            <a:avLst/>
+          </a:prstGeom>
+          <a:noFill xmlns:a="http://schemas.openxmlformats.org/drawingml/2006/main"/>
+          <a:ln xmlns:a="http://schemas.openxmlformats.org/drawingml/2006/main" w="0">
+            <a:noFill/>
+            <a:prstDash val="solid"/>
+          </a:ln>
+        </p:spPr>
+        <p:txBody>
+          <a:bodyPr xmlns:a="http://schemas.openxmlformats.org/drawingml/2006/main"/>
+          <a:lstStyle xmlns:a="http://schemas.openxmlformats.org/drawingml/2006/main"/>
+          <a:p xmlns:a="http://schemas.openxmlformats.org/drawingml/2006/main">
+            <a:pPr algn="r">
+              <a:defRPr sz="1050" b="0">
+                <a:solidFill>
+                  <a:srgbClr val="5B6472"/>
+                </a:solidFill>
+              </a:defRPr>
+            </a:pPr>
+            <a:r>
+              <a:rPr sz="1050" b="0">
+                <a:solidFill>
+                  <a:srgbClr val="5B6472"/>
+                </a:solidFill>
+              </a:rPr>
+              <a:t>10</a:t>
+            </a:r>
+          </a:p>
+        </p:txBody>
+      </p:sp>
+    </p:spTree>
+    <p:extLst>
+      <p:ext uri="{BB962C8B-B14F-4D97-AF65-F5344CB8AC3E}">
+        <p14:creationId xmlns:p14="http://schemas.microsoft.com/office/powerpoint/2010/main" val="437258722"/>
       </p:ext>
     </p:extLst>
   </p:cSld>
@@ -2814,7 +3842,7 @@
           <p:cNvPr id="1" name="">
             <a:extLst xmlns:a="http://schemas.openxmlformats.org/drawingml/2006/main">
               <a:ext uri="{FF2B5EF4-FFF2-40B4-BE49-F238E27FC236}">
-                <a16:creationId xmlns:a16="http://schemas.microsoft.com/office/drawing/2014/main" id="{57893AED-29DA-4261-A59E-8857B44FF9AB}"/>
+                <a16:creationId xmlns:a16="http://schemas.microsoft.com/office/drawing/2014/main" id="{574367DE-0327-40EA-AD81-4C3F55B04EB8}"/>
               </a:ext>
             </a:extLst>
           </p:cNvPr>
@@ -2864,7 +3892,7 @@
           <p:cNvPr id="2" name="">
             <a:extLst xmlns:a="http://schemas.openxmlformats.org/drawingml/2006/main">
               <a:ext uri="{FF2B5EF4-FFF2-40B4-BE49-F238E27FC236}">
-                <a16:creationId xmlns:a16="http://schemas.microsoft.com/office/drawing/2014/main" id="{3E5656E3-C1B5-4878-BB24-15E687113B2B}"/>
+                <a16:creationId xmlns:a16="http://schemas.microsoft.com/office/drawing/2014/main" id="{10261AE2-12A5-406A-9AF3-AAF5BE5DEAAF}"/>
               </a:ext>
             </a:extLst>
           </p:cNvPr>
@@ -2897,7 +3925,7 @@
           <p:cNvPr id="3" name="">
             <a:extLst xmlns:a="http://schemas.openxmlformats.org/drawingml/2006/main">
               <a:ext uri="{FF2B5EF4-FFF2-40B4-BE49-F238E27FC236}">
-                <a16:creationId xmlns:a16="http://schemas.microsoft.com/office/drawing/2014/main" id="{63917819-7342-4FB2-9706-3BEA25E29556}"/>
+                <a16:creationId xmlns:a16="http://schemas.microsoft.com/office/drawing/2014/main" id="{1244C19B-5852-4086-9E6C-B3428AD86CBA}"/>
               </a:ext>
             </a:extLst>
           </p:cNvPr>
@@ -2930,7 +3958,7 @@
           <p:cNvPr id="4" name="">
             <a:extLst xmlns:a="http://schemas.openxmlformats.org/drawingml/2006/main">
               <a:ext uri="{FF2B5EF4-FFF2-40B4-BE49-F238E27FC236}">
-                <a16:creationId xmlns:a16="http://schemas.microsoft.com/office/drawing/2014/main" id="{8EA61BD0-DAA1-438E-B1BE-C8161F4BDAE4}"/>
+                <a16:creationId xmlns:a16="http://schemas.microsoft.com/office/drawing/2014/main" id="{FE14666F-7585-46CE-96F0-D42EE40E6C79}"/>
               </a:ext>
             </a:extLst>
           </p:cNvPr>
@@ -2980,7 +4008,7 @@
           <p:cNvPr id="5" name="">
             <a:extLst xmlns:a="http://schemas.openxmlformats.org/drawingml/2006/main">
               <a:ext uri="{FF2B5EF4-FFF2-40B4-BE49-F238E27FC236}">
-                <a16:creationId xmlns:a16="http://schemas.microsoft.com/office/drawing/2014/main" id="{3850B635-287B-4F10-9530-453506E6B3E9}"/>
+                <a16:creationId xmlns:a16="http://schemas.microsoft.com/office/drawing/2014/main" id="{46CDB4A6-838B-4FDC-B19E-C7243165D363}"/>
               </a:ext>
             </a:extLst>
           </p:cNvPr>
@@ -3030,7 +4058,7 @@
           <p:cNvPr id="6" name="">
             <a:extLst xmlns:a="http://schemas.openxmlformats.org/drawingml/2006/main">
               <a:ext uri="{FF2B5EF4-FFF2-40B4-BE49-F238E27FC236}">
-                <a16:creationId xmlns:a16="http://schemas.microsoft.com/office/drawing/2014/main" id="{AF7597B8-2F77-4293-B1A9-D3017F5CD790}"/>
+                <a16:creationId xmlns:a16="http://schemas.microsoft.com/office/drawing/2014/main" id="{62EC836B-3BFB-454F-B504-6D54D74FA0CF}"/>
               </a:ext>
             </a:extLst>
           </p:cNvPr>
@@ -3080,7 +4108,7 @@
           <p:cNvPr id="7" name="">
             <a:extLst xmlns:a="http://schemas.openxmlformats.org/drawingml/2006/main">
               <a:ext uri="{FF2B5EF4-FFF2-40B4-BE49-F238E27FC236}">
-                <a16:creationId xmlns:a16="http://schemas.microsoft.com/office/drawing/2014/main" id="{68243538-1C13-46DF-9296-DC281DECC1F5}"/>
+                <a16:creationId xmlns:a16="http://schemas.microsoft.com/office/drawing/2014/main" id="{66CE7FB5-6647-417B-B687-1B6D3D821B6E}"/>
               </a:ext>
             </a:extLst>
           </p:cNvPr>
@@ -3113,7 +4141,7 @@
           <p:cNvPr id="8" name="">
             <a:extLst xmlns:a="http://schemas.openxmlformats.org/drawingml/2006/main">
               <a:ext uri="{FF2B5EF4-FFF2-40B4-BE49-F238E27FC236}">
-                <a16:creationId xmlns:a16="http://schemas.microsoft.com/office/drawing/2014/main" id="{1E32B302-8CAF-4B04-ADE4-F02DA5BFCEB5}"/>
+                <a16:creationId xmlns:a16="http://schemas.microsoft.com/office/drawing/2014/main" id="{A36D8E0B-7B37-400A-A780-C3926DF58B51}"/>
               </a:ext>
             </a:extLst>
           </p:cNvPr>
@@ -3146,7 +4174,7 @@
           <p:cNvPr id="9" name="">
             <a:extLst xmlns:a="http://schemas.openxmlformats.org/drawingml/2006/main">
               <a:ext uri="{FF2B5EF4-FFF2-40B4-BE49-F238E27FC236}">
-                <a16:creationId xmlns:a16="http://schemas.microsoft.com/office/drawing/2014/main" id="{6C04131B-83B1-4E15-AFCE-C29564A4F534}"/>
+                <a16:creationId xmlns:a16="http://schemas.microsoft.com/office/drawing/2014/main" id="{78B22C37-5653-4265-87A0-1A12E750AB0D}"/>
               </a:ext>
             </a:extLst>
           </p:cNvPr>
@@ -3196,7 +4224,7 @@
           <p:cNvPr id="10" name="">
             <a:extLst xmlns:a="http://schemas.openxmlformats.org/drawingml/2006/main">
               <a:ext uri="{FF2B5EF4-FFF2-40B4-BE49-F238E27FC236}">
-                <a16:creationId xmlns:a16="http://schemas.microsoft.com/office/drawing/2014/main" id="{ACC73E84-8AD2-45D8-BE50-EF965621D342}"/>
+                <a16:creationId xmlns:a16="http://schemas.microsoft.com/office/drawing/2014/main" id="{407FF97B-E512-4103-AAF0-966B62B54782}"/>
               </a:ext>
             </a:extLst>
           </p:cNvPr>
@@ -3246,7 +4274,7 @@
           <p:cNvPr id="11" name="">
             <a:extLst xmlns:a="http://schemas.openxmlformats.org/drawingml/2006/main">
               <a:ext uri="{FF2B5EF4-FFF2-40B4-BE49-F238E27FC236}">
-                <a16:creationId xmlns:a16="http://schemas.microsoft.com/office/drawing/2014/main" id="{375D43B5-0D34-432E-BAC1-C832888EBB2C}"/>
+                <a16:creationId xmlns:a16="http://schemas.microsoft.com/office/drawing/2014/main" id="{69D1B563-9D33-4B79-9DB8-C971AF165840}"/>
               </a:ext>
             </a:extLst>
           </p:cNvPr>
@@ -3296,7 +4324,7 @@
           <p:cNvPr id="12" name="">
             <a:extLst xmlns:a="http://schemas.openxmlformats.org/drawingml/2006/main">
               <a:ext uri="{FF2B5EF4-FFF2-40B4-BE49-F238E27FC236}">
-                <a16:creationId xmlns:a16="http://schemas.microsoft.com/office/drawing/2014/main" id="{A41C3EFB-B253-4D2C-822C-F987DAEBD1CD}"/>
+                <a16:creationId xmlns:a16="http://schemas.microsoft.com/office/drawing/2014/main" id="{1088D6DE-A6B3-4911-A629-438AF430D6AA}"/>
               </a:ext>
             </a:extLst>
           </p:cNvPr>
@@ -3329,7 +4357,7 @@
           <p:cNvPr id="13" name="">
             <a:extLst xmlns:a="http://schemas.openxmlformats.org/drawingml/2006/main">
               <a:ext uri="{FF2B5EF4-FFF2-40B4-BE49-F238E27FC236}">
-                <a16:creationId xmlns:a16="http://schemas.microsoft.com/office/drawing/2014/main" id="{3A6C333F-0B5B-4F2D-A41C-319DFB2DB585}"/>
+                <a16:creationId xmlns:a16="http://schemas.microsoft.com/office/drawing/2014/main" id="{B4075E4E-66BD-45E4-832C-DB45871FF044}"/>
               </a:ext>
             </a:extLst>
           </p:cNvPr>
@@ -3362,7 +4390,7 @@
           <p:cNvPr id="14" name="">
             <a:extLst xmlns:a="http://schemas.openxmlformats.org/drawingml/2006/main">
               <a:ext uri="{FF2B5EF4-FFF2-40B4-BE49-F238E27FC236}">
-                <a16:creationId xmlns:a16="http://schemas.microsoft.com/office/drawing/2014/main" id="{EF1F5FA2-C433-43C8-978E-31D66F5A226B}"/>
+                <a16:creationId xmlns:a16="http://schemas.microsoft.com/office/drawing/2014/main" id="{4AC1C85C-AF41-4A4E-9E38-EDD09FCE8FD1}"/>
               </a:ext>
             </a:extLst>
           </p:cNvPr>
@@ -3412,7 +4440,7 @@
           <p:cNvPr id="15" name="">
             <a:extLst xmlns:a="http://schemas.openxmlformats.org/drawingml/2006/main">
               <a:ext uri="{FF2B5EF4-FFF2-40B4-BE49-F238E27FC236}">
-                <a16:creationId xmlns:a16="http://schemas.microsoft.com/office/drawing/2014/main" id="{B853C4AE-5393-41BA-83DB-E441972D8385}"/>
+                <a16:creationId xmlns:a16="http://schemas.microsoft.com/office/drawing/2014/main" id="{832BBE22-ED22-4447-AEF2-18A33E5273F1}"/>
               </a:ext>
             </a:extLst>
           </p:cNvPr>
@@ -3462,7 +4490,7 @@
           <p:cNvPr id="16" name="">
             <a:extLst xmlns:a="http://schemas.openxmlformats.org/drawingml/2006/main">
               <a:ext uri="{FF2B5EF4-FFF2-40B4-BE49-F238E27FC236}">
-                <a16:creationId xmlns:a16="http://schemas.microsoft.com/office/drawing/2014/main" id="{2FB94F76-11FF-4600-9B45-35D99DCA9699}"/>
+                <a16:creationId xmlns:a16="http://schemas.microsoft.com/office/drawing/2014/main" id="{EC896F14-E454-4209-B21B-3B768E06049E}"/>
               </a:ext>
             </a:extLst>
           </p:cNvPr>
@@ -3512,7 +4540,7 @@
           <p:cNvPr id="17" name="">
             <a:extLst xmlns:a="http://schemas.openxmlformats.org/drawingml/2006/main">
               <a:ext uri="{FF2B5EF4-FFF2-40B4-BE49-F238E27FC236}">
-                <a16:creationId xmlns:a16="http://schemas.microsoft.com/office/drawing/2014/main" id="{FEC84399-78D1-4397-BE25-C80F30032079}"/>
+                <a16:creationId xmlns:a16="http://schemas.microsoft.com/office/drawing/2014/main" id="{0F290555-C64E-49EA-AB09-9E9EF9BD01FE}"/>
               </a:ext>
             </a:extLst>
           </p:cNvPr>
@@ -3545,7 +4573,7 @@
           <p:cNvPr id="18" name="">
             <a:extLst xmlns:a="http://schemas.openxmlformats.org/drawingml/2006/main">
               <a:ext uri="{FF2B5EF4-FFF2-40B4-BE49-F238E27FC236}">
-                <a16:creationId xmlns:a16="http://schemas.microsoft.com/office/drawing/2014/main" id="{F8D516F5-9081-4A3A-A09C-5B65539A8B77}"/>
+                <a16:creationId xmlns:a16="http://schemas.microsoft.com/office/drawing/2014/main" id="{1954258A-C55A-4889-849B-DBA5DA829999}"/>
               </a:ext>
             </a:extLst>
           </p:cNvPr>
@@ -3578,7 +4606,7 @@
           <p:cNvPr id="19" name="">
             <a:extLst xmlns:a="http://schemas.openxmlformats.org/drawingml/2006/main">
               <a:ext uri="{FF2B5EF4-FFF2-40B4-BE49-F238E27FC236}">
-                <a16:creationId xmlns:a16="http://schemas.microsoft.com/office/drawing/2014/main" id="{B40CC001-0345-4B7D-9C5C-302F9D385CB7}"/>
+                <a16:creationId xmlns:a16="http://schemas.microsoft.com/office/drawing/2014/main" id="{FC10366B-259E-44AC-83BC-F5F1227B39A1}"/>
               </a:ext>
             </a:extLst>
           </p:cNvPr>
@@ -3628,7 +4656,7 @@
           <p:cNvPr id="20" name="">
             <a:extLst xmlns:a="http://schemas.openxmlformats.org/drawingml/2006/main">
               <a:ext uri="{FF2B5EF4-FFF2-40B4-BE49-F238E27FC236}">
-                <a16:creationId xmlns:a16="http://schemas.microsoft.com/office/drawing/2014/main" id="{5FF30043-1862-44D9-99EE-27E36719A851}"/>
+                <a16:creationId xmlns:a16="http://schemas.microsoft.com/office/drawing/2014/main" id="{23B14F58-EA1D-4C25-911D-454E8448B762}"/>
               </a:ext>
             </a:extLst>
           </p:cNvPr>
@@ -3678,7 +4706,7 @@
           <p:cNvPr id="21" name="">
             <a:extLst xmlns:a="http://schemas.openxmlformats.org/drawingml/2006/main">
               <a:ext uri="{FF2B5EF4-FFF2-40B4-BE49-F238E27FC236}">
-                <a16:creationId xmlns:a16="http://schemas.microsoft.com/office/drawing/2014/main" id="{F8FE13F9-87BF-47B6-BD73-12708141917D}"/>
+                <a16:creationId xmlns:a16="http://schemas.microsoft.com/office/drawing/2014/main" id="{25E15E00-B2CA-4779-92F0-C9FAB1C91876}"/>
               </a:ext>
             </a:extLst>
           </p:cNvPr>
@@ -3728,7 +4756,7 @@
           <p:cNvPr id="22" name="">
             <a:extLst xmlns:a="http://schemas.openxmlformats.org/drawingml/2006/main">
               <a:ext uri="{FF2B5EF4-FFF2-40B4-BE49-F238E27FC236}">
-                <a16:creationId xmlns:a16="http://schemas.microsoft.com/office/drawing/2014/main" id="{0A236F24-7113-47C7-B0B3-822D33634A27}"/>
+                <a16:creationId xmlns:a16="http://schemas.microsoft.com/office/drawing/2014/main" id="{356EC33F-878D-47D8-AA86-A90381A3495C}"/>
               </a:ext>
             </a:extLst>
           </p:cNvPr>
@@ -3778,7 +4806,7 @@
           <p:cNvPr id="23" name="">
             <a:extLst xmlns:a="http://schemas.openxmlformats.org/drawingml/2006/main">
               <a:ext uri="{FF2B5EF4-FFF2-40B4-BE49-F238E27FC236}">
-                <a16:creationId xmlns:a16="http://schemas.microsoft.com/office/drawing/2014/main" id="{C7E5A73C-FF91-41B2-85B5-297899036C64}"/>
+                <a16:creationId xmlns:a16="http://schemas.microsoft.com/office/drawing/2014/main" id="{5480C836-2E53-4B94-8D23-77A0A4ABDD42}"/>
               </a:ext>
             </a:extLst>
           </p:cNvPr>
@@ -3826,7 +4854,7 @@
     </p:spTree>
     <p:extLst>
       <p:ext uri="{BB962C8B-B14F-4D97-AF65-F5344CB8AC3E}">
-        <p14:creationId xmlns:p14="http://schemas.microsoft.com/office/powerpoint/2010/main" val="1671239600"/>
+        <p14:creationId xmlns:p14="http://schemas.microsoft.com/office/powerpoint/2010/main" val="1137059989"/>
       </p:ext>
     </p:extLst>
   </p:cSld>
@@ -3857,7 +4885,7 @@
           <p:cNvPr id="1" name="">
             <a:extLst xmlns:a="http://schemas.openxmlformats.org/drawingml/2006/main">
               <a:ext uri="{FF2B5EF4-FFF2-40B4-BE49-F238E27FC236}">
-                <a16:creationId xmlns:a16="http://schemas.microsoft.com/office/drawing/2014/main" id="{90813F45-1CAC-4B85-BDBA-7D8AA53D6A5C}"/>
+                <a16:creationId xmlns:a16="http://schemas.microsoft.com/office/drawing/2014/main" id="{E884415F-7AEF-4ED0-98DC-9DA8DE3B3E70}"/>
               </a:ext>
             </a:extLst>
           </p:cNvPr>
@@ -3907,7 +4935,7 @@
           <p:cNvPr id="2" name="">
             <a:extLst xmlns:a="http://schemas.openxmlformats.org/drawingml/2006/main">
               <a:ext uri="{FF2B5EF4-FFF2-40B4-BE49-F238E27FC236}">
-                <a16:creationId xmlns:a16="http://schemas.microsoft.com/office/drawing/2014/main" id="{EB8625D1-9652-4F4D-B9E0-C79E8C61D452}"/>
+                <a16:creationId xmlns:a16="http://schemas.microsoft.com/office/drawing/2014/main" id="{1963A415-85A2-4E6D-8729-77F3A9C5580E}"/>
               </a:ext>
             </a:extLst>
           </p:cNvPr>
@@ -3940,7 +4968,7 @@
           <p:cNvPr id="3" name="">
             <a:extLst xmlns:a="http://schemas.openxmlformats.org/drawingml/2006/main">
               <a:ext uri="{FF2B5EF4-FFF2-40B4-BE49-F238E27FC236}">
-                <a16:creationId xmlns:a16="http://schemas.microsoft.com/office/drawing/2014/main" id="{0BD25909-117E-4CBB-9636-674557AF833A}"/>
+                <a16:creationId xmlns:a16="http://schemas.microsoft.com/office/drawing/2014/main" id="{67F776BA-712F-445C-B08E-32B4CF967E01}"/>
               </a:ext>
             </a:extLst>
           </p:cNvPr>
@@ -3990,7 +5018,7 @@
           <p:cNvPr id="4" name="">
             <a:extLst xmlns:a="http://schemas.openxmlformats.org/drawingml/2006/main">
               <a:ext uri="{FF2B5EF4-FFF2-40B4-BE49-F238E27FC236}">
-                <a16:creationId xmlns:a16="http://schemas.microsoft.com/office/drawing/2014/main" id="{66381F43-2FBF-45A7-B1AD-742EF2FE5092}"/>
+                <a16:creationId xmlns:a16="http://schemas.microsoft.com/office/drawing/2014/main" id="{422362AD-67F6-4495-8F5A-52D163A1FC4F}"/>
               </a:ext>
             </a:extLst>
           </p:cNvPr>
@@ -4040,7 +5068,7 @@
           <p:cNvPr id="5" name="">
             <a:extLst xmlns:a="http://schemas.openxmlformats.org/drawingml/2006/main">
               <a:ext uri="{FF2B5EF4-FFF2-40B4-BE49-F238E27FC236}">
-                <a16:creationId xmlns:a16="http://schemas.microsoft.com/office/drawing/2014/main" id="{D0FD7D59-6975-4C15-90DC-A3FF1A42FF11}"/>
+                <a16:creationId xmlns:a16="http://schemas.microsoft.com/office/drawing/2014/main" id="{5CF2F0A5-4271-49E7-A900-7F97353D95E6}"/>
               </a:ext>
             </a:extLst>
           </p:cNvPr>
@@ -4073,7 +5101,7 @@
           <p:cNvPr id="6" name="">
             <a:extLst xmlns:a="http://schemas.openxmlformats.org/drawingml/2006/main">
               <a:ext uri="{FF2B5EF4-FFF2-40B4-BE49-F238E27FC236}">
-                <a16:creationId xmlns:a16="http://schemas.microsoft.com/office/drawing/2014/main" id="{9A7BB735-4713-4A05-B5AE-68A66C9C2E59}"/>
+                <a16:creationId xmlns:a16="http://schemas.microsoft.com/office/drawing/2014/main" id="{F040D2B2-1362-4473-A6E1-2F16CF36AA74}"/>
               </a:ext>
             </a:extLst>
           </p:cNvPr>
@@ -4123,7 +5151,7 @@
           <p:cNvPr id="7" name="">
             <a:extLst xmlns:a="http://schemas.openxmlformats.org/drawingml/2006/main">
               <a:ext uri="{FF2B5EF4-FFF2-40B4-BE49-F238E27FC236}">
-                <a16:creationId xmlns:a16="http://schemas.microsoft.com/office/drawing/2014/main" id="{898565CB-C6A8-452E-9DE6-E53B79820E6D}"/>
+                <a16:creationId xmlns:a16="http://schemas.microsoft.com/office/drawing/2014/main" id="{C614ED7C-D5CC-4A28-A712-65D48A707971}"/>
               </a:ext>
             </a:extLst>
           </p:cNvPr>
@@ -4173,7 +5201,7 @@
           <p:cNvPr id="8" name="">
             <a:extLst xmlns:a="http://schemas.openxmlformats.org/drawingml/2006/main">
               <a:ext uri="{FF2B5EF4-FFF2-40B4-BE49-F238E27FC236}">
-                <a16:creationId xmlns:a16="http://schemas.microsoft.com/office/drawing/2014/main" id="{6B1904EF-FFB8-40D5-BECE-CFF5F984F614}"/>
+                <a16:creationId xmlns:a16="http://schemas.microsoft.com/office/drawing/2014/main" id="{63BEDF0D-EF23-42CF-AC0E-A05D3C92BDD4}"/>
               </a:ext>
             </a:extLst>
           </p:cNvPr>
@@ -4206,7 +5234,7 @@
           <p:cNvPr id="9" name="">
             <a:extLst xmlns:a="http://schemas.openxmlformats.org/drawingml/2006/main">
               <a:ext uri="{FF2B5EF4-FFF2-40B4-BE49-F238E27FC236}">
-                <a16:creationId xmlns:a16="http://schemas.microsoft.com/office/drawing/2014/main" id="{E2CA3895-35D4-4DA7-A40D-60D26E767F0C}"/>
+                <a16:creationId xmlns:a16="http://schemas.microsoft.com/office/drawing/2014/main" id="{7D0199EA-6263-45F1-B5E8-96B5EE84BA1D}"/>
               </a:ext>
             </a:extLst>
           </p:cNvPr>
@@ -4256,7 +5284,7 @@
           <p:cNvPr id="10" name="">
             <a:extLst xmlns:a="http://schemas.openxmlformats.org/drawingml/2006/main">
               <a:ext uri="{FF2B5EF4-FFF2-40B4-BE49-F238E27FC236}">
-                <a16:creationId xmlns:a16="http://schemas.microsoft.com/office/drawing/2014/main" id="{204CBD82-1409-4AE5-9F8A-0CA494CE31DB}"/>
+                <a16:creationId xmlns:a16="http://schemas.microsoft.com/office/drawing/2014/main" id="{B43547B5-56BE-4AB4-A548-90B6A93E1251}"/>
               </a:ext>
             </a:extLst>
           </p:cNvPr>
@@ -4306,7 +5334,7 @@
           <p:cNvPr id="11" name="">
             <a:extLst xmlns:a="http://schemas.openxmlformats.org/drawingml/2006/main">
               <a:ext uri="{FF2B5EF4-FFF2-40B4-BE49-F238E27FC236}">
-                <a16:creationId xmlns:a16="http://schemas.microsoft.com/office/drawing/2014/main" id="{0CA01DBA-D713-4586-9F78-7FEF57EEAF62}"/>
+                <a16:creationId xmlns:a16="http://schemas.microsoft.com/office/drawing/2014/main" id="{17277530-A542-4036-AD8E-0658281A3550}"/>
               </a:ext>
             </a:extLst>
           </p:cNvPr>
@@ -4339,7 +5367,7 @@
           <p:cNvPr id="12" name="">
             <a:extLst xmlns:a="http://schemas.openxmlformats.org/drawingml/2006/main">
               <a:ext uri="{FF2B5EF4-FFF2-40B4-BE49-F238E27FC236}">
-                <a16:creationId xmlns:a16="http://schemas.microsoft.com/office/drawing/2014/main" id="{C73C29E8-7133-4861-AA24-E990396209B0}"/>
+                <a16:creationId xmlns:a16="http://schemas.microsoft.com/office/drawing/2014/main" id="{6E7B1F23-15D7-463E-BA39-10D8B0315A2A}"/>
               </a:ext>
             </a:extLst>
           </p:cNvPr>
@@ -4389,7 +5417,7 @@
           <p:cNvPr id="13" name="">
             <a:extLst xmlns:a="http://schemas.openxmlformats.org/drawingml/2006/main">
               <a:ext uri="{FF2B5EF4-FFF2-40B4-BE49-F238E27FC236}">
-                <a16:creationId xmlns:a16="http://schemas.microsoft.com/office/drawing/2014/main" id="{140C33DE-9DF8-4016-8841-F2E5B322355A}"/>
+                <a16:creationId xmlns:a16="http://schemas.microsoft.com/office/drawing/2014/main" id="{8E1E0FA3-569F-4AA5-A0A3-04889BFFED07}"/>
               </a:ext>
             </a:extLst>
           </p:cNvPr>
@@ -4439,7 +5467,7 @@
           <p:cNvPr id="14" name="">
             <a:extLst xmlns:a="http://schemas.openxmlformats.org/drawingml/2006/main">
               <a:ext uri="{FF2B5EF4-FFF2-40B4-BE49-F238E27FC236}">
-                <a16:creationId xmlns:a16="http://schemas.microsoft.com/office/drawing/2014/main" id="{A95340ED-8969-4321-BC31-96C478448B1C}"/>
+                <a16:creationId xmlns:a16="http://schemas.microsoft.com/office/drawing/2014/main" id="{539A9271-A315-45ED-B620-87E91026EF07}"/>
               </a:ext>
             </a:extLst>
           </p:cNvPr>
@@ -4472,7 +5500,7 @@
           <p:cNvPr id="15" name="">
             <a:extLst xmlns:a="http://schemas.openxmlformats.org/drawingml/2006/main">
               <a:ext uri="{FF2B5EF4-FFF2-40B4-BE49-F238E27FC236}">
-                <a16:creationId xmlns:a16="http://schemas.microsoft.com/office/drawing/2014/main" id="{D8DAE660-1D53-417C-9ADA-9627D6419FC1}"/>
+                <a16:creationId xmlns:a16="http://schemas.microsoft.com/office/drawing/2014/main" id="{5AEAC53C-FE2D-4208-A01E-DD6B1EAEE261}"/>
               </a:ext>
             </a:extLst>
           </p:cNvPr>
@@ -4522,7 +5550,7 @@
           <p:cNvPr id="16" name="">
             <a:extLst xmlns:a="http://schemas.openxmlformats.org/drawingml/2006/main">
               <a:ext uri="{FF2B5EF4-FFF2-40B4-BE49-F238E27FC236}">
-                <a16:creationId xmlns:a16="http://schemas.microsoft.com/office/drawing/2014/main" id="{1995521E-C509-49EA-8FD6-622B725100A3}"/>
+                <a16:creationId xmlns:a16="http://schemas.microsoft.com/office/drawing/2014/main" id="{4D670296-4306-4738-BA1B-0B5C5FC3008D}"/>
               </a:ext>
             </a:extLst>
           </p:cNvPr>
@@ -4572,7 +5600,7 @@
           <p:cNvPr id="17" name="">
             <a:extLst xmlns:a="http://schemas.openxmlformats.org/drawingml/2006/main">
               <a:ext uri="{FF2B5EF4-FFF2-40B4-BE49-F238E27FC236}">
-                <a16:creationId xmlns:a16="http://schemas.microsoft.com/office/drawing/2014/main" id="{8BF88803-0445-441D-953E-081E3070D1E2}"/>
+                <a16:creationId xmlns:a16="http://schemas.microsoft.com/office/drawing/2014/main" id="{9A9D605D-DB2C-41B0-BE74-BBD085ACF3A1}"/>
               </a:ext>
             </a:extLst>
           </p:cNvPr>
@@ -4605,7 +5633,7 @@
           <p:cNvPr id="18" name="">
             <a:extLst xmlns:a="http://schemas.openxmlformats.org/drawingml/2006/main">
               <a:ext uri="{FF2B5EF4-FFF2-40B4-BE49-F238E27FC236}">
-                <a16:creationId xmlns:a16="http://schemas.microsoft.com/office/drawing/2014/main" id="{740AE1B5-27D5-4EEB-8531-A00CDC9DF76E}"/>
+                <a16:creationId xmlns:a16="http://schemas.microsoft.com/office/drawing/2014/main" id="{C28EDA0F-6383-4D39-A77C-4306BD27A8EC}"/>
               </a:ext>
             </a:extLst>
           </p:cNvPr>
@@ -4655,7 +5683,7 @@
           <p:cNvPr id="19" name="">
             <a:extLst xmlns:a="http://schemas.openxmlformats.org/drawingml/2006/main">
               <a:ext uri="{FF2B5EF4-FFF2-40B4-BE49-F238E27FC236}">
-                <a16:creationId xmlns:a16="http://schemas.microsoft.com/office/drawing/2014/main" id="{9DA1FEA4-FB11-429B-9B5B-984180C8488C}"/>
+                <a16:creationId xmlns:a16="http://schemas.microsoft.com/office/drawing/2014/main" id="{02929566-BB35-4F3C-AFE2-BA6FE52E736D}"/>
               </a:ext>
             </a:extLst>
           </p:cNvPr>
@@ -4705,7 +5733,7 @@
           <p:cNvPr id="20" name="">
             <a:extLst xmlns:a="http://schemas.openxmlformats.org/drawingml/2006/main">
               <a:ext uri="{FF2B5EF4-FFF2-40B4-BE49-F238E27FC236}">
-                <a16:creationId xmlns:a16="http://schemas.microsoft.com/office/drawing/2014/main" id="{ADD6F1A8-5E37-4462-984D-7B40CCB7C557}"/>
+                <a16:creationId xmlns:a16="http://schemas.microsoft.com/office/drawing/2014/main" id="{F661516B-9F76-41AE-AC17-2823C9D4AF35}"/>
               </a:ext>
             </a:extLst>
           </p:cNvPr>
@@ -4738,7 +5766,7 @@
           <p:cNvPr id="21" name="">
             <a:extLst xmlns:a="http://schemas.openxmlformats.org/drawingml/2006/main">
               <a:ext uri="{FF2B5EF4-FFF2-40B4-BE49-F238E27FC236}">
-                <a16:creationId xmlns:a16="http://schemas.microsoft.com/office/drawing/2014/main" id="{C6DE185C-44E3-4E52-8D22-75322CE8599D}"/>
+                <a16:creationId xmlns:a16="http://schemas.microsoft.com/office/drawing/2014/main" id="{9DEC10F4-B70E-41BA-8A6F-8A575D8E54DE}"/>
               </a:ext>
             </a:extLst>
           </p:cNvPr>
@@ -4778,7 +5806,7 @@
                   <a:srgbClr val="FFFFFF"/>
                 </a:solidFill>
               </a:rPr>
-              <a:t>Risk Decision Index = .35 Reward + .25 Spending + .25 Risk + .15 Conflict</a:t>
+              <a:t>RDI = .35 Reward + .25 Spending + .25 Risk + .15 Conflict</a:t>
             </a:r>
           </a:p>
         </p:txBody>
@@ -4788,7 +5816,7 @@
           <p:cNvPr id="22" name="">
             <a:extLst xmlns:a="http://schemas.openxmlformats.org/drawingml/2006/main">
               <a:ext uri="{FF2B5EF4-FFF2-40B4-BE49-F238E27FC236}">
-                <a16:creationId xmlns:a16="http://schemas.microsoft.com/office/drawing/2014/main" id="{510EFE18-99FA-4F74-8A56-292967BB51F4}"/>
+                <a16:creationId xmlns:a16="http://schemas.microsoft.com/office/drawing/2014/main" id="{7A9400DC-FD7D-43A3-B7CD-C0C482A6298E}"/>
               </a:ext>
             </a:extLst>
           </p:cNvPr>
@@ -4838,7 +5866,7 @@
           <p:cNvPr id="23" name="">
             <a:extLst xmlns:a="http://schemas.openxmlformats.org/drawingml/2006/main">
               <a:ext uri="{FF2B5EF4-FFF2-40B4-BE49-F238E27FC236}">
-                <a16:creationId xmlns:a16="http://schemas.microsoft.com/office/drawing/2014/main" id="{59816A8E-901D-4E51-A248-B84AF7C4C2D5}"/>
+                <a16:creationId xmlns:a16="http://schemas.microsoft.com/office/drawing/2014/main" id="{1CC1C085-991F-48D9-8EB9-883AE067DD08}"/>
               </a:ext>
             </a:extLst>
           </p:cNvPr>
@@ -4886,7 +5914,7 @@
     </p:spTree>
     <p:extLst>
       <p:ext uri="{BB962C8B-B14F-4D97-AF65-F5344CB8AC3E}">
-        <p14:creationId xmlns:p14="http://schemas.microsoft.com/office/powerpoint/2010/main" val="232785237"/>
+        <p14:creationId xmlns:p14="http://schemas.microsoft.com/office/powerpoint/2010/main" val="852148316"/>
       </p:ext>
     </p:extLst>
   </p:cSld>
@@ -4917,7 +5945,7 @@
           <p:cNvPr id="1" name="">
             <a:extLst xmlns:a="http://schemas.openxmlformats.org/drawingml/2006/main">
               <a:ext uri="{FF2B5EF4-FFF2-40B4-BE49-F238E27FC236}">
-                <a16:creationId xmlns:a16="http://schemas.microsoft.com/office/drawing/2014/main" id="{E3A90D59-9D2D-42FA-96C0-D17092911CC1}"/>
+                <a16:creationId xmlns:a16="http://schemas.microsoft.com/office/drawing/2014/main" id="{A40BDF76-39B7-43A7-A5CF-520B4AE3ECC8}"/>
               </a:ext>
             </a:extLst>
           </p:cNvPr>
@@ -4967,7 +5995,7 @@
           <p:cNvPr id="2" name="">
             <a:extLst xmlns:a="http://schemas.openxmlformats.org/drawingml/2006/main">
               <a:ext uri="{FF2B5EF4-FFF2-40B4-BE49-F238E27FC236}">
-                <a16:creationId xmlns:a16="http://schemas.microsoft.com/office/drawing/2014/main" id="{02B9F757-41D1-41E3-ABCA-1C99A6B807B3}"/>
+                <a16:creationId xmlns:a16="http://schemas.microsoft.com/office/drawing/2014/main" id="{61829EE3-5407-45E4-B3E9-FE6EE1091772}"/>
               </a:ext>
             </a:extLst>
           </p:cNvPr>
@@ -5000,7 +6028,7 @@
           <p:cNvPr id="3" name="">
             <a:extLst xmlns:a="http://schemas.openxmlformats.org/drawingml/2006/main">
               <a:ext uri="{FF2B5EF4-FFF2-40B4-BE49-F238E27FC236}">
-                <a16:creationId xmlns:a16="http://schemas.microsoft.com/office/drawing/2014/main" id="{508375B2-353D-4C46-A9B9-DA5DF1A2FF98}"/>
+                <a16:creationId xmlns:a16="http://schemas.microsoft.com/office/drawing/2014/main" id="{6F138A1A-E09F-44D8-9AA5-86BFB6289C23}"/>
               </a:ext>
             </a:extLst>
           </p:cNvPr>
@@ -5050,7 +6078,7 @@
           <p:cNvPr id="4" name="">
             <a:extLst xmlns:a="http://schemas.openxmlformats.org/drawingml/2006/main">
               <a:ext uri="{FF2B5EF4-FFF2-40B4-BE49-F238E27FC236}">
-                <a16:creationId xmlns:a16="http://schemas.microsoft.com/office/drawing/2014/main" id="{C25D1AA9-B2CB-486E-8634-3697D4171258}"/>
+                <a16:creationId xmlns:a16="http://schemas.microsoft.com/office/drawing/2014/main" id="{ECF854C1-02B6-40CF-A838-B34C6B9E78E1}"/>
               </a:ext>
             </a:extLst>
           </p:cNvPr>
@@ -5100,7 +6128,7 @@
           <p:cNvPr id="5" name="">
             <a:extLst xmlns:a="http://schemas.openxmlformats.org/drawingml/2006/main">
               <a:ext uri="{FF2B5EF4-FFF2-40B4-BE49-F238E27FC236}">
-                <a16:creationId xmlns:a16="http://schemas.microsoft.com/office/drawing/2014/main" id="{ECE373FF-77E8-4CF8-921E-7E1773BBA5C1}"/>
+                <a16:creationId xmlns:a16="http://schemas.microsoft.com/office/drawing/2014/main" id="{6FB8D90A-5E73-4C36-A09B-981CBE5E1AAF}"/>
               </a:ext>
             </a:extLst>
           </p:cNvPr>
@@ -5150,7 +6178,7 @@
           <p:cNvPr id="6" name="">
             <a:extLst xmlns:a="http://schemas.openxmlformats.org/drawingml/2006/main">
               <a:ext uri="{FF2B5EF4-FFF2-40B4-BE49-F238E27FC236}">
-                <a16:creationId xmlns:a16="http://schemas.microsoft.com/office/drawing/2014/main" id="{8C954838-3E12-4E4E-BB19-5F4DF18745C1}"/>
+                <a16:creationId xmlns:a16="http://schemas.microsoft.com/office/drawing/2014/main" id="{DAB294D6-76A2-4C79-A965-5D44BA8D3065}"/>
               </a:ext>
             </a:extLst>
           </p:cNvPr>
@@ -5183,7 +6211,7 @@
           <p:cNvPr id="7" name="">
             <a:extLst xmlns:a="http://schemas.openxmlformats.org/drawingml/2006/main">
               <a:ext uri="{FF2B5EF4-FFF2-40B4-BE49-F238E27FC236}">
-                <a16:creationId xmlns:a16="http://schemas.microsoft.com/office/drawing/2014/main" id="{B3D7D39B-5E7D-467B-AA09-BA91317A74B7}"/>
+                <a16:creationId xmlns:a16="http://schemas.microsoft.com/office/drawing/2014/main" id="{5369A328-EA87-4BE8-BBFC-6FDF6E5D2BD8}"/>
               </a:ext>
             </a:extLst>
           </p:cNvPr>
@@ -5233,7 +6261,7 @@
           <p:cNvPr id="8" name="">
             <a:extLst xmlns:a="http://schemas.openxmlformats.org/drawingml/2006/main">
               <a:ext uri="{FF2B5EF4-FFF2-40B4-BE49-F238E27FC236}">
-                <a16:creationId xmlns:a16="http://schemas.microsoft.com/office/drawing/2014/main" id="{7846CB5B-D60B-48F0-B5CA-0A61BD5E9070}"/>
+                <a16:creationId xmlns:a16="http://schemas.microsoft.com/office/drawing/2014/main" id="{28AFEA81-0B2E-403D-86AE-F44426014184}"/>
               </a:ext>
             </a:extLst>
           </p:cNvPr>
@@ -5283,7 +6311,7 @@
           <p:cNvPr id="9" name="">
             <a:extLst xmlns:a="http://schemas.openxmlformats.org/drawingml/2006/main">
               <a:ext uri="{FF2B5EF4-FFF2-40B4-BE49-F238E27FC236}">
-                <a16:creationId xmlns:a16="http://schemas.microsoft.com/office/drawing/2014/main" id="{C4A04A65-481C-4D46-A8B7-0B6ECCCEB212}"/>
+                <a16:creationId xmlns:a16="http://schemas.microsoft.com/office/drawing/2014/main" id="{2F40D405-06AF-47FB-9CCF-AD32106B5654}"/>
               </a:ext>
             </a:extLst>
           </p:cNvPr>
@@ -5333,7 +6361,7 @@
           <p:cNvPr id="10" name="">
             <a:extLst xmlns:a="http://schemas.openxmlformats.org/drawingml/2006/main">
               <a:ext uri="{FF2B5EF4-FFF2-40B4-BE49-F238E27FC236}">
-                <a16:creationId xmlns:a16="http://schemas.microsoft.com/office/drawing/2014/main" id="{D3C88194-2F47-419C-9F0E-5D9EC2B8B003}"/>
+                <a16:creationId xmlns:a16="http://schemas.microsoft.com/office/drawing/2014/main" id="{30BC5F00-9518-4294-A976-67CF0867621F}"/>
               </a:ext>
             </a:extLst>
           </p:cNvPr>
@@ -5366,7 +6394,7 @@
           <p:cNvPr id="11" name="">
             <a:extLst xmlns:a="http://schemas.openxmlformats.org/drawingml/2006/main">
               <a:ext uri="{FF2B5EF4-FFF2-40B4-BE49-F238E27FC236}">
-                <a16:creationId xmlns:a16="http://schemas.microsoft.com/office/drawing/2014/main" id="{3B6AE1C9-2E9C-4848-8218-656B497E39DD}"/>
+                <a16:creationId xmlns:a16="http://schemas.microsoft.com/office/drawing/2014/main" id="{865F3A8B-FB58-4E0F-B8F5-B7CFD3DD9D1E}"/>
               </a:ext>
             </a:extLst>
           </p:cNvPr>
@@ -5416,7 +6444,7 @@
           <p:cNvPr id="12" name="">
             <a:extLst xmlns:a="http://schemas.openxmlformats.org/drawingml/2006/main">
               <a:ext uri="{FF2B5EF4-FFF2-40B4-BE49-F238E27FC236}">
-                <a16:creationId xmlns:a16="http://schemas.microsoft.com/office/drawing/2014/main" id="{7E9EDD87-A3B0-4E1F-A251-DF01E94C616D}"/>
+                <a16:creationId xmlns:a16="http://schemas.microsoft.com/office/drawing/2014/main" id="{A7166172-3235-4604-BF6A-E203FC79B81E}"/>
               </a:ext>
             </a:extLst>
           </p:cNvPr>
@@ -5466,7 +6494,7 @@
           <p:cNvPr id="13" name="">
             <a:extLst xmlns:a="http://schemas.openxmlformats.org/drawingml/2006/main">
               <a:ext uri="{FF2B5EF4-FFF2-40B4-BE49-F238E27FC236}">
-                <a16:creationId xmlns:a16="http://schemas.microsoft.com/office/drawing/2014/main" id="{B7CE3A18-0398-49CA-B265-9FFEB265627E}"/>
+                <a16:creationId xmlns:a16="http://schemas.microsoft.com/office/drawing/2014/main" id="{31156ECC-23B9-4966-AF60-04E130F7065E}"/>
               </a:ext>
             </a:extLst>
           </p:cNvPr>
@@ -5516,7 +6544,7 @@
           <p:cNvPr id="14" name="">
             <a:extLst xmlns:a="http://schemas.openxmlformats.org/drawingml/2006/main">
               <a:ext uri="{FF2B5EF4-FFF2-40B4-BE49-F238E27FC236}">
-                <a16:creationId xmlns:a16="http://schemas.microsoft.com/office/drawing/2014/main" id="{BA73CCC7-B3B5-4B4F-9FF2-959E7DC4CE83}"/>
+                <a16:creationId xmlns:a16="http://schemas.microsoft.com/office/drawing/2014/main" id="{44CD35A6-AB0D-4D82-8562-62362D7F9FE1}"/>
               </a:ext>
             </a:extLst>
           </p:cNvPr>
@@ -5549,7 +6577,7 @@
           <p:cNvPr id="15" name="">
             <a:extLst xmlns:a="http://schemas.openxmlformats.org/drawingml/2006/main">
               <a:ext uri="{FF2B5EF4-FFF2-40B4-BE49-F238E27FC236}">
-                <a16:creationId xmlns:a16="http://schemas.microsoft.com/office/drawing/2014/main" id="{99C25E0C-1EE4-4A7B-84F5-EB003C2E57B2}"/>
+                <a16:creationId xmlns:a16="http://schemas.microsoft.com/office/drawing/2014/main" id="{F0CB443F-CA6D-4549-B2EB-1597E1AFB95F}"/>
               </a:ext>
             </a:extLst>
           </p:cNvPr>
@@ -5599,7 +6627,7 @@
           <p:cNvPr id="16" name="">
             <a:extLst xmlns:a="http://schemas.openxmlformats.org/drawingml/2006/main">
               <a:ext uri="{FF2B5EF4-FFF2-40B4-BE49-F238E27FC236}">
-                <a16:creationId xmlns:a16="http://schemas.microsoft.com/office/drawing/2014/main" id="{7577EB75-107A-495A-9D87-5F6C438500AE}"/>
+                <a16:creationId xmlns:a16="http://schemas.microsoft.com/office/drawing/2014/main" id="{A2076233-1F76-4E06-9BFB-5B93961ED8CB}"/>
               </a:ext>
             </a:extLst>
           </p:cNvPr>
@@ -5649,7 +6677,7 @@
           <p:cNvPr id="17" name="">
             <a:extLst xmlns:a="http://schemas.openxmlformats.org/drawingml/2006/main">
               <a:ext uri="{FF2B5EF4-FFF2-40B4-BE49-F238E27FC236}">
-                <a16:creationId xmlns:a16="http://schemas.microsoft.com/office/drawing/2014/main" id="{B3703021-8A90-4702-898B-7CA410E96F1B}"/>
+                <a16:creationId xmlns:a16="http://schemas.microsoft.com/office/drawing/2014/main" id="{AFBEDEE7-B86E-4583-B7C5-5E41D2F75CB6}"/>
               </a:ext>
             </a:extLst>
           </p:cNvPr>
@@ -5699,7 +6727,7 @@
           <p:cNvPr id="18" name="">
             <a:extLst xmlns:a="http://schemas.openxmlformats.org/drawingml/2006/main">
               <a:ext uri="{FF2B5EF4-FFF2-40B4-BE49-F238E27FC236}">
-                <a16:creationId xmlns:a16="http://schemas.microsoft.com/office/drawing/2014/main" id="{E625436F-6CAA-4360-A24A-A4322BE5457F}"/>
+                <a16:creationId xmlns:a16="http://schemas.microsoft.com/office/drawing/2014/main" id="{EEF01E49-32E3-4BA1-94C0-53C28B34A88D}"/>
               </a:ext>
             </a:extLst>
           </p:cNvPr>
@@ -5749,7 +6777,7 @@
           <p:cNvPr id="19" name="">
             <a:extLst xmlns:a="http://schemas.openxmlformats.org/drawingml/2006/main">
               <a:ext uri="{FF2B5EF4-FFF2-40B4-BE49-F238E27FC236}">
-                <a16:creationId xmlns:a16="http://schemas.microsoft.com/office/drawing/2014/main" id="{9565CAE8-C0AB-47D9-B5E2-6954B21A70EC}"/>
+                <a16:creationId xmlns:a16="http://schemas.microsoft.com/office/drawing/2014/main" id="{7BBE2AE0-045F-497D-A038-F32CCF214D13}"/>
               </a:ext>
             </a:extLst>
           </p:cNvPr>
@@ -5799,7 +6827,7 @@
           <p:cNvPr id="20" name="">
             <a:extLst xmlns:a="http://schemas.openxmlformats.org/drawingml/2006/main">
               <a:ext uri="{FF2B5EF4-FFF2-40B4-BE49-F238E27FC236}">
-                <a16:creationId xmlns:a16="http://schemas.microsoft.com/office/drawing/2014/main" id="{65D27DA1-A29C-4ED9-BA9A-340765BF1521}"/>
+                <a16:creationId xmlns:a16="http://schemas.microsoft.com/office/drawing/2014/main" id="{22A9CCB3-739A-497D-A1CD-9A29EDE87241}"/>
               </a:ext>
             </a:extLst>
           </p:cNvPr>
@@ -5847,7 +6875,7 @@
     </p:spTree>
     <p:extLst>
       <p:ext uri="{BB962C8B-B14F-4D97-AF65-F5344CB8AC3E}">
-        <p14:creationId xmlns:p14="http://schemas.microsoft.com/office/powerpoint/2010/main" val="1708890390"/>
+        <p14:creationId xmlns:p14="http://schemas.microsoft.com/office/powerpoint/2010/main" val="357094856"/>
       </p:ext>
     </p:extLst>
   </p:cSld>
@@ -5878,7 +6906,7 @@
           <p:cNvPr id="1" name="">
             <a:extLst xmlns:a="http://schemas.openxmlformats.org/drawingml/2006/main">
               <a:ext uri="{FF2B5EF4-FFF2-40B4-BE49-F238E27FC236}">
-                <a16:creationId xmlns:a16="http://schemas.microsoft.com/office/drawing/2014/main" id="{B2DC1DF4-30A4-4D3D-AD09-D4991449FEB8}"/>
+                <a16:creationId xmlns:a16="http://schemas.microsoft.com/office/drawing/2014/main" id="{8F638E35-E80E-4D50-889A-7E726E18C0DF}"/>
               </a:ext>
             </a:extLst>
           </p:cNvPr>
@@ -5935,7 +6963,7 @@
         </p:xfrm>
         <a:graphic xmlns:a="http://schemas.openxmlformats.org/drawingml/2006/main">
           <a:graphicData uri="http://schemas.openxmlformats.org/drawingml/2006/chart">
-            <c:chart xmlns:r="http://schemas.openxmlformats.org/officeDocument/2006/relationships" xmlns:c="http://schemas.openxmlformats.org/drawingml/2006/chart" r:id="R84fa32e97ea84561"/>
+            <c:chart xmlns:r="http://schemas.openxmlformats.org/officeDocument/2006/relationships" xmlns:c="http://schemas.openxmlformats.org/drawingml/2006/chart" r:id="R7f0cbc25d1504232"/>
           </a:graphicData>
         </a:graphic>
       </p:graphicFrame>
@@ -5944,7 +6972,7 @@
           <p:cNvPr id="3" name="">
             <a:extLst xmlns:a="http://schemas.openxmlformats.org/drawingml/2006/main">
               <a:ext uri="{FF2B5EF4-FFF2-40B4-BE49-F238E27FC236}">
-                <a16:creationId xmlns:a16="http://schemas.microsoft.com/office/drawing/2014/main" id="{3D6D5947-3DC6-4001-8191-B595A4B5BDFE}"/>
+                <a16:creationId xmlns:a16="http://schemas.microsoft.com/office/drawing/2014/main" id="{4AF7C4AC-82FB-4E89-A59B-38730106C199}"/>
               </a:ext>
             </a:extLst>
           </p:cNvPr>
@@ -5977,7 +7005,7 @@
           <p:cNvPr id="4" name="">
             <a:extLst xmlns:a="http://schemas.openxmlformats.org/drawingml/2006/main">
               <a:ext uri="{FF2B5EF4-FFF2-40B4-BE49-F238E27FC236}">
-                <a16:creationId xmlns:a16="http://schemas.microsoft.com/office/drawing/2014/main" id="{C2E07B3E-80B1-4F7B-850E-9987D211C8BA}"/>
+                <a16:creationId xmlns:a16="http://schemas.microsoft.com/office/drawing/2014/main" id="{61099D53-B168-4410-930D-364922BC3B2B}"/>
               </a:ext>
             </a:extLst>
           </p:cNvPr>
@@ -6027,7 +7055,7 @@
           <p:cNvPr id="5" name="">
             <a:extLst xmlns:a="http://schemas.openxmlformats.org/drawingml/2006/main">
               <a:ext uri="{FF2B5EF4-FFF2-40B4-BE49-F238E27FC236}">
-                <a16:creationId xmlns:a16="http://schemas.microsoft.com/office/drawing/2014/main" id="{A20A8351-3040-4E17-88E6-01CC46C72FC6}"/>
+                <a16:creationId xmlns:a16="http://schemas.microsoft.com/office/drawing/2014/main" id="{431E9079-44BB-4983-BE22-678B020A5353}"/>
               </a:ext>
             </a:extLst>
           </p:cNvPr>
@@ -6077,7 +7105,7 @@
           <p:cNvPr id="6" name="">
             <a:extLst xmlns:a="http://schemas.openxmlformats.org/drawingml/2006/main">
               <a:ext uri="{FF2B5EF4-FFF2-40B4-BE49-F238E27FC236}">
-                <a16:creationId xmlns:a16="http://schemas.microsoft.com/office/drawing/2014/main" id="{61284129-7E70-4583-B519-E0799415F48A}"/>
+                <a16:creationId xmlns:a16="http://schemas.microsoft.com/office/drawing/2014/main" id="{71815C9E-23D1-411E-B3A1-5C428E85F9F0}"/>
               </a:ext>
             </a:extLst>
           </p:cNvPr>
@@ -6127,7 +7155,7 @@
           <p:cNvPr id="7" name="">
             <a:extLst xmlns:a="http://schemas.openxmlformats.org/drawingml/2006/main">
               <a:ext uri="{FF2B5EF4-FFF2-40B4-BE49-F238E27FC236}">
-                <a16:creationId xmlns:a16="http://schemas.microsoft.com/office/drawing/2014/main" id="{BAE2405B-E299-4542-B54C-3CE49F4524AD}"/>
+                <a16:creationId xmlns:a16="http://schemas.microsoft.com/office/drawing/2014/main" id="{DD6DF66F-CF8E-4552-B477-945C44B8E6A5}"/>
               </a:ext>
             </a:extLst>
           </p:cNvPr>
@@ -6177,7 +7205,7 @@
           <p:cNvPr id="8" name="">
             <a:extLst xmlns:a="http://schemas.openxmlformats.org/drawingml/2006/main">
               <a:ext uri="{FF2B5EF4-FFF2-40B4-BE49-F238E27FC236}">
-                <a16:creationId xmlns:a16="http://schemas.microsoft.com/office/drawing/2014/main" id="{8D28CE31-1919-47F9-85FC-15B662663D80}"/>
+                <a16:creationId xmlns:a16="http://schemas.microsoft.com/office/drawing/2014/main" id="{89D8B600-6C18-41DD-A0D6-B444A773C023}"/>
               </a:ext>
             </a:extLst>
           </p:cNvPr>
@@ -6227,7 +7255,7 @@
           <p:cNvPr id="9" name="">
             <a:extLst xmlns:a="http://schemas.openxmlformats.org/drawingml/2006/main">
               <a:ext uri="{FF2B5EF4-FFF2-40B4-BE49-F238E27FC236}">
-                <a16:creationId xmlns:a16="http://schemas.microsoft.com/office/drawing/2014/main" id="{6B946DE9-821F-4A37-B185-A84509D046E9}"/>
+                <a16:creationId xmlns:a16="http://schemas.microsoft.com/office/drawing/2014/main" id="{6FC1BA33-5AB4-4DB0-8DB6-9569E35F7054}"/>
               </a:ext>
             </a:extLst>
           </p:cNvPr>
@@ -6277,7 +7305,7 @@
           <p:cNvPr id="10" name="">
             <a:extLst xmlns:a="http://schemas.openxmlformats.org/drawingml/2006/main">
               <a:ext uri="{FF2B5EF4-FFF2-40B4-BE49-F238E27FC236}">
-                <a16:creationId xmlns:a16="http://schemas.microsoft.com/office/drawing/2014/main" id="{6CE03214-ABB5-478B-91E8-8461F7252A78}"/>
+                <a16:creationId xmlns:a16="http://schemas.microsoft.com/office/drawing/2014/main" id="{73C4E7AC-109A-4D2F-98D5-5319362D3BA0}"/>
               </a:ext>
             </a:extLst>
           </p:cNvPr>
@@ -6325,7 +7353,7 @@
     </p:spTree>
     <p:extLst>
       <p:ext uri="{BB962C8B-B14F-4D97-AF65-F5344CB8AC3E}">
-        <p14:creationId xmlns:p14="http://schemas.microsoft.com/office/powerpoint/2010/main" val="756539529"/>
+        <p14:creationId xmlns:p14="http://schemas.microsoft.com/office/powerpoint/2010/main" val="1317629649"/>
       </p:ext>
     </p:extLst>
   </p:cSld>
@@ -6356,7 +7384,7 @@
           <p:cNvPr id="1" name="">
             <a:extLst xmlns:a="http://schemas.openxmlformats.org/drawingml/2006/main">
               <a:ext uri="{FF2B5EF4-FFF2-40B4-BE49-F238E27FC236}">
-                <a16:creationId xmlns:a16="http://schemas.microsoft.com/office/drawing/2014/main" id="{619CE941-4664-4300-B6F3-074522D264CA}"/>
+                <a16:creationId xmlns:a16="http://schemas.microsoft.com/office/drawing/2014/main" id="{640BFC2B-C2BA-4DF6-AA30-D0F5A09A916E}"/>
               </a:ext>
             </a:extLst>
           </p:cNvPr>
@@ -6413,7 +7441,7 @@
         </p:xfrm>
         <a:graphic xmlns:a="http://schemas.openxmlformats.org/drawingml/2006/main">
           <a:graphicData uri="http://schemas.openxmlformats.org/drawingml/2006/chart">
-            <c:chart xmlns:r="http://schemas.openxmlformats.org/officeDocument/2006/relationships" xmlns:c="http://schemas.openxmlformats.org/drawingml/2006/chart" r:id="Rfd2f95af4eb64ca3"/>
+            <c:chart xmlns:r="http://schemas.openxmlformats.org/officeDocument/2006/relationships" xmlns:c="http://schemas.openxmlformats.org/drawingml/2006/chart" r:id="R2395702d50b2459c"/>
           </a:graphicData>
         </a:graphic>
       </p:graphicFrame>
@@ -6422,7 +7450,7 @@
           <p:cNvPr id="3" name="">
             <a:extLst xmlns:a="http://schemas.openxmlformats.org/drawingml/2006/main">
               <a:ext uri="{FF2B5EF4-FFF2-40B4-BE49-F238E27FC236}">
-                <a16:creationId xmlns:a16="http://schemas.microsoft.com/office/drawing/2014/main" id="{582D6115-BC8A-41DE-9C09-4544F16CD971}"/>
+                <a16:creationId xmlns:a16="http://schemas.microsoft.com/office/drawing/2014/main" id="{991B9FCD-A84B-45E5-8DA0-B9CCACEFA106}"/>
               </a:ext>
             </a:extLst>
           </p:cNvPr>
@@ -6455,7 +7483,7 @@
           <p:cNvPr id="4" name="">
             <a:extLst xmlns:a="http://schemas.openxmlformats.org/drawingml/2006/main">
               <a:ext uri="{FF2B5EF4-FFF2-40B4-BE49-F238E27FC236}">
-                <a16:creationId xmlns:a16="http://schemas.microsoft.com/office/drawing/2014/main" id="{895575A6-DFA7-4151-A786-7B088596FD5D}"/>
+                <a16:creationId xmlns:a16="http://schemas.microsoft.com/office/drawing/2014/main" id="{FD5F5EB7-3EB5-4806-9E0D-3AC08928F520}"/>
               </a:ext>
             </a:extLst>
           </p:cNvPr>
@@ -6505,7 +7533,7 @@
           <p:cNvPr id="5" name="">
             <a:extLst xmlns:a="http://schemas.openxmlformats.org/drawingml/2006/main">
               <a:ext uri="{FF2B5EF4-FFF2-40B4-BE49-F238E27FC236}">
-                <a16:creationId xmlns:a16="http://schemas.microsoft.com/office/drawing/2014/main" id="{DCBA21BD-651E-43AD-9E3F-77A6B1BE741E}"/>
+                <a16:creationId xmlns:a16="http://schemas.microsoft.com/office/drawing/2014/main" id="{9B83A563-AB71-4C41-B4D8-CFFDAEC02C4C}"/>
               </a:ext>
             </a:extLst>
           </p:cNvPr>
@@ -6555,7 +7583,7 @@
           <p:cNvPr id="6" name="">
             <a:extLst xmlns:a="http://schemas.openxmlformats.org/drawingml/2006/main">
               <a:ext uri="{FF2B5EF4-FFF2-40B4-BE49-F238E27FC236}">
-                <a16:creationId xmlns:a16="http://schemas.microsoft.com/office/drawing/2014/main" id="{70845C52-A7D5-43E0-BBA5-ACA5CDBA02A4}"/>
+                <a16:creationId xmlns:a16="http://schemas.microsoft.com/office/drawing/2014/main" id="{6849220B-F731-429E-B09D-1DA5930ACE77}"/>
               </a:ext>
             </a:extLst>
           </p:cNvPr>
@@ -6605,7 +7633,7 @@
           <p:cNvPr id="7" name="">
             <a:extLst xmlns:a="http://schemas.openxmlformats.org/drawingml/2006/main">
               <a:ext uri="{FF2B5EF4-FFF2-40B4-BE49-F238E27FC236}">
-                <a16:creationId xmlns:a16="http://schemas.microsoft.com/office/drawing/2014/main" id="{53945AC1-2028-4D39-A6D1-3AA5E3DF9A21}"/>
+                <a16:creationId xmlns:a16="http://schemas.microsoft.com/office/drawing/2014/main" id="{09067E55-8E2B-4A22-8E71-C858C57553C4}"/>
               </a:ext>
             </a:extLst>
           </p:cNvPr>
@@ -6655,7 +7683,7 @@
           <p:cNvPr id="8" name="">
             <a:extLst xmlns:a="http://schemas.openxmlformats.org/drawingml/2006/main">
               <a:ext uri="{FF2B5EF4-FFF2-40B4-BE49-F238E27FC236}">
-                <a16:creationId xmlns:a16="http://schemas.microsoft.com/office/drawing/2014/main" id="{042F3B9D-23E6-4630-AA41-DCBD482B8AE9}"/>
+                <a16:creationId xmlns:a16="http://schemas.microsoft.com/office/drawing/2014/main" id="{C29EDF2D-17A9-4A85-80F1-8C7D5D931AC9}"/>
               </a:ext>
             </a:extLst>
           </p:cNvPr>
@@ -6705,7 +7733,7 @@
           <p:cNvPr id="9" name="">
             <a:extLst xmlns:a="http://schemas.openxmlformats.org/drawingml/2006/main">
               <a:ext uri="{FF2B5EF4-FFF2-40B4-BE49-F238E27FC236}">
-                <a16:creationId xmlns:a16="http://schemas.microsoft.com/office/drawing/2014/main" id="{AEEF148B-66AB-4901-8DE3-B6D373C52ABA}"/>
+                <a16:creationId xmlns:a16="http://schemas.microsoft.com/office/drawing/2014/main" id="{F78F8648-A16E-439A-8957-E3230E823EAD}"/>
               </a:ext>
             </a:extLst>
           </p:cNvPr>
@@ -6755,7 +7783,7 @@
           <p:cNvPr id="10" name="">
             <a:extLst xmlns:a="http://schemas.openxmlformats.org/drawingml/2006/main">
               <a:ext uri="{FF2B5EF4-FFF2-40B4-BE49-F238E27FC236}">
-                <a16:creationId xmlns:a16="http://schemas.microsoft.com/office/drawing/2014/main" id="{1785DDEB-0433-4055-9170-71F1E37BC742}"/>
+                <a16:creationId xmlns:a16="http://schemas.microsoft.com/office/drawing/2014/main" id="{A802E952-BEF1-4535-8B04-6C12042057E7}"/>
               </a:ext>
             </a:extLst>
           </p:cNvPr>
@@ -6803,7 +7831,7 @@
     </p:spTree>
     <p:extLst>
       <p:ext uri="{BB962C8B-B14F-4D97-AF65-F5344CB8AC3E}">
-        <p14:creationId xmlns:p14="http://schemas.microsoft.com/office/powerpoint/2010/main" val="918989307"/>
+        <p14:creationId xmlns:p14="http://schemas.microsoft.com/office/powerpoint/2010/main" val="2019593286"/>
       </p:ext>
     </p:extLst>
   </p:cSld>
@@ -6834,7 +7862,7 @@
           <p:cNvPr id="1" name="">
             <a:extLst xmlns:a="http://schemas.openxmlformats.org/drawingml/2006/main">
               <a:ext uri="{FF2B5EF4-FFF2-40B4-BE49-F238E27FC236}">
-                <a16:creationId xmlns:a16="http://schemas.microsoft.com/office/drawing/2014/main" id="{55857A03-798C-4139-A090-477A1016C9DE}"/>
+                <a16:creationId xmlns:a16="http://schemas.microsoft.com/office/drawing/2014/main" id="{050418C4-945B-4892-9A12-2329434DA577}"/>
               </a:ext>
             </a:extLst>
           </p:cNvPr>
@@ -6884,7 +7912,7 @@
           <p:cNvPr id="2" name="">
             <a:extLst xmlns:a="http://schemas.openxmlformats.org/drawingml/2006/main">
               <a:ext uri="{FF2B5EF4-FFF2-40B4-BE49-F238E27FC236}">
-                <a16:creationId xmlns:a16="http://schemas.microsoft.com/office/drawing/2014/main" id="{BD4F7517-F636-42AF-9F9B-0E2E4159DEE8}"/>
+                <a16:creationId xmlns:a16="http://schemas.microsoft.com/office/drawing/2014/main" id="{BF0A014A-13DF-4AE8-9150-2EFEF03BDB86}"/>
               </a:ext>
             </a:extLst>
           </p:cNvPr>
@@ -6917,7 +7945,7 @@
           <p:cNvPr id="3" name="">
             <a:extLst xmlns:a="http://schemas.openxmlformats.org/drawingml/2006/main">
               <a:ext uri="{FF2B5EF4-FFF2-40B4-BE49-F238E27FC236}">
-                <a16:creationId xmlns:a16="http://schemas.microsoft.com/office/drawing/2014/main" id="{6A9A72C4-93A8-49DF-A241-F9AD4A609346}"/>
+                <a16:creationId xmlns:a16="http://schemas.microsoft.com/office/drawing/2014/main" id="{A85EB4B1-689E-4AC0-8509-01E47EFA12A0}"/>
               </a:ext>
             </a:extLst>
           </p:cNvPr>
@@ -6967,7 +7995,7 @@
           <p:cNvPr id="4" name="">
             <a:extLst xmlns:a="http://schemas.openxmlformats.org/drawingml/2006/main">
               <a:ext uri="{FF2B5EF4-FFF2-40B4-BE49-F238E27FC236}">
-                <a16:creationId xmlns:a16="http://schemas.microsoft.com/office/drawing/2014/main" id="{F68B5CC0-C124-485E-B223-BFFAD8B7E545}"/>
+                <a16:creationId xmlns:a16="http://schemas.microsoft.com/office/drawing/2014/main" id="{2821616D-98CB-4E75-9DE1-DE975507001A}"/>
               </a:ext>
             </a:extLst>
           </p:cNvPr>
@@ -7017,7 +8045,7 @@
           <p:cNvPr id="5" name="">
             <a:extLst xmlns:a="http://schemas.openxmlformats.org/drawingml/2006/main">
               <a:ext uri="{FF2B5EF4-FFF2-40B4-BE49-F238E27FC236}">
-                <a16:creationId xmlns:a16="http://schemas.microsoft.com/office/drawing/2014/main" id="{742F11D1-3A59-4781-A931-323B27EE8628}"/>
+                <a16:creationId xmlns:a16="http://schemas.microsoft.com/office/drawing/2014/main" id="{6761F55A-1231-4583-877A-607F161F1472}"/>
               </a:ext>
             </a:extLst>
           </p:cNvPr>
@@ -7067,7 +8095,7 @@
           <p:cNvPr id="6" name="">
             <a:extLst xmlns:a="http://schemas.openxmlformats.org/drawingml/2006/main">
               <a:ext uri="{FF2B5EF4-FFF2-40B4-BE49-F238E27FC236}">
-                <a16:creationId xmlns:a16="http://schemas.microsoft.com/office/drawing/2014/main" id="{F2072F00-A00E-4D30-89AA-1FB9CDAEF6F0}"/>
+                <a16:creationId xmlns:a16="http://schemas.microsoft.com/office/drawing/2014/main" id="{FDC41E85-18D5-470D-8E86-78983D45CC1E}"/>
               </a:ext>
             </a:extLst>
           </p:cNvPr>
@@ -7117,7 +8145,7 @@
           <p:cNvPr id="7" name="">
             <a:extLst xmlns:a="http://schemas.openxmlformats.org/drawingml/2006/main">
               <a:ext uri="{FF2B5EF4-FFF2-40B4-BE49-F238E27FC236}">
-                <a16:creationId xmlns:a16="http://schemas.microsoft.com/office/drawing/2014/main" id="{B97F5D22-0787-4576-B190-65AAEFAB75ED}"/>
+                <a16:creationId xmlns:a16="http://schemas.microsoft.com/office/drawing/2014/main" id="{3D758D48-DB77-40CC-A1D5-99FF82F24FF7}"/>
               </a:ext>
             </a:extLst>
           </p:cNvPr>
@@ -7167,7 +8195,7 @@
           <p:cNvPr id="8" name="">
             <a:extLst xmlns:a="http://schemas.openxmlformats.org/drawingml/2006/main">
               <a:ext uri="{FF2B5EF4-FFF2-40B4-BE49-F238E27FC236}">
-                <a16:creationId xmlns:a16="http://schemas.microsoft.com/office/drawing/2014/main" id="{60DB7D51-B0DB-481F-834D-4215E0992D0C}"/>
+                <a16:creationId xmlns:a16="http://schemas.microsoft.com/office/drawing/2014/main" id="{8BDA0AB4-C339-48A3-BA13-094FDB231854}"/>
               </a:ext>
             </a:extLst>
           </p:cNvPr>
@@ -7200,7 +8228,7 @@
           <p:cNvPr id="9" name="">
             <a:extLst xmlns:a="http://schemas.openxmlformats.org/drawingml/2006/main">
               <a:ext uri="{FF2B5EF4-FFF2-40B4-BE49-F238E27FC236}">
-                <a16:creationId xmlns:a16="http://schemas.microsoft.com/office/drawing/2014/main" id="{7E9453F8-53C9-428A-9504-9FA5544E92AE}"/>
+                <a16:creationId xmlns:a16="http://schemas.microsoft.com/office/drawing/2014/main" id="{422D031F-A717-4508-9B69-DA22ABDA9E17}"/>
               </a:ext>
             </a:extLst>
           </p:cNvPr>
@@ -7250,7 +8278,7 @@
           <p:cNvPr id="10" name="">
             <a:extLst xmlns:a="http://schemas.openxmlformats.org/drawingml/2006/main">
               <a:ext uri="{FF2B5EF4-FFF2-40B4-BE49-F238E27FC236}">
-                <a16:creationId xmlns:a16="http://schemas.microsoft.com/office/drawing/2014/main" id="{8354FC32-5F74-4E37-807F-402CC09D01E4}"/>
+                <a16:creationId xmlns:a16="http://schemas.microsoft.com/office/drawing/2014/main" id="{D78593B3-F409-490C-89D8-B99F28468ECB}"/>
               </a:ext>
             </a:extLst>
           </p:cNvPr>
@@ -7300,7 +8328,7 @@
           <p:cNvPr id="11" name="">
             <a:extLst xmlns:a="http://schemas.openxmlformats.org/drawingml/2006/main">
               <a:ext uri="{FF2B5EF4-FFF2-40B4-BE49-F238E27FC236}">
-                <a16:creationId xmlns:a16="http://schemas.microsoft.com/office/drawing/2014/main" id="{2CE373DB-A5CB-4275-949C-CD1839B740E5}"/>
+                <a16:creationId xmlns:a16="http://schemas.microsoft.com/office/drawing/2014/main" id="{73E2F8DF-1406-404D-AD3C-3656ECEEA945}"/>
               </a:ext>
             </a:extLst>
           </p:cNvPr>
@@ -7350,7 +8378,7 @@
           <p:cNvPr id="12" name="">
             <a:extLst xmlns:a="http://schemas.openxmlformats.org/drawingml/2006/main">
               <a:ext uri="{FF2B5EF4-FFF2-40B4-BE49-F238E27FC236}">
-                <a16:creationId xmlns:a16="http://schemas.microsoft.com/office/drawing/2014/main" id="{0D4FD539-9AFE-4EBF-B225-3E097226AEDF}"/>
+                <a16:creationId xmlns:a16="http://schemas.microsoft.com/office/drawing/2014/main" id="{71F00AE4-E27E-43FD-9EBF-5D0B19995128}"/>
               </a:ext>
             </a:extLst>
           </p:cNvPr>
@@ -7400,19 +8428,19 @@
           <p:cNvPr id="13" name="">
             <a:extLst xmlns:a="http://schemas.openxmlformats.org/drawingml/2006/main">
               <a:ext uri="{FF2B5EF4-FFF2-40B4-BE49-F238E27FC236}">
-                <a16:creationId xmlns:a16="http://schemas.microsoft.com/office/drawing/2014/main" id="{40276B71-4A6B-4F7B-A7F4-46A05CC744EB}"/>
-              </a:ext>
-            </a:extLst>
-          </p:cNvPr>
-          <p:cNvSpPr>
-            <a:spLocks xmlns:a="http://schemas.openxmlformats.org/drawingml/2006/main" noGrp="1"/>
-          </p:cNvSpPr>
-          <p:nvPr/>
-        </p:nvSpPr>
-        <p:spPr>
-          <a:xfrm xmlns:a="http://schemas.openxmlformats.org/drawingml/2006/main">
-            <a:off x="1752600" y="5638800"/>
-            <a:ext cx="8667750" cy="285750"/>
+                <a16:creationId xmlns:a16="http://schemas.microsoft.com/office/drawing/2014/main" id="{8E69C519-567E-42B5-AACC-4E836460384F}"/>
+              </a:ext>
+            </a:extLst>
+          </p:cNvPr>
+          <p:cNvSpPr>
+            <a:spLocks xmlns:a="http://schemas.openxmlformats.org/drawingml/2006/main" noGrp="1"/>
+          </p:cNvSpPr>
+          <p:nvPr/>
+        </p:nvSpPr>
+        <p:spPr>
+          <a:xfrm xmlns:a="http://schemas.openxmlformats.org/drawingml/2006/main">
+            <a:off x="1257300" y="5638800"/>
+            <a:ext cx="9715500" cy="285750"/>
           </a:xfrm>
           <a:prstGeom xmlns:a="http://schemas.openxmlformats.org/drawingml/2006/main" prst="rect">
             <a:avLst/>
@@ -7428,19 +8456,19 @@
           <a:lstStyle xmlns:a="http://schemas.openxmlformats.org/drawingml/2006/main"/>
           <a:p xmlns:a="http://schemas.openxmlformats.org/drawingml/2006/main">
             <a:pPr algn="ctr">
-              <a:defRPr sz="1650" b="1">
+              <a:defRPr sz="1350" b="1">
                 <a:solidFill>
                   <a:srgbClr val="B23A48"/>
                 </a:solidFill>
               </a:defRPr>
             </a:pPr>
             <a:r>
-              <a:rPr sz="1650" b="1">
+              <a:rPr sz="1350" b="1">
                 <a:solidFill>
                   <a:srgbClr val="B23A48"/>
                 </a:solidFill>
               </a:rPr>
-              <a:t>Local survey link: http://localhost:8765/survey</a:t>
+              <a:t>Public survey: https://taste-empire-come-advancement.trycloudflare.com/survey</a:t>
             </a:r>
           </a:p>
         </p:txBody>
@@ -7450,7 +8478,7 @@
           <p:cNvPr id="14" name="">
             <a:extLst xmlns:a="http://schemas.openxmlformats.org/drawingml/2006/main">
               <a:ext uri="{FF2B5EF4-FFF2-40B4-BE49-F238E27FC236}">
-                <a16:creationId xmlns:a16="http://schemas.microsoft.com/office/drawing/2014/main" id="{AE4B3661-9892-4AF8-B05C-CE78A3F64932}"/>
+                <a16:creationId xmlns:a16="http://schemas.microsoft.com/office/drawing/2014/main" id="{B937A76D-F4A7-4E8A-AA52-56114B9F2725}"/>
               </a:ext>
             </a:extLst>
           </p:cNvPr>
@@ -7500,7 +8528,7 @@
           <p:cNvPr id="15" name="">
             <a:extLst xmlns:a="http://schemas.openxmlformats.org/drawingml/2006/main">
               <a:ext uri="{FF2B5EF4-FFF2-40B4-BE49-F238E27FC236}">
-                <a16:creationId xmlns:a16="http://schemas.microsoft.com/office/drawing/2014/main" id="{17FB7458-B7B5-49AB-908E-9E341C7B764B}"/>
+                <a16:creationId xmlns:a16="http://schemas.microsoft.com/office/drawing/2014/main" id="{69F7614F-273A-4A4B-BC18-C8B5C96B3993}"/>
               </a:ext>
             </a:extLst>
           </p:cNvPr>
@@ -7548,7 +8576,7 @@
     </p:spTree>
     <p:extLst>
       <p:ext uri="{BB962C8B-B14F-4D97-AF65-F5344CB8AC3E}">
-        <p14:creationId xmlns:p14="http://schemas.microsoft.com/office/powerpoint/2010/main" val="1182157242"/>
+        <p14:creationId xmlns:p14="http://schemas.microsoft.com/office/powerpoint/2010/main" val="1842636213"/>
       </p:ext>
     </p:extLst>
   </p:cSld>
@@ -7579,7 +8607,7 @@
           <p:cNvPr id="1" name="">
             <a:extLst xmlns:a="http://schemas.openxmlformats.org/drawingml/2006/main">
               <a:ext uri="{FF2B5EF4-FFF2-40B4-BE49-F238E27FC236}">
-                <a16:creationId xmlns:a16="http://schemas.microsoft.com/office/drawing/2014/main" id="{95A3D436-B040-4CC9-BBE0-45AE7C5731EF}"/>
+                <a16:creationId xmlns:a16="http://schemas.microsoft.com/office/drawing/2014/main" id="{90D529C1-8165-48D1-A62F-5337B17D566C}"/>
               </a:ext>
             </a:extLst>
           </p:cNvPr>
@@ -7629,7 +8657,7 @@
           <p:cNvPr id="2" name="">
             <a:extLst xmlns:a="http://schemas.openxmlformats.org/drawingml/2006/main">
               <a:ext uri="{FF2B5EF4-FFF2-40B4-BE49-F238E27FC236}">
-                <a16:creationId xmlns:a16="http://schemas.microsoft.com/office/drawing/2014/main" id="{C4CD311D-6469-4BD3-AD2F-1D18D4C72957}"/>
+                <a16:creationId xmlns:a16="http://schemas.microsoft.com/office/drawing/2014/main" id="{C5276217-5F25-43CB-9E41-7B4F4EF173CF}"/>
               </a:ext>
             </a:extLst>
           </p:cNvPr>
@@ -7662,7 +8690,7 @@
           <p:cNvPr id="3" name="">
             <a:extLst xmlns:a="http://schemas.openxmlformats.org/drawingml/2006/main">
               <a:ext uri="{FF2B5EF4-FFF2-40B4-BE49-F238E27FC236}">
-                <a16:creationId xmlns:a16="http://schemas.microsoft.com/office/drawing/2014/main" id="{B8EE0B4A-44B9-480E-9414-8998884842D5}"/>
+                <a16:creationId xmlns:a16="http://schemas.microsoft.com/office/drawing/2014/main" id="{5EEE4A9C-67A9-4D6B-9356-437F995DBB9D}"/>
               </a:ext>
             </a:extLst>
           </p:cNvPr>
@@ -7712,7 +8740,7 @@
           <p:cNvPr id="4" name="">
             <a:extLst xmlns:a="http://schemas.openxmlformats.org/drawingml/2006/main">
               <a:ext uri="{FF2B5EF4-FFF2-40B4-BE49-F238E27FC236}">
-                <a16:creationId xmlns:a16="http://schemas.microsoft.com/office/drawing/2014/main" id="{69669204-D604-4167-99C3-145B8E465870}"/>
+                <a16:creationId xmlns:a16="http://schemas.microsoft.com/office/drawing/2014/main" id="{6367642E-2527-4C30-869E-B022B9820EA3}"/>
               </a:ext>
             </a:extLst>
           </p:cNvPr>
@@ -7762,7 +8790,7 @@
           <p:cNvPr id="5" name="">
             <a:extLst xmlns:a="http://schemas.openxmlformats.org/drawingml/2006/main">
               <a:ext uri="{FF2B5EF4-FFF2-40B4-BE49-F238E27FC236}">
-                <a16:creationId xmlns:a16="http://schemas.microsoft.com/office/drawing/2014/main" id="{E798FD60-719A-4ECB-9312-35471E9A1AAF}"/>
+                <a16:creationId xmlns:a16="http://schemas.microsoft.com/office/drawing/2014/main" id="{89A42035-6793-42DA-BD9B-EE1780BAD409}"/>
               </a:ext>
             </a:extLst>
           </p:cNvPr>
@@ -7795,7 +8823,7 @@
           <p:cNvPr id="6" name="">
             <a:extLst xmlns:a="http://schemas.openxmlformats.org/drawingml/2006/main">
               <a:ext uri="{FF2B5EF4-FFF2-40B4-BE49-F238E27FC236}">
-                <a16:creationId xmlns:a16="http://schemas.microsoft.com/office/drawing/2014/main" id="{3D4D9362-F55E-42AA-A5CF-9346B5A74F69}"/>
+                <a16:creationId xmlns:a16="http://schemas.microsoft.com/office/drawing/2014/main" id="{B934C94D-1844-4541-AFDA-9EFAD6D1128F}"/>
               </a:ext>
             </a:extLst>
           </p:cNvPr>
@@ -7845,7 +8873,7 @@
           <p:cNvPr id="7" name="">
             <a:extLst xmlns:a="http://schemas.openxmlformats.org/drawingml/2006/main">
               <a:ext uri="{FF2B5EF4-FFF2-40B4-BE49-F238E27FC236}">
-                <a16:creationId xmlns:a16="http://schemas.microsoft.com/office/drawing/2014/main" id="{D14762AE-BF89-40BC-8277-D03577B8E974}"/>
+                <a16:creationId xmlns:a16="http://schemas.microsoft.com/office/drawing/2014/main" id="{E71D5D5E-494A-481B-A555-AF618CB995E1}"/>
               </a:ext>
             </a:extLst>
           </p:cNvPr>
@@ -7895,7 +8923,7 @@
           <p:cNvPr id="8" name="">
             <a:extLst xmlns:a="http://schemas.openxmlformats.org/drawingml/2006/main">
               <a:ext uri="{FF2B5EF4-FFF2-40B4-BE49-F238E27FC236}">
-                <a16:creationId xmlns:a16="http://schemas.microsoft.com/office/drawing/2014/main" id="{16B2AF14-0057-4880-8392-3C1E30547C8C}"/>
+                <a16:creationId xmlns:a16="http://schemas.microsoft.com/office/drawing/2014/main" id="{CA0DC7D7-B950-401A-B87D-12B2BB41C3F1}"/>
               </a:ext>
             </a:extLst>
           </p:cNvPr>
@@ -7928,7 +8956,7 @@
           <p:cNvPr id="9" name="">
             <a:extLst xmlns:a="http://schemas.openxmlformats.org/drawingml/2006/main">
               <a:ext uri="{FF2B5EF4-FFF2-40B4-BE49-F238E27FC236}">
-                <a16:creationId xmlns:a16="http://schemas.microsoft.com/office/drawing/2014/main" id="{ABCB8D01-39A5-49F1-A056-B2BCC4B4C880}"/>
+                <a16:creationId xmlns:a16="http://schemas.microsoft.com/office/drawing/2014/main" id="{A90F8AD3-1A00-43D2-862F-CE294CE75703}"/>
               </a:ext>
             </a:extLst>
           </p:cNvPr>
@@ -7978,7 +9006,7 @@
           <p:cNvPr id="10" name="">
             <a:extLst xmlns:a="http://schemas.openxmlformats.org/drawingml/2006/main">
               <a:ext uri="{FF2B5EF4-FFF2-40B4-BE49-F238E27FC236}">
-                <a16:creationId xmlns:a16="http://schemas.microsoft.com/office/drawing/2014/main" id="{E3404422-C0BB-4A40-A47D-315E370137A2}"/>
+                <a16:creationId xmlns:a16="http://schemas.microsoft.com/office/drawing/2014/main" id="{95AD1BEA-629E-4B73-917F-C58A458967ED}"/>
               </a:ext>
             </a:extLst>
           </p:cNvPr>
@@ -8028,7 +9056,7 @@
           <p:cNvPr id="11" name="">
             <a:extLst xmlns:a="http://schemas.openxmlformats.org/drawingml/2006/main">
               <a:ext uri="{FF2B5EF4-FFF2-40B4-BE49-F238E27FC236}">
-                <a16:creationId xmlns:a16="http://schemas.microsoft.com/office/drawing/2014/main" id="{7BB09503-F2AE-4E6F-AD13-60214D0F69EA}"/>
+                <a16:creationId xmlns:a16="http://schemas.microsoft.com/office/drawing/2014/main" id="{963ECFF2-E508-4BB3-A8E2-88332963B3A7}"/>
               </a:ext>
             </a:extLst>
           </p:cNvPr>
@@ -8061,7 +9089,7 @@
           <p:cNvPr id="12" name="">
             <a:extLst xmlns:a="http://schemas.openxmlformats.org/drawingml/2006/main">
               <a:ext uri="{FF2B5EF4-FFF2-40B4-BE49-F238E27FC236}">
-                <a16:creationId xmlns:a16="http://schemas.microsoft.com/office/drawing/2014/main" id="{42F838B6-EE36-4BD7-ABA6-1F397B9711A1}"/>
+                <a16:creationId xmlns:a16="http://schemas.microsoft.com/office/drawing/2014/main" id="{56632557-0CEF-4999-BC31-1B5D8A96A057}"/>
               </a:ext>
             </a:extLst>
           </p:cNvPr>
@@ -8111,7 +9139,7 @@
           <p:cNvPr id="13" name="">
             <a:extLst xmlns:a="http://schemas.openxmlformats.org/drawingml/2006/main">
               <a:ext uri="{FF2B5EF4-FFF2-40B4-BE49-F238E27FC236}">
-                <a16:creationId xmlns:a16="http://schemas.microsoft.com/office/drawing/2014/main" id="{EED1A533-EAAF-41BF-9D3D-BA07BDD586B3}"/>
+                <a16:creationId xmlns:a16="http://schemas.microsoft.com/office/drawing/2014/main" id="{5E7A70D3-E881-4E4D-8B87-3EC29A301EB1}"/>
               </a:ext>
             </a:extLst>
           </p:cNvPr>
@@ -8161,7 +9189,7 @@
           <p:cNvPr id="14" name="">
             <a:extLst xmlns:a="http://schemas.openxmlformats.org/drawingml/2006/main">
               <a:ext uri="{FF2B5EF4-FFF2-40B4-BE49-F238E27FC236}">
-                <a16:creationId xmlns:a16="http://schemas.microsoft.com/office/drawing/2014/main" id="{87972953-9358-4207-905D-C767B32D3C6F}"/>
+                <a16:creationId xmlns:a16="http://schemas.microsoft.com/office/drawing/2014/main" id="{26A3124C-143F-4913-94BE-7640BE75CAC3}"/>
               </a:ext>
             </a:extLst>
           </p:cNvPr>
@@ -8211,7 +9239,7 @@
           <p:cNvPr id="15" name="">
             <a:extLst xmlns:a="http://schemas.openxmlformats.org/drawingml/2006/main">
               <a:ext uri="{FF2B5EF4-FFF2-40B4-BE49-F238E27FC236}">
-                <a16:creationId xmlns:a16="http://schemas.microsoft.com/office/drawing/2014/main" id="{6A0E43DD-481F-4B1E-A4C3-88BBFAB9BC9E}"/>
+                <a16:creationId xmlns:a16="http://schemas.microsoft.com/office/drawing/2014/main" id="{5DDADFD5-93C1-4AF3-B8E2-41A5DBE40B1F}"/>
               </a:ext>
             </a:extLst>
           </p:cNvPr>
@@ -8261,7 +9289,7 @@
           <p:cNvPr id="16" name="">
             <a:extLst xmlns:a="http://schemas.openxmlformats.org/drawingml/2006/main">
               <a:ext uri="{FF2B5EF4-FFF2-40B4-BE49-F238E27FC236}">
-                <a16:creationId xmlns:a16="http://schemas.microsoft.com/office/drawing/2014/main" id="{AF21F112-BC50-45A9-B687-459B0D84C318}"/>
+                <a16:creationId xmlns:a16="http://schemas.microsoft.com/office/drawing/2014/main" id="{BF371941-D5C4-4CA5-983F-6BA32D77DF11}"/>
               </a:ext>
             </a:extLst>
           </p:cNvPr>
@@ -8309,7 +9337,7 @@
     </p:spTree>
     <p:extLst>
       <p:ext uri="{BB962C8B-B14F-4D97-AF65-F5344CB8AC3E}">
-        <p14:creationId xmlns:p14="http://schemas.microsoft.com/office/powerpoint/2010/main" val="723528630"/>
+        <p14:creationId xmlns:p14="http://schemas.microsoft.com/office/powerpoint/2010/main" val="583230830"/>
       </p:ext>
     </p:extLst>
   </p:cSld>
@@ -8340,7 +9368,7 @@
           <p:cNvPr id="1" name="">
             <a:extLst xmlns:a="http://schemas.openxmlformats.org/drawingml/2006/main">
               <a:ext uri="{FF2B5EF4-FFF2-40B4-BE49-F238E27FC236}">
-                <a16:creationId xmlns:a16="http://schemas.microsoft.com/office/drawing/2014/main" id="{1259F1A5-B00B-4444-975D-0F1C580908B9}"/>
+                <a16:creationId xmlns:a16="http://schemas.microsoft.com/office/drawing/2014/main" id="{9E372F7F-838D-4A35-9F2B-EA0C7FE065BA}"/>
               </a:ext>
             </a:extLst>
           </p:cNvPr>
@@ -8352,35 +9380,35 @@
         <p:spPr>
           <a:xfrm xmlns:a="http://schemas.openxmlformats.org/drawingml/2006/main">
             <a:off x="685800" y="514350"/>
-            <a:ext cx="9239250" cy="723900"/>
-          </a:xfrm>
-          <a:prstGeom xmlns:a="http://schemas.openxmlformats.org/drawingml/2006/main" prst="rect">
-            <a:avLst/>
-          </a:prstGeom>
-          <a:noFill xmlns:a="http://schemas.openxmlformats.org/drawingml/2006/main"/>
-          <a:ln xmlns:a="http://schemas.openxmlformats.org/drawingml/2006/main" w="0">
-            <a:noFill/>
-            <a:prstDash val="solid"/>
-          </a:ln>
-        </p:spPr>
-        <p:txBody>
-          <a:bodyPr xmlns:a="http://schemas.openxmlformats.org/drawingml/2006/main"/>
-          <a:lstStyle xmlns:a="http://schemas.openxmlformats.org/drawingml/2006/main"/>
-          <a:p xmlns:a="http://schemas.openxmlformats.org/drawingml/2006/main">
-            <a:pPr algn="l">
-              <a:defRPr sz="3150" b="1">
+            <a:ext cx="9906000" cy="723900"/>
+          </a:xfrm>
+          <a:prstGeom xmlns:a="http://schemas.openxmlformats.org/drawingml/2006/main" prst="rect">
+            <a:avLst/>
+          </a:prstGeom>
+          <a:noFill xmlns:a="http://schemas.openxmlformats.org/drawingml/2006/main"/>
+          <a:ln xmlns:a="http://schemas.openxmlformats.org/drawingml/2006/main" w="0">
+            <a:noFill/>
+            <a:prstDash val="solid"/>
+          </a:ln>
+        </p:spPr>
+        <p:txBody>
+          <a:bodyPr xmlns:a="http://schemas.openxmlformats.org/drawingml/2006/main"/>
+          <a:lstStyle xmlns:a="http://schemas.openxmlformats.org/drawingml/2006/main"/>
+          <a:p xmlns:a="http://schemas.openxmlformats.org/drawingml/2006/main">
+            <a:pPr algn="l">
+              <a:defRPr sz="3000" b="1">
                 <a:solidFill>
                   <a:srgbClr val="1C2430"/>
                 </a:solidFill>
               </a:defRPr>
             </a:pPr>
             <a:r>
-              <a:rPr sz="3150" b="1">
+              <a:rPr sz="3000" b="1">
                 <a:solidFill>
                   <a:srgbClr val="1C2430"/>
                 </a:solidFill>
               </a:rPr>
-              <a:t>The strongest next step is real sampling, not more decoration.</a:t>
+              <a:t>The research package can now move from local demo to public collection.</a:t>
             </a:r>
           </a:p>
         </p:txBody>
@@ -8390,19 +9418,19 @@
           <p:cNvPr id="2" name="">
             <a:extLst xmlns:a="http://schemas.openxmlformats.org/drawingml/2006/main">
               <a:ext uri="{FF2B5EF4-FFF2-40B4-BE49-F238E27FC236}">
-                <a16:creationId xmlns:a16="http://schemas.microsoft.com/office/drawing/2014/main" id="{742E720C-E17E-4782-956F-174BF1310CB2}"/>
-              </a:ext>
-            </a:extLst>
-          </p:cNvPr>
-          <p:cNvSpPr>
-            <a:spLocks xmlns:a="http://schemas.openxmlformats.org/drawingml/2006/main" noGrp="1"/>
-          </p:cNvSpPr>
-          <p:nvPr/>
-        </p:nvSpPr>
-        <p:spPr>
-          <a:xfrm xmlns:a="http://schemas.openxmlformats.org/drawingml/2006/main">
-            <a:off x="857250" y="1695450"/>
-            <a:ext cx="4476750" cy="1257300"/>
+                <a16:creationId xmlns:a16="http://schemas.microsoft.com/office/drawing/2014/main" id="{029A3300-3248-4842-A081-8E88DE44BB1C}"/>
+              </a:ext>
+            </a:extLst>
+          </p:cNvPr>
+          <p:cNvSpPr>
+            <a:spLocks xmlns:a="http://schemas.openxmlformats.org/drawingml/2006/main" noGrp="1"/>
+          </p:cNvSpPr>
+          <p:nvPr/>
+        </p:nvSpPr>
+        <p:spPr>
+          <a:xfrm xmlns:a="http://schemas.openxmlformats.org/drawingml/2006/main">
+            <a:off x="685800" y="1504950"/>
+            <a:ext cx="4953000" cy="3714750"/>
           </a:xfrm>
           <a:prstGeom xmlns:a="http://schemas.openxmlformats.org/drawingml/2006/main" prst="rect">
             <a:avLst/>
@@ -8423,147 +9451,147 @@
           <p:cNvPr id="3" name="">
             <a:extLst xmlns:a="http://schemas.openxmlformats.org/drawingml/2006/main">
               <a:ext uri="{FF2B5EF4-FFF2-40B4-BE49-F238E27FC236}">
-                <a16:creationId xmlns:a16="http://schemas.microsoft.com/office/drawing/2014/main" id="{9DEA1DD7-BE18-47E1-A687-E3E57EB8CB70}"/>
-              </a:ext>
-            </a:extLst>
-          </p:cNvPr>
-          <p:cNvSpPr>
-            <a:spLocks xmlns:a="http://schemas.openxmlformats.org/drawingml/2006/main" noGrp="1"/>
-          </p:cNvSpPr>
-          <p:nvPr/>
-        </p:nvSpPr>
-        <p:spPr>
-          <a:xfrm xmlns:a="http://schemas.openxmlformats.org/drawingml/2006/main">
-            <a:off x="1085850" y="1943100"/>
-            <a:ext cx="552450" cy="495300"/>
-          </a:xfrm>
-          <a:prstGeom xmlns:a="http://schemas.openxmlformats.org/drawingml/2006/main" prst="rect">
-            <a:avLst/>
-          </a:prstGeom>
-          <a:noFill xmlns:a="http://schemas.openxmlformats.org/drawingml/2006/main"/>
-          <a:ln xmlns:a="http://schemas.openxmlformats.org/drawingml/2006/main" w="0">
-            <a:noFill/>
-            <a:prstDash val="solid"/>
-          </a:ln>
-        </p:spPr>
-        <p:txBody>
-          <a:bodyPr xmlns:a="http://schemas.openxmlformats.org/drawingml/2006/main"/>
-          <a:lstStyle xmlns:a="http://schemas.openxmlformats.org/drawingml/2006/main"/>
-          <a:p xmlns:a="http://schemas.openxmlformats.org/drawingml/2006/main">
-            <a:pPr algn="l">
-              <a:defRPr sz="3300" b="1">
+                <a16:creationId xmlns:a16="http://schemas.microsoft.com/office/drawing/2014/main" id="{82685DA8-E57B-4039-9ED1-858106C49E85}"/>
+              </a:ext>
+            </a:extLst>
+          </p:cNvPr>
+          <p:cNvSpPr>
+            <a:spLocks xmlns:a="http://schemas.openxmlformats.org/drawingml/2006/main" noGrp="1"/>
+          </p:cNvSpPr>
+          <p:nvPr/>
+        </p:nvSpPr>
+        <p:spPr>
+          <a:xfrm xmlns:a="http://schemas.openxmlformats.org/drawingml/2006/main">
+            <a:off x="990600" y="1790700"/>
+            <a:ext cx="4095750" cy="323850"/>
+          </a:xfrm>
+          <a:prstGeom xmlns:a="http://schemas.openxmlformats.org/drawingml/2006/main" prst="rect">
+            <a:avLst/>
+          </a:prstGeom>
+          <a:noFill xmlns:a="http://schemas.openxmlformats.org/drawingml/2006/main"/>
+          <a:ln xmlns:a="http://schemas.openxmlformats.org/drawingml/2006/main" w="0">
+            <a:noFill/>
+            <a:prstDash val="solid"/>
+          </a:ln>
+        </p:spPr>
+        <p:txBody>
+          <a:bodyPr xmlns:a="http://schemas.openxmlformats.org/drawingml/2006/main"/>
+          <a:lstStyle xmlns:a="http://schemas.openxmlformats.org/drawingml/2006/main"/>
+          <a:p xmlns:a="http://schemas.openxmlformats.org/drawingml/2006/main">
+            <a:pPr algn="l">
+              <a:defRPr sz="2100" b="1">
+                <a:solidFill>
+                  <a:srgbClr val="456990"/>
+                </a:solidFill>
+              </a:defRPr>
+            </a:pPr>
+            <a:r>
+              <a:rPr sz="2100" b="1">
+                <a:solidFill>
+                  <a:srgbClr val="456990"/>
+                </a:solidFill>
+              </a:rPr>
+              <a:t>Public access layer</a:t>
+            </a:r>
+          </a:p>
+        </p:txBody>
+      </p:sp>
+      <p:sp>
+        <p:nvSpPr>
+          <p:cNvPr id="4" name="">
+            <a:extLst xmlns:a="http://schemas.openxmlformats.org/drawingml/2006/main">
+              <a:ext uri="{FF2B5EF4-FFF2-40B4-BE49-F238E27FC236}">
+                <a16:creationId xmlns:a16="http://schemas.microsoft.com/office/drawing/2014/main" id="{1769A40E-CEFF-49A3-A7DD-1190FDBE9094}"/>
+              </a:ext>
+            </a:extLst>
+          </p:cNvPr>
+          <p:cNvSpPr>
+            <a:spLocks xmlns:a="http://schemas.openxmlformats.org/drawingml/2006/main" noGrp="1"/>
+          </p:cNvSpPr>
+          <p:nvPr/>
+        </p:nvSpPr>
+        <p:spPr>
+          <a:xfrm xmlns:a="http://schemas.openxmlformats.org/drawingml/2006/main">
+            <a:off x="1009650" y="2362200"/>
+            <a:ext cx="1428750" cy="228600"/>
+          </a:xfrm>
+          <a:prstGeom xmlns:a="http://schemas.openxmlformats.org/drawingml/2006/main" prst="rect">
+            <a:avLst/>
+          </a:prstGeom>
+          <a:noFill xmlns:a="http://schemas.openxmlformats.org/drawingml/2006/main"/>
+          <a:ln xmlns:a="http://schemas.openxmlformats.org/drawingml/2006/main" w="0">
+            <a:noFill/>
+            <a:prstDash val="solid"/>
+          </a:ln>
+        </p:spPr>
+        <p:txBody>
+          <a:bodyPr xmlns:a="http://schemas.openxmlformats.org/drawingml/2006/main"/>
+          <a:lstStyle xmlns:a="http://schemas.openxmlformats.org/drawingml/2006/main"/>
+          <a:p xmlns:a="http://schemas.openxmlformats.org/drawingml/2006/main">
+            <a:pPr algn="l">
+              <a:defRPr sz="1425" b="1">
                 <a:solidFill>
                   <a:srgbClr val="2D6A6A"/>
                 </a:solidFill>
               </a:defRPr>
             </a:pPr>
             <a:r>
-              <a:rPr sz="3300" b="1">
+              <a:rPr sz="1425" b="1">
                 <a:solidFill>
                   <a:srgbClr val="2D6A6A"/>
                 </a:solidFill>
               </a:rPr>
-              <a:t>1</a:t>
-            </a:r>
-          </a:p>
-        </p:txBody>
-      </p:sp>
-      <p:sp>
-        <p:nvSpPr>
-          <p:cNvPr id="4" name="">
-            <a:extLst xmlns:a="http://schemas.openxmlformats.org/drawingml/2006/main">
-              <a:ext uri="{FF2B5EF4-FFF2-40B4-BE49-F238E27FC236}">
-                <a16:creationId xmlns:a16="http://schemas.microsoft.com/office/drawing/2014/main" id="{AB6E74CD-36CD-4CB1-AB25-C1879FADB994}"/>
-              </a:ext>
-            </a:extLst>
-          </p:cNvPr>
-          <p:cNvSpPr>
-            <a:spLocks xmlns:a="http://schemas.openxmlformats.org/drawingml/2006/main" noGrp="1"/>
-          </p:cNvSpPr>
-          <p:nvPr/>
-        </p:nvSpPr>
-        <p:spPr>
-          <a:xfrm xmlns:a="http://schemas.openxmlformats.org/drawingml/2006/main">
-            <a:off x="1790700" y="1905000"/>
-            <a:ext cx="3143250" cy="552450"/>
-          </a:xfrm>
-          <a:prstGeom xmlns:a="http://schemas.openxmlformats.org/drawingml/2006/main" prst="rect">
-            <a:avLst/>
-          </a:prstGeom>
-          <a:noFill xmlns:a="http://schemas.openxmlformats.org/drawingml/2006/main"/>
-          <a:ln xmlns:a="http://schemas.openxmlformats.org/drawingml/2006/main" w="0">
-            <a:noFill/>
-            <a:prstDash val="solid"/>
-          </a:ln>
-        </p:spPr>
-        <p:txBody>
-          <a:bodyPr xmlns:a="http://schemas.openxmlformats.org/drawingml/2006/main"/>
-          <a:lstStyle xmlns:a="http://schemas.openxmlformats.org/drawingml/2006/main"/>
-          <a:p xmlns:a="http://schemas.openxmlformats.org/drawingml/2006/main">
-            <a:pPr algn="l">
-              <a:defRPr sz="1725" b="1">
+              <a:t>Current survey</a:t>
+            </a:r>
+          </a:p>
+        </p:txBody>
+      </p:sp>
+      <p:sp>
+        <p:nvSpPr>
+          <p:cNvPr id="5" name="">
+            <a:extLst xmlns:a="http://schemas.openxmlformats.org/drawingml/2006/main">
+              <a:ext uri="{FF2B5EF4-FFF2-40B4-BE49-F238E27FC236}">
+                <a16:creationId xmlns:a16="http://schemas.microsoft.com/office/drawing/2014/main" id="{8BB3245E-FD42-4718-84E9-AAFBE5EF1E81}"/>
+              </a:ext>
+            </a:extLst>
+          </p:cNvPr>
+          <p:cNvSpPr>
+            <a:spLocks xmlns:a="http://schemas.openxmlformats.org/drawingml/2006/main" noGrp="1"/>
+          </p:cNvSpPr>
+          <p:nvPr/>
+        </p:nvSpPr>
+        <p:spPr>
+          <a:xfrm xmlns:a="http://schemas.openxmlformats.org/drawingml/2006/main">
+            <a:off x="2571750" y="2343150"/>
+            <a:ext cx="2667000" cy="476250"/>
+          </a:xfrm>
+          <a:prstGeom xmlns:a="http://schemas.openxmlformats.org/drawingml/2006/main" prst="rect">
+            <a:avLst/>
+          </a:prstGeom>
+          <a:noFill xmlns:a="http://schemas.openxmlformats.org/drawingml/2006/main"/>
+          <a:ln xmlns:a="http://schemas.openxmlformats.org/drawingml/2006/main" w="0">
+            <a:noFill/>
+            <a:prstDash val="solid"/>
+          </a:ln>
+        </p:spPr>
+        <p:txBody>
+          <a:bodyPr xmlns:a="http://schemas.openxmlformats.org/drawingml/2006/main"/>
+          <a:lstStyle xmlns:a="http://schemas.openxmlformats.org/drawingml/2006/main"/>
+          <a:p xmlns:a="http://schemas.openxmlformats.org/drawingml/2006/main">
+            <a:pPr algn="l">
+              <a:defRPr sz="1050" b="0">
                 <a:solidFill>
                   <a:srgbClr val="1C2430"/>
                 </a:solidFill>
               </a:defRPr>
             </a:pPr>
             <a:r>
-              <a:rPr sz="1725" b="1">
+              <a:rPr sz="1050" b="0">
                 <a:solidFill>
                   <a:srgbClr val="1C2430"/>
                 </a:solidFill>
               </a:rPr>
-              <a:t>Pilot review</a:t>
-            </a:r>
-          </a:p>
-        </p:txBody>
-      </p:sp>
-      <p:sp>
-        <p:nvSpPr>
-          <p:cNvPr id="5" name="">
-            <a:extLst xmlns:a="http://schemas.openxmlformats.org/drawingml/2006/main">
-              <a:ext uri="{FF2B5EF4-FFF2-40B4-BE49-F238E27FC236}">
-                <a16:creationId xmlns:a16="http://schemas.microsoft.com/office/drawing/2014/main" id="{ED6252CB-90D3-4F0C-9D86-93D29191EEB2}"/>
-              </a:ext>
-            </a:extLst>
-          </p:cNvPr>
-          <p:cNvSpPr>
-            <a:spLocks xmlns:a="http://schemas.openxmlformats.org/drawingml/2006/main" noGrp="1"/>
-          </p:cNvSpPr>
-          <p:nvPr/>
-        </p:nvSpPr>
-        <p:spPr>
-          <a:xfrm xmlns:a="http://schemas.openxmlformats.org/drawingml/2006/main">
-            <a:off x="1790700" y="2438400"/>
-            <a:ext cx="3143250" cy="400050"/>
-          </a:xfrm>
-          <a:prstGeom xmlns:a="http://schemas.openxmlformats.org/drawingml/2006/main" prst="rect">
-            <a:avLst/>
-          </a:prstGeom>
-          <a:noFill xmlns:a="http://schemas.openxmlformats.org/drawingml/2006/main"/>
-          <a:ln xmlns:a="http://schemas.openxmlformats.org/drawingml/2006/main" w="0">
-            <a:noFill/>
-            <a:prstDash val="solid"/>
-          </a:ln>
-        </p:spPr>
-        <p:txBody>
-          <a:bodyPr xmlns:a="http://schemas.openxmlformats.org/drawingml/2006/main"/>
-          <a:lstStyle xmlns:a="http://schemas.openxmlformats.org/drawingml/2006/main"/>
-          <a:p xmlns:a="http://schemas.openxmlformats.org/drawingml/2006/main">
-            <a:pPr algn="l">
-              <a:defRPr sz="1200" b="0">
-                <a:solidFill>
-                  <a:srgbClr val="5B6472"/>
-                </a:solidFill>
-              </a:defRPr>
-            </a:pPr>
-            <a:r>
-              <a:rPr sz="1200" b="0">
-                <a:solidFill>
-                  <a:srgbClr val="5B6472"/>
-                </a:solidFill>
-              </a:rPr>
-              <a:t>Have a mentor review item wording, consent, and risk language.</a:t>
+              <a:t>https://taste-empire-come-advancement.trycloudflare.com/survey</a:t>
             </a:r>
           </a:p>
         </p:txBody>
@@ -8573,25 +9601,325 @@
           <p:cNvPr id="6" name="">
             <a:extLst xmlns:a="http://schemas.openxmlformats.org/drawingml/2006/main">
               <a:ext uri="{FF2B5EF4-FFF2-40B4-BE49-F238E27FC236}">
-                <a16:creationId xmlns:a16="http://schemas.microsoft.com/office/drawing/2014/main" id="{78EC9950-664C-4690-9835-0B7926826341}"/>
-              </a:ext>
-            </a:extLst>
-          </p:cNvPr>
-          <p:cNvSpPr>
-            <a:spLocks xmlns:a="http://schemas.openxmlformats.org/drawingml/2006/main" noGrp="1"/>
-          </p:cNvSpPr>
-          <p:nvPr/>
-        </p:nvSpPr>
-        <p:spPr>
-          <a:xfrm xmlns:a="http://schemas.openxmlformats.org/drawingml/2006/main">
-            <a:off x="6000750" y="1695450"/>
-            <a:ext cx="4476750" cy="1257300"/>
+                <a16:creationId xmlns:a16="http://schemas.microsoft.com/office/drawing/2014/main" id="{A72435FD-B3D9-45C5-A406-41A1CFC78C99}"/>
+              </a:ext>
+            </a:extLst>
+          </p:cNvPr>
+          <p:cNvSpPr>
+            <a:spLocks xmlns:a="http://schemas.openxmlformats.org/drawingml/2006/main" noGrp="1"/>
+          </p:cNvSpPr>
+          <p:nvPr/>
+        </p:nvSpPr>
+        <p:spPr>
+          <a:xfrm xmlns:a="http://schemas.openxmlformats.org/drawingml/2006/main">
+            <a:off x="1009650" y="3009900"/>
+            <a:ext cx="1428750" cy="228600"/>
+          </a:xfrm>
+          <a:prstGeom xmlns:a="http://schemas.openxmlformats.org/drawingml/2006/main" prst="rect">
+            <a:avLst/>
+          </a:prstGeom>
+          <a:noFill xmlns:a="http://schemas.openxmlformats.org/drawingml/2006/main"/>
+          <a:ln xmlns:a="http://schemas.openxmlformats.org/drawingml/2006/main" w="0">
+            <a:noFill/>
+            <a:prstDash val="solid"/>
+          </a:ln>
+        </p:spPr>
+        <p:txBody>
+          <a:bodyPr xmlns:a="http://schemas.openxmlformats.org/drawingml/2006/main"/>
+          <a:lstStyle xmlns:a="http://schemas.openxmlformats.org/drawingml/2006/main"/>
+          <a:p xmlns:a="http://schemas.openxmlformats.org/drawingml/2006/main">
+            <a:pPr algn="l">
+              <a:defRPr sz="1425" b="1">
+                <a:solidFill>
+                  <a:srgbClr val="D98E04"/>
+                </a:solidFill>
+              </a:defRPr>
+            </a:pPr>
+            <a:r>
+              <a:rPr sz="1425" b="1">
+                <a:solidFill>
+                  <a:srgbClr val="D98E04"/>
+                </a:solidFill>
+              </a:rPr>
+              <a:t>GitHub repo</a:t>
+            </a:r>
+          </a:p>
+        </p:txBody>
+      </p:sp>
+      <p:sp>
+        <p:nvSpPr>
+          <p:cNvPr id="7" name="">
+            <a:extLst xmlns:a="http://schemas.openxmlformats.org/drawingml/2006/main">
+              <a:ext uri="{FF2B5EF4-FFF2-40B4-BE49-F238E27FC236}">
+                <a16:creationId xmlns:a16="http://schemas.microsoft.com/office/drawing/2014/main" id="{53A726AC-035D-4A4F-8493-51896C7B27D2}"/>
+              </a:ext>
+            </a:extLst>
+          </p:cNvPr>
+          <p:cNvSpPr>
+            <a:spLocks xmlns:a="http://schemas.openxmlformats.org/drawingml/2006/main" noGrp="1"/>
+          </p:cNvSpPr>
+          <p:nvPr/>
+        </p:nvSpPr>
+        <p:spPr>
+          <a:xfrm xmlns:a="http://schemas.openxmlformats.org/drawingml/2006/main">
+            <a:off x="2571750" y="2990850"/>
+            <a:ext cx="2667000" cy="476250"/>
+          </a:xfrm>
+          <a:prstGeom xmlns:a="http://schemas.openxmlformats.org/drawingml/2006/main" prst="rect">
+            <a:avLst/>
+          </a:prstGeom>
+          <a:noFill xmlns:a="http://schemas.openxmlformats.org/drawingml/2006/main"/>
+          <a:ln xmlns:a="http://schemas.openxmlformats.org/drawingml/2006/main" w="0">
+            <a:noFill/>
+            <a:prstDash val="solid"/>
+          </a:ln>
+        </p:spPr>
+        <p:txBody>
+          <a:bodyPr xmlns:a="http://schemas.openxmlformats.org/drawingml/2006/main"/>
+          <a:lstStyle xmlns:a="http://schemas.openxmlformats.org/drawingml/2006/main"/>
+          <a:p xmlns:a="http://schemas.openxmlformats.org/drawingml/2006/main">
+            <a:pPr algn="l">
+              <a:defRPr sz="1050" b="0">
+                <a:solidFill>
+                  <a:srgbClr val="1C2430"/>
+                </a:solidFill>
+              </a:defRPr>
+            </a:pPr>
+            <a:r>
+              <a:rPr sz="1050" b="0">
+                <a:solidFill>
+                  <a:srgbClr val="1C2430"/>
+                </a:solidFill>
+              </a:rPr>
+              <a:t>https://github.com/haobosun940-crypto/loneliness-risk-decision-lab</a:t>
+            </a:r>
+          </a:p>
+        </p:txBody>
+      </p:sp>
+      <p:sp>
+        <p:nvSpPr>
+          <p:cNvPr id="8" name="">
+            <a:extLst xmlns:a="http://schemas.openxmlformats.org/drawingml/2006/main">
+              <a:ext uri="{FF2B5EF4-FFF2-40B4-BE49-F238E27FC236}">
+                <a16:creationId xmlns:a16="http://schemas.microsoft.com/office/drawing/2014/main" id="{DA21FC26-33F8-42FD-BCC0-9F4514DCBAFC}"/>
+              </a:ext>
+            </a:extLst>
+          </p:cNvPr>
+          <p:cNvSpPr>
+            <a:spLocks xmlns:a="http://schemas.openxmlformats.org/drawingml/2006/main" noGrp="1"/>
+          </p:cNvSpPr>
+          <p:nvPr/>
+        </p:nvSpPr>
+        <p:spPr>
+          <a:xfrm xmlns:a="http://schemas.openxmlformats.org/drawingml/2006/main">
+            <a:off x="1009650" y="3657600"/>
+            <a:ext cx="1428750" cy="228600"/>
+          </a:xfrm>
+          <a:prstGeom xmlns:a="http://schemas.openxmlformats.org/drawingml/2006/main" prst="rect">
+            <a:avLst/>
+          </a:prstGeom>
+          <a:noFill xmlns:a="http://schemas.openxmlformats.org/drawingml/2006/main"/>
+          <a:ln xmlns:a="http://schemas.openxmlformats.org/drawingml/2006/main" w="0">
+            <a:noFill/>
+            <a:prstDash val="solid"/>
+          </a:ln>
+        </p:spPr>
+        <p:txBody>
+          <a:bodyPr xmlns:a="http://schemas.openxmlformats.org/drawingml/2006/main"/>
+          <a:lstStyle xmlns:a="http://schemas.openxmlformats.org/drawingml/2006/main"/>
+          <a:p xmlns:a="http://schemas.openxmlformats.org/drawingml/2006/main">
+            <a:pPr algn="l">
+              <a:defRPr sz="1425" b="1">
+                <a:solidFill>
+                  <a:srgbClr val="456990"/>
+                </a:solidFill>
+              </a:defRPr>
+            </a:pPr>
+            <a:r>
+              <a:rPr sz="1425" b="1">
+                <a:solidFill>
+                  <a:srgbClr val="456990"/>
+                </a:solidFill>
+              </a:rPr>
+              <a:t>Render setup</a:t>
+            </a:r>
+          </a:p>
+        </p:txBody>
+      </p:sp>
+      <p:sp>
+        <p:nvSpPr>
+          <p:cNvPr id="9" name="">
+            <a:extLst xmlns:a="http://schemas.openxmlformats.org/drawingml/2006/main">
+              <a:ext uri="{FF2B5EF4-FFF2-40B4-BE49-F238E27FC236}">
+                <a16:creationId xmlns:a16="http://schemas.microsoft.com/office/drawing/2014/main" id="{154505EC-42E9-484B-962E-88AB3CDF4014}"/>
+              </a:ext>
+            </a:extLst>
+          </p:cNvPr>
+          <p:cNvSpPr>
+            <a:spLocks xmlns:a="http://schemas.openxmlformats.org/drawingml/2006/main" noGrp="1"/>
+          </p:cNvSpPr>
+          <p:nvPr/>
+        </p:nvSpPr>
+        <p:spPr>
+          <a:xfrm xmlns:a="http://schemas.openxmlformats.org/drawingml/2006/main">
+            <a:off x="2571750" y="3638550"/>
+            <a:ext cx="2667000" cy="476250"/>
+          </a:xfrm>
+          <a:prstGeom xmlns:a="http://schemas.openxmlformats.org/drawingml/2006/main" prst="rect">
+            <a:avLst/>
+          </a:prstGeom>
+          <a:noFill xmlns:a="http://schemas.openxmlformats.org/drawingml/2006/main"/>
+          <a:ln xmlns:a="http://schemas.openxmlformats.org/drawingml/2006/main" w="0">
+            <a:noFill/>
+            <a:prstDash val="solid"/>
+          </a:ln>
+        </p:spPr>
+        <p:txBody>
+          <a:bodyPr xmlns:a="http://schemas.openxmlformats.org/drawingml/2006/main"/>
+          <a:lstStyle xmlns:a="http://schemas.openxmlformats.org/drawingml/2006/main"/>
+          <a:p xmlns:a="http://schemas.openxmlformats.org/drawingml/2006/main">
+            <a:pPr algn="l">
+              <a:defRPr sz="1050" b="0">
+                <a:solidFill>
+                  <a:srgbClr val="1C2430"/>
+                </a:solidFill>
+              </a:defRPr>
+            </a:pPr>
+            <a:r>
+              <a:rPr sz="1050" b="0">
+                <a:solidFill>
+                  <a:srgbClr val="1C2430"/>
+                </a:solidFill>
+              </a:rPr>
+              <a:t>https://dashboard.render.com/blueprint/new?repo=https://github.com/haobosun940-crypto/loneliness-risk-decision-lab</a:t>
+            </a:r>
+          </a:p>
+        </p:txBody>
+      </p:sp>
+      <p:sp>
+        <p:nvSpPr>
+          <p:cNvPr id="10" name="">
+            <a:extLst xmlns:a="http://schemas.openxmlformats.org/drawingml/2006/main">
+              <a:ext uri="{FF2B5EF4-FFF2-40B4-BE49-F238E27FC236}">
+                <a16:creationId xmlns:a16="http://schemas.microsoft.com/office/drawing/2014/main" id="{5C821017-D7A2-42C0-B9E2-8DD5C1F86EE9}"/>
+              </a:ext>
+            </a:extLst>
+          </p:cNvPr>
+          <p:cNvSpPr>
+            <a:spLocks xmlns:a="http://schemas.openxmlformats.org/drawingml/2006/main" noGrp="1"/>
+          </p:cNvSpPr>
+          <p:nvPr/>
+        </p:nvSpPr>
+        <p:spPr>
+          <a:xfrm xmlns:a="http://schemas.openxmlformats.org/drawingml/2006/main">
+            <a:off x="1009650" y="4305300"/>
+            <a:ext cx="1428750" cy="228600"/>
+          </a:xfrm>
+          <a:prstGeom xmlns:a="http://schemas.openxmlformats.org/drawingml/2006/main" prst="rect">
+            <a:avLst/>
+          </a:prstGeom>
+          <a:noFill xmlns:a="http://schemas.openxmlformats.org/drawingml/2006/main"/>
+          <a:ln xmlns:a="http://schemas.openxmlformats.org/drawingml/2006/main" w="0">
+            <a:noFill/>
+            <a:prstDash val="solid"/>
+          </a:ln>
+        </p:spPr>
+        <p:txBody>
+          <a:bodyPr xmlns:a="http://schemas.openxmlformats.org/drawingml/2006/main"/>
+          <a:lstStyle xmlns:a="http://schemas.openxmlformats.org/drawingml/2006/main"/>
+          <a:p xmlns:a="http://schemas.openxmlformats.org/drawingml/2006/main">
+            <a:pPr algn="l">
+              <a:defRPr sz="1425" b="1">
+                <a:solidFill>
+                  <a:srgbClr val="B23A48"/>
+                </a:solidFill>
+              </a:defRPr>
+            </a:pPr>
+            <a:r>
+              <a:rPr sz="1425" b="1">
+                <a:solidFill>
+                  <a:srgbClr val="B23A48"/>
+                </a:solidFill>
+              </a:rPr>
+              <a:t>Downloads</a:t>
+            </a:r>
+          </a:p>
+        </p:txBody>
+      </p:sp>
+      <p:sp>
+        <p:nvSpPr>
+          <p:cNvPr id="11" name="">
+            <a:extLst xmlns:a="http://schemas.openxmlformats.org/drawingml/2006/main">
+              <a:ext uri="{FF2B5EF4-FFF2-40B4-BE49-F238E27FC236}">
+                <a16:creationId xmlns:a16="http://schemas.microsoft.com/office/drawing/2014/main" id="{2EB66604-F79D-4CE7-B027-1FF226AF9C6C}"/>
+              </a:ext>
+            </a:extLst>
+          </p:cNvPr>
+          <p:cNvSpPr>
+            <a:spLocks xmlns:a="http://schemas.openxmlformats.org/drawingml/2006/main" noGrp="1"/>
+          </p:cNvSpPr>
+          <p:nvPr/>
+        </p:nvSpPr>
+        <p:spPr>
+          <a:xfrm xmlns:a="http://schemas.openxmlformats.org/drawingml/2006/main">
+            <a:off x="2571750" y="4286250"/>
+            <a:ext cx="2667000" cy="476250"/>
+          </a:xfrm>
+          <a:prstGeom xmlns:a="http://schemas.openxmlformats.org/drawingml/2006/main" prst="rect">
+            <a:avLst/>
+          </a:prstGeom>
+          <a:noFill xmlns:a="http://schemas.openxmlformats.org/drawingml/2006/main"/>
+          <a:ln xmlns:a="http://schemas.openxmlformats.org/drawingml/2006/main" w="0">
+            <a:noFill/>
+            <a:prstDash val="solid"/>
+          </a:ln>
+        </p:spPr>
+        <p:txBody>
+          <a:bodyPr xmlns:a="http://schemas.openxmlformats.org/drawingml/2006/main"/>
+          <a:lstStyle xmlns:a="http://schemas.openxmlformats.org/drawingml/2006/main"/>
+          <a:p xmlns:a="http://schemas.openxmlformats.org/drawingml/2006/main">
+            <a:pPr algn="l">
+              <a:defRPr sz="1050" b="0">
+                <a:solidFill>
+                  <a:srgbClr val="1C2430"/>
+                </a:solidFill>
+              </a:defRPr>
+            </a:pPr>
+            <a:r>
+              <a:rPr sz="1050" b="0">
+                <a:solidFill>
+                  <a:srgbClr val="1C2430"/>
+                </a:solidFill>
+              </a:rPr>
+              <a:t>https://taste-empire-come-advancement.trycloudflare.com/downloads</a:t>
+            </a:r>
+          </a:p>
+        </p:txBody>
+      </p:sp>
+      <p:sp>
+        <p:nvSpPr>
+          <p:cNvPr id="12" name="">
+            <a:extLst xmlns:a="http://schemas.openxmlformats.org/drawingml/2006/main">
+              <a:ext uri="{FF2B5EF4-FFF2-40B4-BE49-F238E27FC236}">
+                <a16:creationId xmlns:a16="http://schemas.microsoft.com/office/drawing/2014/main" id="{DF67DCA6-3159-4E0F-B473-BE5F571B6756}"/>
+              </a:ext>
+            </a:extLst>
+          </p:cNvPr>
+          <p:cNvSpPr>
+            <a:spLocks xmlns:a="http://schemas.openxmlformats.org/drawingml/2006/main" noGrp="1"/>
+          </p:cNvSpPr>
+          <p:nvPr/>
+        </p:nvSpPr>
+        <p:spPr>
+          <a:xfrm xmlns:a="http://schemas.openxmlformats.org/drawingml/2006/main">
+            <a:off x="6334125" y="1562100"/>
+            <a:ext cx="4095750" cy="3619500"/>
           </a:xfrm>
           <a:prstGeom xmlns:a="http://schemas.openxmlformats.org/drawingml/2006/main" prst="rect">
             <a:avLst/>
           </a:prstGeom>
           <a:solidFill xmlns:a="http://schemas.openxmlformats.org/drawingml/2006/main">
-            <a:srgbClr val="FFFFFF"/>
+            <a:srgbClr val="1C2430"/>
           </a:solidFill>
           <a:ln xmlns:a="http://schemas.openxmlformats.org/drawingml/2006/main" w="9525">
             <a:solidFill>
@@ -8603,122 +9931,122 @@
       </p:sp>
       <p:sp>
         <p:nvSpPr>
-          <p:cNvPr id="7" name="">
-            <a:extLst xmlns:a="http://schemas.openxmlformats.org/drawingml/2006/main">
-              <a:ext uri="{FF2B5EF4-FFF2-40B4-BE49-F238E27FC236}">
-                <a16:creationId xmlns:a16="http://schemas.microsoft.com/office/drawing/2014/main" id="{A243DD68-0F66-4598-B7E2-FA9014706C3C}"/>
-              </a:ext>
-            </a:extLst>
-          </p:cNvPr>
-          <p:cNvSpPr>
-            <a:spLocks xmlns:a="http://schemas.openxmlformats.org/drawingml/2006/main" noGrp="1"/>
-          </p:cNvSpPr>
-          <p:nvPr/>
-        </p:nvSpPr>
-        <p:spPr>
-          <a:xfrm xmlns:a="http://schemas.openxmlformats.org/drawingml/2006/main">
-            <a:off x="6229350" y="1943100"/>
-            <a:ext cx="552450" cy="495300"/>
-          </a:xfrm>
-          <a:prstGeom xmlns:a="http://schemas.openxmlformats.org/drawingml/2006/main" prst="rect">
-            <a:avLst/>
-          </a:prstGeom>
-          <a:noFill xmlns:a="http://schemas.openxmlformats.org/drawingml/2006/main"/>
-          <a:ln xmlns:a="http://schemas.openxmlformats.org/drawingml/2006/main" w="0">
-            <a:noFill/>
-            <a:prstDash val="solid"/>
-          </a:ln>
-        </p:spPr>
-        <p:txBody>
-          <a:bodyPr xmlns:a="http://schemas.openxmlformats.org/drawingml/2006/main"/>
-          <a:lstStyle xmlns:a="http://schemas.openxmlformats.org/drawingml/2006/main"/>
-          <a:p xmlns:a="http://schemas.openxmlformats.org/drawingml/2006/main">
-            <a:pPr algn="l">
-              <a:defRPr sz="3300" b="1">
+          <p:cNvPr id="13" name="">
+            <a:extLst xmlns:a="http://schemas.openxmlformats.org/drawingml/2006/main">
+              <a:ext uri="{FF2B5EF4-FFF2-40B4-BE49-F238E27FC236}">
+                <a16:creationId xmlns:a16="http://schemas.microsoft.com/office/drawing/2014/main" id="{F3EFCD51-A234-4ACB-8168-C3DCFCCDAE75}"/>
+              </a:ext>
+            </a:extLst>
+          </p:cNvPr>
+          <p:cNvSpPr>
+            <a:spLocks xmlns:a="http://schemas.openxmlformats.org/drawingml/2006/main" noGrp="1"/>
+          </p:cNvSpPr>
+          <p:nvPr/>
+        </p:nvSpPr>
+        <p:spPr>
+          <a:xfrm xmlns:a="http://schemas.openxmlformats.org/drawingml/2006/main">
+            <a:off x="6715125" y="1885950"/>
+            <a:ext cx="3048000" cy="323850"/>
+          </a:xfrm>
+          <a:prstGeom xmlns:a="http://schemas.openxmlformats.org/drawingml/2006/main" prst="rect">
+            <a:avLst/>
+          </a:prstGeom>
+          <a:noFill xmlns:a="http://schemas.openxmlformats.org/drawingml/2006/main"/>
+          <a:ln xmlns:a="http://schemas.openxmlformats.org/drawingml/2006/main" w="0">
+            <a:noFill/>
+            <a:prstDash val="solid"/>
+          </a:ln>
+        </p:spPr>
+        <p:txBody>
+          <a:bodyPr xmlns:a="http://schemas.openxmlformats.org/drawingml/2006/main"/>
+          <a:lstStyle xmlns:a="http://schemas.openxmlformats.org/drawingml/2006/main"/>
+          <a:p xmlns:a="http://schemas.openxmlformats.org/drawingml/2006/main">
+            <a:pPr algn="l">
+              <a:defRPr sz="2250" b="1">
+                <a:solidFill>
+                  <a:srgbClr val="FFFFFF"/>
+                </a:solidFill>
+              </a:defRPr>
+            </a:pPr>
+            <a:r>
+              <a:rPr sz="2250" b="1">
+                <a:solidFill>
+                  <a:srgbClr val="FFFFFF"/>
+                </a:solidFill>
+              </a:rPr>
+              <a:t>Route map</a:t>
+            </a:r>
+          </a:p>
+        </p:txBody>
+      </p:sp>
+      <p:sp>
+        <p:nvSpPr>
+          <p:cNvPr id="14" name="">
+            <a:extLst xmlns:a="http://schemas.openxmlformats.org/drawingml/2006/main">
+              <a:ext uri="{FF2B5EF4-FFF2-40B4-BE49-F238E27FC236}">
+                <a16:creationId xmlns:a16="http://schemas.microsoft.com/office/drawing/2014/main" id="{B38B3753-B74F-4E92-A407-25FB9D15A364}"/>
+              </a:ext>
+            </a:extLst>
+          </p:cNvPr>
+          <p:cNvSpPr>
+            <a:spLocks xmlns:a="http://schemas.openxmlformats.org/drawingml/2006/main" noGrp="1"/>
+          </p:cNvSpPr>
+          <p:nvPr/>
+        </p:nvSpPr>
+        <p:spPr>
+          <a:xfrm xmlns:a="http://schemas.openxmlformats.org/drawingml/2006/main">
+            <a:off x="6781800" y="2476500"/>
+            <a:ext cx="1428750" cy="228600"/>
+          </a:xfrm>
+          <a:prstGeom xmlns:a="http://schemas.openxmlformats.org/drawingml/2006/main" prst="rect">
+            <a:avLst/>
+          </a:prstGeom>
+          <a:noFill xmlns:a="http://schemas.openxmlformats.org/drawingml/2006/main"/>
+          <a:ln xmlns:a="http://schemas.openxmlformats.org/drawingml/2006/main" w="0">
+            <a:noFill/>
+            <a:prstDash val="solid"/>
+          </a:ln>
+        </p:spPr>
+        <p:txBody>
+          <a:bodyPr xmlns:a="http://schemas.openxmlformats.org/drawingml/2006/main"/>
+          <a:lstStyle xmlns:a="http://schemas.openxmlformats.org/drawingml/2006/main"/>
+          <a:p xmlns:a="http://schemas.openxmlformats.org/drawingml/2006/main">
+            <a:pPr algn="l">
+              <a:defRPr sz="1650" b="1">
                 <a:solidFill>
                   <a:srgbClr val="D98E04"/>
                 </a:solidFill>
               </a:defRPr>
             </a:pPr>
             <a:r>
-              <a:rPr sz="3300" b="1">
+              <a:rPr sz="1650" b="1">
                 <a:solidFill>
                   <a:srgbClr val="D98E04"/>
                 </a:solidFill>
               </a:rPr>
-              <a:t>2</a:t>
-            </a:r>
-          </a:p>
-        </p:txBody>
-      </p:sp>
-      <p:sp>
-        <p:nvSpPr>
-          <p:cNvPr id="8" name="">
-            <a:extLst xmlns:a="http://schemas.openxmlformats.org/drawingml/2006/main">
-              <a:ext uri="{FF2B5EF4-FFF2-40B4-BE49-F238E27FC236}">
-                <a16:creationId xmlns:a16="http://schemas.microsoft.com/office/drawing/2014/main" id="{39082943-00F1-48CD-A87A-AF49087F975E}"/>
-              </a:ext>
-            </a:extLst>
-          </p:cNvPr>
-          <p:cNvSpPr>
-            <a:spLocks xmlns:a="http://schemas.openxmlformats.org/drawingml/2006/main" noGrp="1"/>
-          </p:cNvSpPr>
-          <p:nvPr/>
-        </p:nvSpPr>
-        <p:spPr>
-          <a:xfrm xmlns:a="http://schemas.openxmlformats.org/drawingml/2006/main">
-            <a:off x="6934200" y="1905000"/>
-            <a:ext cx="3143250" cy="552450"/>
-          </a:xfrm>
-          <a:prstGeom xmlns:a="http://schemas.openxmlformats.org/drawingml/2006/main" prst="rect">
-            <a:avLst/>
-          </a:prstGeom>
-          <a:noFill xmlns:a="http://schemas.openxmlformats.org/drawingml/2006/main"/>
-          <a:ln xmlns:a="http://schemas.openxmlformats.org/drawingml/2006/main" w="0">
-            <a:noFill/>
-            <a:prstDash val="solid"/>
-          </a:ln>
-        </p:spPr>
-        <p:txBody>
-          <a:bodyPr xmlns:a="http://schemas.openxmlformats.org/drawingml/2006/main"/>
-          <a:lstStyle xmlns:a="http://schemas.openxmlformats.org/drawingml/2006/main"/>
-          <a:p xmlns:a="http://schemas.openxmlformats.org/drawingml/2006/main">
-            <a:pPr algn="l">
-              <a:defRPr sz="1725" b="1">
-                <a:solidFill>
-                  <a:srgbClr val="1C2430"/>
-                </a:solidFill>
-              </a:defRPr>
-            </a:pPr>
-            <a:r>
-              <a:rPr sz="1725" b="1">
-                <a:solidFill>
-                  <a:srgbClr val="1C2430"/>
-                </a:solidFill>
-              </a:rPr>
-              <a:t>Collect 80-150 live responses</a:t>
-            </a:r>
-          </a:p>
-        </p:txBody>
-      </p:sp>
-      <p:sp>
-        <p:nvSpPr>
-          <p:cNvPr id="9" name="">
-            <a:extLst xmlns:a="http://schemas.openxmlformats.org/drawingml/2006/main">
-              <a:ext uri="{FF2B5EF4-FFF2-40B4-BE49-F238E27FC236}">
-                <a16:creationId xmlns:a16="http://schemas.microsoft.com/office/drawing/2014/main" id="{FC8C01F0-B43D-4FF7-9BE9-B1564F94FBBB}"/>
-              </a:ext>
-            </a:extLst>
-          </p:cNvPr>
-          <p:cNvSpPr>
-            <a:spLocks xmlns:a="http://schemas.openxmlformats.org/drawingml/2006/main" noGrp="1"/>
-          </p:cNvSpPr>
-          <p:nvPr/>
-        </p:nvSpPr>
-        <p:spPr>
-          <a:xfrm xmlns:a="http://schemas.openxmlformats.org/drawingml/2006/main">
-            <a:off x="6934200" y="2438400"/>
-            <a:ext cx="3143250" cy="400050"/>
+              <a:t>/survey</a:t>
+            </a:r>
+          </a:p>
+        </p:txBody>
+      </p:sp>
+      <p:sp>
+        <p:nvSpPr>
+          <p:cNvPr id="15" name="">
+            <a:extLst xmlns:a="http://schemas.openxmlformats.org/drawingml/2006/main">
+              <a:ext uri="{FF2B5EF4-FFF2-40B4-BE49-F238E27FC236}">
+                <a16:creationId xmlns:a16="http://schemas.microsoft.com/office/drawing/2014/main" id="{D27CFBA8-700C-4B4D-B8DD-983AAB4E23BB}"/>
+              </a:ext>
+            </a:extLst>
+          </p:cNvPr>
+          <p:cNvSpPr>
+            <a:spLocks xmlns:a="http://schemas.openxmlformats.org/drawingml/2006/main" noGrp="1"/>
+          </p:cNvSpPr>
+          <p:nvPr/>
+        </p:nvSpPr>
+        <p:spPr>
+          <a:xfrm xmlns:a="http://schemas.openxmlformats.org/drawingml/2006/main">
+            <a:off x="8286750" y="2495550"/>
+            <a:ext cx="1714500" cy="400050"/>
           </a:xfrm>
           <a:prstGeom xmlns:a="http://schemas.openxmlformats.org/drawingml/2006/main" prst="rect">
             <a:avLst/>
@@ -8736,443 +10064,377 @@
             <a:pPr algn="l">
               <a:defRPr sz="1200" b="0">
                 <a:solidFill>
+                  <a:srgbClr val="D8DEE6"/>
+                </a:solidFill>
+              </a:defRPr>
+            </a:pPr>
+            <a:r>
+              <a:rPr sz="1200" b="0">
+                <a:solidFill>
+                  <a:srgbClr val="D8DEE6"/>
+                </a:solidFill>
+              </a:rPr>
+              <a:t>Questionnaire and personal report</a:t>
+            </a:r>
+          </a:p>
+        </p:txBody>
+      </p:sp>
+      <p:sp>
+        <p:nvSpPr>
+          <p:cNvPr id="16" name="">
+            <a:extLst xmlns:a="http://schemas.openxmlformats.org/drawingml/2006/main">
+              <a:ext uri="{FF2B5EF4-FFF2-40B4-BE49-F238E27FC236}">
+                <a16:creationId xmlns:a16="http://schemas.microsoft.com/office/drawing/2014/main" id="{1F6A91A4-3F38-4A81-A341-5430F96BB19C}"/>
+              </a:ext>
+            </a:extLst>
+          </p:cNvPr>
+          <p:cNvSpPr>
+            <a:spLocks xmlns:a="http://schemas.openxmlformats.org/drawingml/2006/main" noGrp="1"/>
+          </p:cNvSpPr>
+          <p:nvPr/>
+        </p:nvSpPr>
+        <p:spPr>
+          <a:xfrm xmlns:a="http://schemas.openxmlformats.org/drawingml/2006/main">
+            <a:off x="6781800" y="3067050"/>
+            <a:ext cx="1428750" cy="228600"/>
+          </a:xfrm>
+          <a:prstGeom xmlns:a="http://schemas.openxmlformats.org/drawingml/2006/main" prst="rect">
+            <a:avLst/>
+          </a:prstGeom>
+          <a:noFill xmlns:a="http://schemas.openxmlformats.org/drawingml/2006/main"/>
+          <a:ln xmlns:a="http://schemas.openxmlformats.org/drawingml/2006/main" w="0">
+            <a:noFill/>
+            <a:prstDash val="solid"/>
+          </a:ln>
+        </p:spPr>
+        <p:txBody>
+          <a:bodyPr xmlns:a="http://schemas.openxmlformats.org/drawingml/2006/main"/>
+          <a:lstStyle xmlns:a="http://schemas.openxmlformats.org/drawingml/2006/main"/>
+          <a:p xmlns:a="http://schemas.openxmlformats.org/drawingml/2006/main">
+            <a:pPr algn="l">
+              <a:defRPr sz="1650" b="1">
+                <a:solidFill>
+                  <a:srgbClr val="D98E04"/>
+                </a:solidFill>
+              </a:defRPr>
+            </a:pPr>
+            <a:r>
+              <a:rPr sz="1650" b="1">
+                <a:solidFill>
+                  <a:srgbClr val="D98E04"/>
+                </a:solidFill>
+              </a:rPr>
+              <a:t>/dashboard</a:t>
+            </a:r>
+          </a:p>
+        </p:txBody>
+      </p:sp>
+      <p:sp>
+        <p:nvSpPr>
+          <p:cNvPr id="17" name="">
+            <a:extLst xmlns:a="http://schemas.openxmlformats.org/drawingml/2006/main">
+              <a:ext uri="{FF2B5EF4-FFF2-40B4-BE49-F238E27FC236}">
+                <a16:creationId xmlns:a16="http://schemas.microsoft.com/office/drawing/2014/main" id="{C7EC0C3D-2ABC-4DF4-AAD7-825C3FA25B7D}"/>
+              </a:ext>
+            </a:extLst>
+          </p:cNvPr>
+          <p:cNvSpPr>
+            <a:spLocks xmlns:a="http://schemas.openxmlformats.org/drawingml/2006/main" noGrp="1"/>
+          </p:cNvSpPr>
+          <p:nvPr/>
+        </p:nvSpPr>
+        <p:spPr>
+          <a:xfrm xmlns:a="http://schemas.openxmlformats.org/drawingml/2006/main">
+            <a:off x="8286750" y="3086100"/>
+            <a:ext cx="1714500" cy="400050"/>
+          </a:xfrm>
+          <a:prstGeom xmlns:a="http://schemas.openxmlformats.org/drawingml/2006/main" prst="rect">
+            <a:avLst/>
+          </a:prstGeom>
+          <a:noFill xmlns:a="http://schemas.openxmlformats.org/drawingml/2006/main"/>
+          <a:ln xmlns:a="http://schemas.openxmlformats.org/drawingml/2006/main" w="0">
+            <a:noFill/>
+            <a:prstDash val="solid"/>
+          </a:ln>
+        </p:spPr>
+        <p:txBody>
+          <a:bodyPr xmlns:a="http://schemas.openxmlformats.org/drawingml/2006/main"/>
+          <a:lstStyle xmlns:a="http://schemas.openxmlformats.org/drawingml/2006/main"/>
+          <a:p xmlns:a="http://schemas.openxmlformats.org/drawingml/2006/main">
+            <a:pPr algn="l">
+              <a:defRPr sz="1200" b="0">
+                <a:solidFill>
+                  <a:srgbClr val="D8DEE6"/>
+                </a:solidFill>
+              </a:defRPr>
+            </a:pPr>
+            <a:r>
+              <a:rPr sz="1200" b="0">
+                <a:solidFill>
+                  <a:srgbClr val="D8DEE6"/>
+                </a:solidFill>
+              </a:rPr>
+              <a:t>Live submissions and CSV export</a:t>
+            </a:r>
+          </a:p>
+        </p:txBody>
+      </p:sp>
+      <p:sp>
+        <p:nvSpPr>
+          <p:cNvPr id="18" name="">
+            <a:extLst xmlns:a="http://schemas.openxmlformats.org/drawingml/2006/main">
+              <a:ext uri="{FF2B5EF4-FFF2-40B4-BE49-F238E27FC236}">
+                <a16:creationId xmlns:a16="http://schemas.microsoft.com/office/drawing/2014/main" id="{B7972883-C0B6-4D87-BB10-B6E044AEBDB6}"/>
+              </a:ext>
+            </a:extLst>
+          </p:cNvPr>
+          <p:cNvSpPr>
+            <a:spLocks xmlns:a="http://schemas.openxmlformats.org/drawingml/2006/main" noGrp="1"/>
+          </p:cNvSpPr>
+          <p:nvPr/>
+        </p:nvSpPr>
+        <p:spPr>
+          <a:xfrm xmlns:a="http://schemas.openxmlformats.org/drawingml/2006/main">
+            <a:off x="6781800" y="3657600"/>
+            <a:ext cx="1428750" cy="228600"/>
+          </a:xfrm>
+          <a:prstGeom xmlns:a="http://schemas.openxmlformats.org/drawingml/2006/main" prst="rect">
+            <a:avLst/>
+          </a:prstGeom>
+          <a:noFill xmlns:a="http://schemas.openxmlformats.org/drawingml/2006/main"/>
+          <a:ln xmlns:a="http://schemas.openxmlformats.org/drawingml/2006/main" w="0">
+            <a:noFill/>
+            <a:prstDash val="solid"/>
+          </a:ln>
+        </p:spPr>
+        <p:txBody>
+          <a:bodyPr xmlns:a="http://schemas.openxmlformats.org/drawingml/2006/main"/>
+          <a:lstStyle xmlns:a="http://schemas.openxmlformats.org/drawingml/2006/main"/>
+          <a:p xmlns:a="http://schemas.openxmlformats.org/drawingml/2006/main">
+            <a:pPr algn="l">
+              <a:defRPr sz="1650" b="1">
+                <a:solidFill>
+                  <a:srgbClr val="D98E04"/>
+                </a:solidFill>
+              </a:defRPr>
+            </a:pPr>
+            <a:r>
+              <a:rPr sz="1650" b="1">
+                <a:solidFill>
+                  <a:srgbClr val="D98E04"/>
+                </a:solidFill>
+              </a:rPr>
+              <a:t>/research</a:t>
+            </a:r>
+          </a:p>
+        </p:txBody>
+      </p:sp>
+      <p:sp>
+        <p:nvSpPr>
+          <p:cNvPr id="19" name="">
+            <a:extLst xmlns:a="http://schemas.openxmlformats.org/drawingml/2006/main">
+              <a:ext uri="{FF2B5EF4-FFF2-40B4-BE49-F238E27FC236}">
+                <a16:creationId xmlns:a16="http://schemas.microsoft.com/office/drawing/2014/main" id="{DFA9EA5E-7387-40A1-BA49-C8DE8CB9596C}"/>
+              </a:ext>
+            </a:extLst>
+          </p:cNvPr>
+          <p:cNvSpPr>
+            <a:spLocks xmlns:a="http://schemas.openxmlformats.org/drawingml/2006/main" noGrp="1"/>
+          </p:cNvSpPr>
+          <p:nvPr/>
+        </p:nvSpPr>
+        <p:spPr>
+          <a:xfrm xmlns:a="http://schemas.openxmlformats.org/drawingml/2006/main">
+            <a:off x="8286750" y="3676650"/>
+            <a:ext cx="1714500" cy="400050"/>
+          </a:xfrm>
+          <a:prstGeom xmlns:a="http://schemas.openxmlformats.org/drawingml/2006/main" prst="rect">
+            <a:avLst/>
+          </a:prstGeom>
+          <a:noFill xmlns:a="http://schemas.openxmlformats.org/drawingml/2006/main"/>
+          <a:ln xmlns:a="http://schemas.openxmlformats.org/drawingml/2006/main" w="0">
+            <a:noFill/>
+            <a:prstDash val="solid"/>
+          </a:ln>
+        </p:spPr>
+        <p:txBody>
+          <a:bodyPr xmlns:a="http://schemas.openxmlformats.org/drawingml/2006/main"/>
+          <a:lstStyle xmlns:a="http://schemas.openxmlformats.org/drawingml/2006/main"/>
+          <a:p xmlns:a="http://schemas.openxmlformats.org/drawingml/2006/main">
+            <a:pPr algn="l">
+              <a:defRPr sz="1200" b="0">
+                <a:solidFill>
+                  <a:srgbClr val="D8DEE6"/>
+                </a:solidFill>
+              </a:defRPr>
+            </a:pPr>
+            <a:r>
+              <a:rPr sz="1200" b="0">
+                <a:solidFill>
+                  <a:srgbClr val="D8DEE6"/>
+                </a:solidFill>
+              </a:rPr>
+              <a:t>Model outputs and workflow</a:t>
+            </a:r>
+          </a:p>
+        </p:txBody>
+      </p:sp>
+      <p:sp>
+        <p:nvSpPr>
+          <p:cNvPr id="20" name="">
+            <a:extLst xmlns:a="http://schemas.openxmlformats.org/drawingml/2006/main">
+              <a:ext uri="{FF2B5EF4-FFF2-40B4-BE49-F238E27FC236}">
+                <a16:creationId xmlns:a16="http://schemas.microsoft.com/office/drawing/2014/main" id="{2856628A-ABC2-44AF-9E05-F44752F7FE6A}"/>
+              </a:ext>
+            </a:extLst>
+          </p:cNvPr>
+          <p:cNvSpPr>
+            <a:spLocks xmlns:a="http://schemas.openxmlformats.org/drawingml/2006/main" noGrp="1"/>
+          </p:cNvSpPr>
+          <p:nvPr/>
+        </p:nvSpPr>
+        <p:spPr>
+          <a:xfrm xmlns:a="http://schemas.openxmlformats.org/drawingml/2006/main">
+            <a:off x="6781800" y="4248150"/>
+            <a:ext cx="1428750" cy="228600"/>
+          </a:xfrm>
+          <a:prstGeom xmlns:a="http://schemas.openxmlformats.org/drawingml/2006/main" prst="rect">
+            <a:avLst/>
+          </a:prstGeom>
+          <a:noFill xmlns:a="http://schemas.openxmlformats.org/drawingml/2006/main"/>
+          <a:ln xmlns:a="http://schemas.openxmlformats.org/drawingml/2006/main" w="0">
+            <a:noFill/>
+            <a:prstDash val="solid"/>
+          </a:ln>
+        </p:spPr>
+        <p:txBody>
+          <a:bodyPr xmlns:a="http://schemas.openxmlformats.org/drawingml/2006/main"/>
+          <a:lstStyle xmlns:a="http://schemas.openxmlformats.org/drawingml/2006/main"/>
+          <a:p xmlns:a="http://schemas.openxmlformats.org/drawingml/2006/main">
+            <a:pPr algn="l">
+              <a:defRPr sz="1650" b="1">
+                <a:solidFill>
+                  <a:srgbClr val="D98E04"/>
+                </a:solidFill>
+              </a:defRPr>
+            </a:pPr>
+            <a:r>
+              <a:rPr sz="1650" b="1">
+                <a:solidFill>
+                  <a:srgbClr val="D98E04"/>
+                </a:solidFill>
+              </a:rPr>
+              <a:t>/downloads</a:t>
+            </a:r>
+          </a:p>
+        </p:txBody>
+      </p:sp>
+      <p:sp>
+        <p:nvSpPr>
+          <p:cNvPr id="21" name="">
+            <a:extLst xmlns:a="http://schemas.openxmlformats.org/drawingml/2006/main">
+              <a:ext uri="{FF2B5EF4-FFF2-40B4-BE49-F238E27FC236}">
+                <a16:creationId xmlns:a16="http://schemas.microsoft.com/office/drawing/2014/main" id="{A7D75521-E261-4A27-8883-C074BC55612F}"/>
+              </a:ext>
+            </a:extLst>
+          </p:cNvPr>
+          <p:cNvSpPr>
+            <a:spLocks xmlns:a="http://schemas.openxmlformats.org/drawingml/2006/main" noGrp="1"/>
+          </p:cNvSpPr>
+          <p:nvPr/>
+        </p:nvSpPr>
+        <p:spPr>
+          <a:xfrm xmlns:a="http://schemas.openxmlformats.org/drawingml/2006/main">
+            <a:off x="8286750" y="4267200"/>
+            <a:ext cx="1714500" cy="400050"/>
+          </a:xfrm>
+          <a:prstGeom xmlns:a="http://schemas.openxmlformats.org/drawingml/2006/main" prst="rect">
+            <a:avLst/>
+          </a:prstGeom>
+          <a:noFill xmlns:a="http://schemas.openxmlformats.org/drawingml/2006/main"/>
+          <a:ln xmlns:a="http://schemas.openxmlformats.org/drawingml/2006/main" w="0">
+            <a:noFill/>
+            <a:prstDash val="solid"/>
+          </a:ln>
+        </p:spPr>
+        <p:txBody>
+          <a:bodyPr xmlns:a="http://schemas.openxmlformats.org/drawingml/2006/main"/>
+          <a:lstStyle xmlns:a="http://schemas.openxmlformats.org/drawingml/2006/main"/>
+          <a:p xmlns:a="http://schemas.openxmlformats.org/drawingml/2006/main">
+            <a:pPr algn="l">
+              <a:defRPr sz="1200" b="0">
+                <a:solidFill>
+                  <a:srgbClr val="D8DEE6"/>
+                </a:solidFill>
+              </a:defRPr>
+            </a:pPr>
+            <a:r>
+              <a:rPr sz="1200" b="0">
+                <a:solidFill>
+                  <a:srgbClr val="D8DEE6"/>
+                </a:solidFill>
+              </a:rPr>
+              <a:t>PDF, Word, PPT, workbook, video, package</a:t>
+            </a:r>
+          </a:p>
+        </p:txBody>
+      </p:sp>
+      <p:sp>
+        <p:nvSpPr>
+          <p:cNvPr id="22" name="">
+            <a:extLst xmlns:a="http://schemas.openxmlformats.org/drawingml/2006/main">
+              <a:ext uri="{FF2B5EF4-FFF2-40B4-BE49-F238E27FC236}">
+                <a16:creationId xmlns:a16="http://schemas.microsoft.com/office/drawing/2014/main" id="{013F0915-ADE8-4288-B9C9-7CC1D95F040A}"/>
+              </a:ext>
+            </a:extLst>
+          </p:cNvPr>
+          <p:cNvSpPr>
+            <a:spLocks xmlns:a="http://schemas.openxmlformats.org/drawingml/2006/main" noGrp="1"/>
+          </p:cNvSpPr>
+          <p:nvPr/>
+        </p:nvSpPr>
+        <p:spPr>
+          <a:xfrm xmlns:a="http://schemas.openxmlformats.org/drawingml/2006/main">
+            <a:off x="1085850" y="5657850"/>
+            <a:ext cx="9144000" cy="400050"/>
+          </a:xfrm>
+          <a:prstGeom xmlns:a="http://schemas.openxmlformats.org/drawingml/2006/main" prst="rect">
+            <a:avLst/>
+          </a:prstGeom>
+          <a:noFill xmlns:a="http://schemas.openxmlformats.org/drawingml/2006/main"/>
+          <a:ln xmlns:a="http://schemas.openxmlformats.org/drawingml/2006/main" w="0">
+            <a:noFill/>
+            <a:prstDash val="solid"/>
+          </a:ln>
+        </p:spPr>
+        <p:txBody>
+          <a:bodyPr xmlns:a="http://schemas.openxmlformats.org/drawingml/2006/main"/>
+          <a:lstStyle xmlns:a="http://schemas.openxmlformats.org/drawingml/2006/main"/>
+          <a:p xmlns:a="http://schemas.openxmlformats.org/drawingml/2006/main">
+            <a:pPr algn="ctr">
+              <a:defRPr sz="1575" b="0">
+                <a:solidFill>
                   <a:srgbClr val="5B6472"/>
                 </a:solidFill>
               </a:defRPr>
             </a:pPr>
             <a:r>
-              <a:rPr sz="1200" b="0">
+              <a:rPr sz="1575" b="0">
                 <a:solidFill>
                   <a:srgbClr val="5B6472"/>
                 </a:solidFill>
               </a:rPr>
-              <a:t>Use the QR/link and keep synthetic data separate.</a:t>
-            </a:r>
-          </a:p>
-        </p:txBody>
-      </p:sp>
-      <p:sp>
-        <p:nvSpPr>
-          <p:cNvPr id="10" name="">
-            <a:extLst xmlns:a="http://schemas.openxmlformats.org/drawingml/2006/main">
-              <a:ext uri="{FF2B5EF4-FFF2-40B4-BE49-F238E27FC236}">
-                <a16:creationId xmlns:a16="http://schemas.microsoft.com/office/drawing/2014/main" id="{7692DC18-078C-4412-AA1A-A86120DB44A5}"/>
-              </a:ext>
-            </a:extLst>
-          </p:cNvPr>
-          <p:cNvSpPr>
-            <a:spLocks xmlns:a="http://schemas.openxmlformats.org/drawingml/2006/main" noGrp="1"/>
-          </p:cNvSpPr>
-          <p:nvPr/>
-        </p:nvSpPr>
-        <p:spPr>
-          <a:xfrm xmlns:a="http://schemas.openxmlformats.org/drawingml/2006/main">
-            <a:off x="857250" y="3314700"/>
-            <a:ext cx="4476750" cy="1257300"/>
-          </a:xfrm>
-          <a:prstGeom xmlns:a="http://schemas.openxmlformats.org/drawingml/2006/main" prst="rect">
-            <a:avLst/>
-          </a:prstGeom>
-          <a:solidFill xmlns:a="http://schemas.openxmlformats.org/drawingml/2006/main">
-            <a:srgbClr val="FFFFFF"/>
-          </a:solidFill>
-          <a:ln xmlns:a="http://schemas.openxmlformats.org/drawingml/2006/main" w="9525">
-            <a:solidFill>
-              <a:srgbClr val="1C2430"/>
-            </a:solidFill>
-            <a:prstDash val="solid"/>
-          </a:ln>
-        </p:spPr>
-      </p:sp>
-      <p:sp>
-        <p:nvSpPr>
-          <p:cNvPr id="11" name="">
-            <a:extLst xmlns:a="http://schemas.openxmlformats.org/drawingml/2006/main">
-              <a:ext uri="{FF2B5EF4-FFF2-40B4-BE49-F238E27FC236}">
-                <a16:creationId xmlns:a16="http://schemas.microsoft.com/office/drawing/2014/main" id="{7B39E6BF-81D2-4FA5-B224-FD8EC3EC396B}"/>
-              </a:ext>
-            </a:extLst>
-          </p:cNvPr>
-          <p:cNvSpPr>
-            <a:spLocks xmlns:a="http://schemas.openxmlformats.org/drawingml/2006/main" noGrp="1"/>
-          </p:cNvSpPr>
-          <p:nvPr/>
-        </p:nvSpPr>
-        <p:spPr>
-          <a:xfrm xmlns:a="http://schemas.openxmlformats.org/drawingml/2006/main">
-            <a:off x="1085850" y="3562350"/>
-            <a:ext cx="552450" cy="495300"/>
-          </a:xfrm>
-          <a:prstGeom xmlns:a="http://schemas.openxmlformats.org/drawingml/2006/main" prst="rect">
-            <a:avLst/>
-          </a:prstGeom>
-          <a:noFill xmlns:a="http://schemas.openxmlformats.org/drawingml/2006/main"/>
-          <a:ln xmlns:a="http://schemas.openxmlformats.org/drawingml/2006/main" w="0">
-            <a:noFill/>
-            <a:prstDash val="solid"/>
-          </a:ln>
-        </p:spPr>
-        <p:txBody>
-          <a:bodyPr xmlns:a="http://schemas.openxmlformats.org/drawingml/2006/main"/>
-          <a:lstStyle xmlns:a="http://schemas.openxmlformats.org/drawingml/2006/main"/>
-          <a:p xmlns:a="http://schemas.openxmlformats.org/drawingml/2006/main">
-            <a:pPr algn="l">
-              <a:defRPr sz="3300" b="1">
-                <a:solidFill>
-                  <a:srgbClr val="456990"/>
-                </a:solidFill>
-              </a:defRPr>
-            </a:pPr>
-            <a:r>
-              <a:rPr sz="3300" b="1">
-                <a:solidFill>
-                  <a:srgbClr val="456990"/>
-                </a:solidFill>
-              </a:rPr>
-              <a:t>3</a:t>
-            </a:r>
-          </a:p>
-        </p:txBody>
-      </p:sp>
-      <p:sp>
-        <p:nvSpPr>
-          <p:cNvPr id="12" name="">
-            <a:extLst xmlns:a="http://schemas.openxmlformats.org/drawingml/2006/main">
-              <a:ext uri="{FF2B5EF4-FFF2-40B4-BE49-F238E27FC236}">
-                <a16:creationId xmlns:a16="http://schemas.microsoft.com/office/drawing/2014/main" id="{736F546C-F254-45A0-B157-128AC5531A75}"/>
-              </a:ext>
-            </a:extLst>
-          </p:cNvPr>
-          <p:cNvSpPr>
-            <a:spLocks xmlns:a="http://schemas.openxmlformats.org/drawingml/2006/main" noGrp="1"/>
-          </p:cNvSpPr>
-          <p:nvPr/>
-        </p:nvSpPr>
-        <p:spPr>
-          <a:xfrm xmlns:a="http://schemas.openxmlformats.org/drawingml/2006/main">
-            <a:off x="1790700" y="3524250"/>
-            <a:ext cx="3143250" cy="552450"/>
-          </a:xfrm>
-          <a:prstGeom xmlns:a="http://schemas.openxmlformats.org/drawingml/2006/main" prst="rect">
-            <a:avLst/>
-          </a:prstGeom>
-          <a:noFill xmlns:a="http://schemas.openxmlformats.org/drawingml/2006/main"/>
-          <a:ln xmlns:a="http://schemas.openxmlformats.org/drawingml/2006/main" w="0">
-            <a:noFill/>
-            <a:prstDash val="solid"/>
-          </a:ln>
-        </p:spPr>
-        <p:txBody>
-          <a:bodyPr xmlns:a="http://schemas.openxmlformats.org/drawingml/2006/main"/>
-          <a:lstStyle xmlns:a="http://schemas.openxmlformats.org/drawingml/2006/main"/>
-          <a:p xmlns:a="http://schemas.openxmlformats.org/drawingml/2006/main">
-            <a:pPr algn="l">
-              <a:defRPr sz="1725" b="1">
-                <a:solidFill>
-                  <a:srgbClr val="1C2430"/>
-                </a:solidFill>
-              </a:defRPr>
-            </a:pPr>
-            <a:r>
-              <a:rPr sz="1725" b="1">
-                <a:solidFill>
-                  <a:srgbClr val="1C2430"/>
-                </a:solidFill>
-              </a:rPr>
-              <a:t>Run Stata/R replication</a:t>
-            </a:r>
-          </a:p>
-        </p:txBody>
-      </p:sp>
-      <p:sp>
-        <p:nvSpPr>
-          <p:cNvPr id="13" name="">
-            <a:extLst xmlns:a="http://schemas.openxmlformats.org/drawingml/2006/main">
-              <a:ext uri="{FF2B5EF4-FFF2-40B4-BE49-F238E27FC236}">
-                <a16:creationId xmlns:a16="http://schemas.microsoft.com/office/drawing/2014/main" id="{6DF06738-B9F6-4922-B68D-BB2DAAB74768}"/>
-              </a:ext>
-            </a:extLst>
-          </p:cNvPr>
-          <p:cNvSpPr>
-            <a:spLocks xmlns:a="http://schemas.openxmlformats.org/drawingml/2006/main" noGrp="1"/>
-          </p:cNvSpPr>
-          <p:nvPr/>
-        </p:nvSpPr>
-        <p:spPr>
-          <a:xfrm xmlns:a="http://schemas.openxmlformats.org/drawingml/2006/main">
-            <a:off x="1790700" y="4057650"/>
-            <a:ext cx="3143250" cy="400050"/>
-          </a:xfrm>
-          <a:prstGeom xmlns:a="http://schemas.openxmlformats.org/drawingml/2006/main" prst="rect">
-            <a:avLst/>
-          </a:prstGeom>
-          <a:noFill xmlns:a="http://schemas.openxmlformats.org/drawingml/2006/main"/>
-          <a:ln xmlns:a="http://schemas.openxmlformats.org/drawingml/2006/main" w="0">
-            <a:noFill/>
-            <a:prstDash val="solid"/>
-          </a:ln>
-        </p:spPr>
-        <p:txBody>
-          <a:bodyPr xmlns:a="http://schemas.openxmlformats.org/drawingml/2006/main"/>
-          <a:lstStyle xmlns:a="http://schemas.openxmlformats.org/drawingml/2006/main"/>
-          <a:p xmlns:a="http://schemas.openxmlformats.org/drawingml/2006/main">
-            <a:pPr algn="l">
-              <a:defRPr sz="1200" b="0">
-                <a:solidFill>
-                  <a:srgbClr val="5B6472"/>
-                </a:solidFill>
-              </a:defRPr>
-            </a:pPr>
-            <a:r>
-              <a:rPr sz="1200" b="0">
-                <a:solidFill>
-                  <a:srgbClr val="5B6472"/>
-                </a:solidFill>
-              </a:rPr>
-              <a:t>Use the included .do file and workbook model sheets.</a:t>
-            </a:r>
-          </a:p>
-        </p:txBody>
-      </p:sp>
-      <p:sp>
-        <p:nvSpPr>
-          <p:cNvPr id="14" name="">
-            <a:extLst xmlns:a="http://schemas.openxmlformats.org/drawingml/2006/main">
-              <a:ext uri="{FF2B5EF4-FFF2-40B4-BE49-F238E27FC236}">
-                <a16:creationId xmlns:a16="http://schemas.microsoft.com/office/drawing/2014/main" id="{AE10744D-B730-43BA-B314-8A1C23D02726}"/>
-              </a:ext>
-            </a:extLst>
-          </p:cNvPr>
-          <p:cNvSpPr>
-            <a:spLocks xmlns:a="http://schemas.openxmlformats.org/drawingml/2006/main" noGrp="1"/>
-          </p:cNvSpPr>
-          <p:nvPr/>
-        </p:nvSpPr>
-        <p:spPr>
-          <a:xfrm xmlns:a="http://schemas.openxmlformats.org/drawingml/2006/main">
-            <a:off x="6000750" y="3314700"/>
-            <a:ext cx="4476750" cy="1257300"/>
-          </a:xfrm>
-          <a:prstGeom xmlns:a="http://schemas.openxmlformats.org/drawingml/2006/main" prst="rect">
-            <a:avLst/>
-          </a:prstGeom>
-          <a:solidFill xmlns:a="http://schemas.openxmlformats.org/drawingml/2006/main">
-            <a:srgbClr val="FFFFFF"/>
-          </a:solidFill>
-          <a:ln xmlns:a="http://schemas.openxmlformats.org/drawingml/2006/main" w="9525">
-            <a:solidFill>
-              <a:srgbClr val="1C2430"/>
-            </a:solidFill>
-            <a:prstDash val="solid"/>
-          </a:ln>
-        </p:spPr>
-      </p:sp>
-      <p:sp>
-        <p:nvSpPr>
-          <p:cNvPr id="15" name="">
-            <a:extLst xmlns:a="http://schemas.openxmlformats.org/drawingml/2006/main">
-              <a:ext uri="{FF2B5EF4-FFF2-40B4-BE49-F238E27FC236}">
-                <a16:creationId xmlns:a16="http://schemas.microsoft.com/office/drawing/2014/main" id="{28B7648A-66FF-4764-AD4F-B6DAADA84E6E}"/>
-              </a:ext>
-            </a:extLst>
-          </p:cNvPr>
-          <p:cNvSpPr>
-            <a:spLocks xmlns:a="http://schemas.openxmlformats.org/drawingml/2006/main" noGrp="1"/>
-          </p:cNvSpPr>
-          <p:nvPr/>
-        </p:nvSpPr>
-        <p:spPr>
-          <a:xfrm xmlns:a="http://schemas.openxmlformats.org/drawingml/2006/main">
-            <a:off x="6229350" y="3562350"/>
-            <a:ext cx="552450" cy="495300"/>
-          </a:xfrm>
-          <a:prstGeom xmlns:a="http://schemas.openxmlformats.org/drawingml/2006/main" prst="rect">
-            <a:avLst/>
-          </a:prstGeom>
-          <a:noFill xmlns:a="http://schemas.openxmlformats.org/drawingml/2006/main"/>
-          <a:ln xmlns:a="http://schemas.openxmlformats.org/drawingml/2006/main" w="0">
-            <a:noFill/>
-            <a:prstDash val="solid"/>
-          </a:ln>
-        </p:spPr>
-        <p:txBody>
-          <a:bodyPr xmlns:a="http://schemas.openxmlformats.org/drawingml/2006/main"/>
-          <a:lstStyle xmlns:a="http://schemas.openxmlformats.org/drawingml/2006/main"/>
-          <a:p xmlns:a="http://schemas.openxmlformats.org/drawingml/2006/main">
-            <a:pPr algn="l">
-              <a:defRPr sz="3300" b="1">
-                <a:solidFill>
-                  <a:srgbClr val="B23A48"/>
-                </a:solidFill>
-              </a:defRPr>
-            </a:pPr>
-            <a:r>
-              <a:rPr sz="3300" b="1">
-                <a:solidFill>
-                  <a:srgbClr val="B23A48"/>
-                </a:solidFill>
-              </a:rPr>
-              <a:t>4</a:t>
-            </a:r>
-          </a:p>
-        </p:txBody>
-      </p:sp>
-      <p:sp>
-        <p:nvSpPr>
-          <p:cNvPr id="16" name="">
-            <a:extLst xmlns:a="http://schemas.openxmlformats.org/drawingml/2006/main">
-              <a:ext uri="{FF2B5EF4-FFF2-40B4-BE49-F238E27FC236}">
-                <a16:creationId xmlns:a16="http://schemas.microsoft.com/office/drawing/2014/main" id="{CF00019D-6B38-4C0C-ABCC-D5AF2480659F}"/>
-              </a:ext>
-            </a:extLst>
-          </p:cNvPr>
-          <p:cNvSpPr>
-            <a:spLocks xmlns:a="http://schemas.openxmlformats.org/drawingml/2006/main" noGrp="1"/>
-          </p:cNvSpPr>
-          <p:nvPr/>
-        </p:nvSpPr>
-        <p:spPr>
-          <a:xfrm xmlns:a="http://schemas.openxmlformats.org/drawingml/2006/main">
-            <a:off x="6934200" y="3524250"/>
-            <a:ext cx="3143250" cy="552450"/>
-          </a:xfrm>
-          <a:prstGeom xmlns:a="http://schemas.openxmlformats.org/drawingml/2006/main" prst="rect">
-            <a:avLst/>
-          </a:prstGeom>
-          <a:noFill xmlns:a="http://schemas.openxmlformats.org/drawingml/2006/main"/>
-          <a:ln xmlns:a="http://schemas.openxmlformats.org/drawingml/2006/main" w="0">
-            <a:noFill/>
-            <a:prstDash val="solid"/>
-          </a:ln>
-        </p:spPr>
-        <p:txBody>
-          <a:bodyPr xmlns:a="http://schemas.openxmlformats.org/drawingml/2006/main"/>
-          <a:lstStyle xmlns:a="http://schemas.openxmlformats.org/drawingml/2006/main"/>
-          <a:p xmlns:a="http://schemas.openxmlformats.org/drawingml/2006/main">
-            <a:pPr algn="l">
-              <a:defRPr sz="1725" b="1">
-                <a:solidFill>
-                  <a:srgbClr val="1C2430"/>
-                </a:solidFill>
-              </a:defRPr>
-            </a:pPr>
-            <a:r>
-              <a:rPr sz="1725" b="1">
-                <a:solidFill>
-                  <a:srgbClr val="1C2430"/>
-                </a:solidFill>
-              </a:rPr>
-              <a:t>Revise claims</a:t>
-            </a:r>
-          </a:p>
-        </p:txBody>
-      </p:sp>
-      <p:sp>
-        <p:nvSpPr>
-          <p:cNvPr id="17" name="">
-            <a:extLst xmlns:a="http://schemas.openxmlformats.org/drawingml/2006/main">
-              <a:ext uri="{FF2B5EF4-FFF2-40B4-BE49-F238E27FC236}">
-                <a16:creationId xmlns:a16="http://schemas.microsoft.com/office/drawing/2014/main" id="{CBA5D023-7F28-4398-BFED-96E413D1C862}"/>
-              </a:ext>
-            </a:extLst>
-          </p:cNvPr>
-          <p:cNvSpPr>
-            <a:spLocks xmlns:a="http://schemas.openxmlformats.org/drawingml/2006/main" noGrp="1"/>
-          </p:cNvSpPr>
-          <p:nvPr/>
-        </p:nvSpPr>
-        <p:spPr>
-          <a:xfrm xmlns:a="http://schemas.openxmlformats.org/drawingml/2006/main">
-            <a:off x="6934200" y="4057650"/>
-            <a:ext cx="3143250" cy="400050"/>
-          </a:xfrm>
-          <a:prstGeom xmlns:a="http://schemas.openxmlformats.org/drawingml/2006/main" prst="rect">
-            <a:avLst/>
-          </a:prstGeom>
-          <a:noFill xmlns:a="http://schemas.openxmlformats.org/drawingml/2006/main"/>
-          <a:ln xmlns:a="http://schemas.openxmlformats.org/drawingml/2006/main" w="0">
-            <a:noFill/>
-            <a:prstDash val="solid"/>
-          </a:ln>
-        </p:spPr>
-        <p:txBody>
-          <a:bodyPr xmlns:a="http://schemas.openxmlformats.org/drawingml/2006/main"/>
-          <a:lstStyle xmlns:a="http://schemas.openxmlformats.org/drawingml/2006/main"/>
-          <a:p xmlns:a="http://schemas.openxmlformats.org/drawingml/2006/main">
-            <a:pPr algn="l">
-              <a:defRPr sz="1200" b="0">
-                <a:solidFill>
-                  <a:srgbClr val="5B6472"/>
-                </a:solidFill>
-              </a:defRPr>
-            </a:pPr>
-            <a:r>
-              <a:rPr sz="1200" b="0">
-                <a:solidFill>
-                  <a:srgbClr val="5B6472"/>
-                </a:solidFill>
-              </a:rPr>
-              <a:t>Replace demonstration language with empirical findings only after real data.</a:t>
-            </a:r>
-          </a:p>
-        </p:txBody>
-      </p:sp>
-      <p:sp>
-        <p:nvSpPr>
-          <p:cNvPr id="18" name="">
-            <a:extLst xmlns:a="http://schemas.openxmlformats.org/drawingml/2006/main">
-              <a:ext uri="{FF2B5EF4-FFF2-40B4-BE49-F238E27FC236}">
-                <a16:creationId xmlns:a16="http://schemas.microsoft.com/office/drawing/2014/main" id="{A605A30F-66A2-40DA-B2BE-82382842664E}"/>
-              </a:ext>
-            </a:extLst>
-          </p:cNvPr>
-          <p:cNvSpPr>
-            <a:spLocks xmlns:a="http://schemas.openxmlformats.org/drawingml/2006/main" noGrp="1"/>
-          </p:cNvSpPr>
-          <p:nvPr/>
-        </p:nvSpPr>
-        <p:spPr>
-          <a:xfrm xmlns:a="http://schemas.openxmlformats.org/drawingml/2006/main">
-            <a:off x="1047750" y="5619750"/>
-            <a:ext cx="9334500" cy="361950"/>
-          </a:xfrm>
-          <a:prstGeom xmlns:a="http://schemas.openxmlformats.org/drawingml/2006/main" prst="rect">
-            <a:avLst/>
-          </a:prstGeom>
-          <a:noFill xmlns:a="http://schemas.openxmlformats.org/drawingml/2006/main"/>
-          <a:ln xmlns:a="http://schemas.openxmlformats.org/drawingml/2006/main" w="0">
-            <a:noFill/>
-            <a:prstDash val="solid"/>
-          </a:ln>
-        </p:spPr>
-        <p:txBody>
-          <a:bodyPr xmlns:a="http://schemas.openxmlformats.org/drawingml/2006/main"/>
-          <a:lstStyle xmlns:a="http://schemas.openxmlformats.org/drawingml/2006/main"/>
-          <a:p xmlns:a="http://schemas.openxmlformats.org/drawingml/2006/main">
-            <a:pPr algn="ctr">
-              <a:defRPr sz="1725" b="1">
-                <a:solidFill>
-                  <a:srgbClr val="1C2430"/>
-                </a:solidFill>
-              </a:defRPr>
-            </a:pPr>
-            <a:r>
-              <a:rPr sz="1725" b="1">
-                <a:solidFill>
-                  <a:srgbClr val="1C2430"/>
-                </a:solidFill>
-              </a:rPr>
-              <a:t>Final output: a usable research website, data workbook, paper-style PDF, presentation deck, and narrated video asset.</a:t>
-            </a:r>
-          </a:p>
-        </p:txBody>
-      </p:sp>
-      <p:sp>
-        <p:nvSpPr>
-          <p:cNvPr id="19" name="">
-            <a:extLst xmlns:a="http://schemas.openxmlformats.org/drawingml/2006/main">
-              <a:ext uri="{FF2B5EF4-FFF2-40B4-BE49-F238E27FC236}">
-                <a16:creationId xmlns:a16="http://schemas.microsoft.com/office/drawing/2014/main" id="{7C0F46F5-DBB9-4347-A45C-072F1132D181}"/>
+              <a:t>The temporary tunnel is ready for classmate collection now. Render should be used for a stable long-running study link.</a:t>
+            </a:r>
+          </a:p>
+        </p:txBody>
+      </p:sp>
+      <p:sp>
+        <p:nvSpPr>
+          <p:cNvPr id="23" name="">
+            <a:extLst xmlns:a="http://schemas.openxmlformats.org/drawingml/2006/main">
+              <a:ext uri="{FF2B5EF4-FFF2-40B4-BE49-F238E27FC236}">
+                <a16:creationId xmlns:a16="http://schemas.microsoft.com/office/drawing/2014/main" id="{74A8ADD8-6F79-4187-8B10-EA19769B405F}"/>
               </a:ext>
             </a:extLst>
           </p:cNvPr>
@@ -9219,10 +10481,10 @@
       </p:sp>
       <p:sp>
         <p:nvSpPr>
-          <p:cNvPr id="20" name="">
-            <a:extLst xmlns:a="http://schemas.openxmlformats.org/drawingml/2006/main">
-              <a:ext uri="{FF2B5EF4-FFF2-40B4-BE49-F238E27FC236}">
-                <a16:creationId xmlns:a16="http://schemas.microsoft.com/office/drawing/2014/main" id="{A91EF8E1-DE82-42DA-84FC-E72E2BAA7E66}"/>
+          <p:cNvPr id="24" name="">
+            <a:extLst xmlns:a="http://schemas.openxmlformats.org/drawingml/2006/main">
+              <a:ext uri="{FF2B5EF4-FFF2-40B4-BE49-F238E27FC236}">
+                <a16:creationId xmlns:a16="http://schemas.microsoft.com/office/drawing/2014/main" id="{70EA4768-C54F-424D-B30C-B4700E6B60DB}"/>
               </a:ext>
             </a:extLst>
           </p:cNvPr>
@@ -9270,7 +10532,7 @@
     </p:spTree>
     <p:extLst>
       <p:ext uri="{BB962C8B-B14F-4D97-AF65-F5344CB8AC3E}">
-        <p14:creationId xmlns:p14="http://schemas.microsoft.com/office/powerpoint/2010/main" val="2040210472"/>
+        <p14:creationId xmlns:p14="http://schemas.microsoft.com/office/powerpoint/2010/main" val="1229367052"/>
       </p:ext>
     </p:extLst>
   </p:cSld>

</xml_diff>